<commit_message>
更新 UFS5.0 分析 slide 为 PCIe 5.0 vs PCIe 6.0 对比方案
- Load/Prefill/Decode 全部切换为 PCIe 5.0 x4 (15.75 GB/s) vs PCIe 6.0 x4 (32 GB/s)
- Decode 表格更新：PCIe6 在 ~37% 命中率时即进入 GPU-bnd，PCIe5 在 ~67%
- Performance Summary 更新为 5 列对比（场景/PCIe5/PCIe6/提升/瓶颈）
- GPU 天花板：10.5 GB / 273 GB/s = 38.5 ms = 26.0 tok/s

Co-Authored-By: Claude Sonnet 4.6 <noreply@anthropic.com>
</commit_message>
<xml_diff>
--- a/ds4_gb10/docs/ufs5_analysis_slide.pptx
+++ b/ds4_gb10/docs/ufs5_analysis_slide.pptx
@@ -953,7 +953,7 @@
               <c:strCache>
                 <c:ptCount val="1"/>
                 <c:pt idx="0">
-                  <c:v>UFS 5.0</c:v>
+                  <c:v>PCIe 5.0</c:v>
                 </c:pt>
               </c:strCache>
             </c:strRef>
@@ -1024,22 +1024,22 @@
                 <c:formatCode>General</c:formatCode>
                 <c:ptCount val="6"/>
                 <c:pt idx="0">
-                  <c:v>5.5</c:v>
+                  <c:v>9.1</c:v>
                 </c:pt>
                 <c:pt idx="1">
-                  <c:v>7.8</c:v>
+                  <c:v>12.9</c:v>
                 </c:pt>
                 <c:pt idx="2">
-                  <c:v>11</c:v>
+                  <c:v>18.1</c:v>
                 </c:pt>
                 <c:pt idx="3">
-                  <c:v>18.3</c:v>
+                  <c:v>27.3</c:v>
                 </c:pt>
                 <c:pt idx="4">
-                  <c:v>36.5</c:v>
+                  <c:v>26.7</c:v>
                 </c:pt>
                 <c:pt idx="5">
-                  <c:v>51.6</c:v>
+                  <c:v>26</c:v>
                 </c:pt>
               </c:numCache>
             </c:numRef>
@@ -1054,7 +1054,7 @@
               <c:strCache>
                 <c:ptCount val="1"/>
                 <c:pt idx="0">
-                  <c:v>NVMe 7</c:v>
+                  <c:v>PCIe 6.0</c:v>
                 </c:pt>
               </c:strCache>
             </c:strRef>
@@ -1125,22 +1125,22 @@
                 <c:formatCode>General</c:formatCode>
                 <c:ptCount val="6"/>
                 <c:pt idx="0">
-                  <c:v>3.8</c:v>
+                  <c:v>18.4</c:v>
                 </c:pt>
                 <c:pt idx="1">
-                  <c:v>5.5</c:v>
+                  <c:v>26.2</c:v>
                 </c:pt>
                 <c:pt idx="2">
-                  <c:v>7.7</c:v>
+                  <c:v>28.3</c:v>
                 </c:pt>
                 <c:pt idx="3">
-                  <c:v>12.8</c:v>
+                  <c:v>27.3</c:v>
                 </c:pt>
                 <c:pt idx="4">
-                  <c:v>25.6</c:v>
+                  <c:v>26.7</c:v>
                 </c:pt>
                 <c:pt idx="5">
-                  <c:v>51.6</c:v>
+                  <c:v>26</c:v>
                 </c:pt>
               </c:numCache>
             </c:numRef>
@@ -1226,22 +1226,22 @@
                 <c:formatCode>General</c:formatCode>
                 <c:ptCount val="6"/>
                 <c:pt idx="0">
-                  <c:v>51.6</c:v>
+                  <c:v>26</c:v>
                 </c:pt>
                 <c:pt idx="1">
-                  <c:v>51.6</c:v>
+                  <c:v>26</c:v>
                 </c:pt>
                 <c:pt idx="2">
-                  <c:v>51.6</c:v>
+                  <c:v>26</c:v>
                 </c:pt>
                 <c:pt idx="3">
-                  <c:v>51.6</c:v>
+                  <c:v>26</c:v>
                 </c:pt>
                 <c:pt idx="4">
-                  <c:v>51.6</c:v>
+                  <c:v>26</c:v>
                 </c:pt>
                 <c:pt idx="5">
-                  <c:v>51.6</c:v>
+                  <c:v>26</c:v>
                 </c:pt>
               </c:numCache>
             </c:numRef>
@@ -1322,7 +1322,7 @@
         <c:axId val="2094734552"/>
         <c:scaling>
           <c:orientation val="minMax"/>
-          <c:max val="55"/>
+          <c:max val="32"/>
           <c:min val="0"/>
         </c:scaling>
         <c:delete val="0"/>
@@ -2236,7 +2236,7 @@
                 <a:ea typeface="Calibri" pitchFamily="34" charset="-122"/>
                 <a:cs typeface="Calibri" pitchFamily="34" charset="-120"/>
               </a:rPr>
-              <a:t>DeepSeek V4-Flash: UFS 5.0 Expert Offload I/O Analysis — New Platform (546 GB/s / 240 TOPS) vs DGX (273 GB/s / 123 TOPS)</a:t>
+              <a:t>DeepSeek V4-Flash: PCIe 5.0 vs PCIe 6.0 NVMe Expert Offload I/O Analysis — GB10 (273 GB/s GPU BW / 123 TOPS FP16)</a:t>
             </a:r>
             <a:endParaRPr lang="en-US" sz="1600" dirty="0"/>
           </a:p>
@@ -2300,7 +2300,7 @@
                 <a:ea typeface="Calibri" pitchFamily="34" charset="-122"/>
                 <a:cs typeface="Calibri" pitchFamily="34" charset="-120"/>
               </a:rPr>
-              <a:t>New Platform (546 GB/s / 240 TOPS): </a:t>
+              <a:t>PCIe 6.0 x4 (32 GB/s) vs PCIe 5.0 x4 (15.75 GB/s): </a:t>
             </a:r>
             <a:pPr algn="l" indent="0" marL="0">
               <a:buNone/>
@@ -2314,7 +2314,35 @@
                 <a:ea typeface="Calibri" pitchFamily="34" charset="-122"/>
                 <a:cs typeface="Calibri" pitchFamily="34" charset="-120"/>
               </a:rPr>
-              <a:t>UFS 5.0 crosses IO→Compute at </a:t>
+              <a:t>2.03× load speedup; </a:t>
+            </a:r>
+            <a:pPr algn="l" indent="0" marL="0">
+              <a:buNone/>
+            </a:pPr>
+            <a:r>
+              <a:rPr lang="en-US" sz="1050" b="1" dirty="0">
+                <a:solidFill>
+                  <a:srgbClr val="1A7A3C"/>
+                </a:solidFill>
+                <a:latin typeface="Calibri" pitchFamily="34" charset="0"/>
+                <a:ea typeface="Calibri" pitchFamily="34" charset="-122"/>
+                <a:cs typeface="Calibri" pitchFamily="34" charset="-120"/>
+              </a:rPr>
+              <a:t>2× cold decode (18.4 vs 9.1 tok/s)</a:t>
+            </a:r>
+            <a:pPr algn="l" indent="0" marL="0">
+              <a:buNone/>
+            </a:pPr>
+            <a:r>
+              <a:rPr lang="en-US" sz="1050" dirty="0">
+                <a:solidFill>
+                  <a:srgbClr val="1B2A4A"/>
+                </a:solidFill>
+                <a:latin typeface="Calibri" pitchFamily="34" charset="0"/>
+                <a:ea typeface="Calibri" pitchFamily="34" charset="-122"/>
+                <a:cs typeface="Calibri" pitchFamily="34" charset="-120"/>
+              </a:rPr>
+              <a:t>. Decode transitions to GPU-memory-bound at </a:t>
             </a:r>
             <a:pPr algn="l" indent="0" marL="0">
               <a:buNone/>
@@ -2328,7 +2356,7 @@
                 <a:ea typeface="Calibri" pitchFamily="34" charset="-122"/>
                 <a:cs typeface="Calibri" pitchFamily="34" charset="-120"/>
               </a:rPr>
-              <a:t>C = 1,800 tok</a:t>
+              <a:t>~37% hit (PCIe 6)</a:t>
             </a:r>
             <a:pPr algn="l" indent="0" marL="0">
               <a:buNone/>
@@ -2342,7 +2370,7 @@
                 <a:ea typeface="Calibri" pitchFamily="34" charset="-122"/>
                 <a:cs typeface="Calibri" pitchFamily="34" charset="-120"/>
               </a:rPr>
-              <a:t> — at standard 2K chunk, </a:t>
+              <a:t> vs </a:t>
             </a:r>
             <a:pPr algn="l" indent="0" marL="0">
               <a:buNone/>
@@ -2356,7 +2384,7 @@
                 <a:ea typeface="Calibri" pitchFamily="34" charset="-122"/>
                 <a:cs typeface="Calibri" pitchFamily="34" charset="-120"/>
               </a:rPr>
-              <a:t>NVMe 7 (7,851) edges UFS 5.0 (7,700 tok/s)</a:t>
+              <a:t>~67% hit (PCIe 5)</a:t>
             </a:r>
             <a:pPr algn="l" indent="0" marL="0">
               <a:buNone/>
@@ -2370,7 +2398,7 @@
                 <a:ea typeface="Calibri" pitchFamily="34" charset="-122"/>
                 <a:cs typeface="Calibri" pitchFamily="34" charset="-120"/>
               </a:rPr>
-              <a:t> because compute becomes the UFS5 bottleneck. Decode GPU ceiling </a:t>
+              <a:t> — both converge to </a:t>
             </a:r>
             <a:pPr algn="l" indent="0" marL="0">
               <a:buNone/>
@@ -2384,7 +2412,7 @@
                 <a:ea typeface="Calibri" pitchFamily="34" charset="-122"/>
                 <a:cs typeface="Calibri" pitchFamily="34" charset="-120"/>
               </a:rPr>
-              <a:t>doubles to 51.6 tok/s</a:t>
+              <a:t>26 tok/s GPU ceiling</a:t>
             </a:r>
             <a:pPr algn="l" indent="0" marL="0">
               <a:buNone/>
@@ -2398,7 +2426,7 @@
                 <a:ea typeface="Calibri" pitchFamily="34" charset="-122"/>
                 <a:cs typeface="Calibri" pitchFamily="34" charset="-120"/>
               </a:rPr>
-              <a:t> vs DGX ref 25.8 tok/s (273 GB/s). DGX (123 TOPS): compute-bound already at C=922.</a:t>
+              <a:t>. Prefill C ≥ 1,024: compute-bound for both; storage upgrade provides no prefill benefit.</a:t>
             </a:r>
             <a:endParaRPr lang="en-US" sz="1050" dirty="0"/>
           </a:p>
@@ -6085,7 +6113,7 @@
                 <a:ea typeface="Calibri" pitchFamily="34" charset="-122"/>
                 <a:cs typeface="Calibri" pitchFamily="34" charset="-120"/>
               </a:rPr>
-              <a:t>258 × 7.08 MB = 1.826 GB</a:t>
+              <a:t>258(6×43) × 6.75 MB = 1.74 GB</a:t>
             </a:r>
             <a:endParaRPr lang="en-US" sz="800" dirty="0"/>
           </a:p>
@@ -6116,7 +6144,7 @@
                 <a:ea typeface="Calibri" pitchFamily="34" charset="-122"/>
                 <a:cs typeface="Calibri" pitchFamily="34" charset="-120"/>
               </a:rPr>
-              <a:t>8.76/546 = 16.0 ms</a:t>
+              <a:t>8.76 GB / 273 GB/s = 32.1 ms</a:t>
             </a:r>
             <a:pPr algn="l" indent="0" marL="0">
               <a:buNone/>
@@ -6130,21 +6158,7 @@
                 <a:ea typeface="Calibri" pitchFamily="34" charset="-122"/>
                 <a:cs typeface="Calibri" pitchFamily="34" charset="-120"/>
               </a:rPr>
-              <a:t>  [DGX: /273 = 32.1 ms]  </a:t>
-            </a:r>
-            <a:pPr algn="l" indent="0" marL="0">
-              <a:buNone/>
-            </a:pPr>
-            <a:r>
-              <a:rPr lang="en-US" sz="800" i="1" dirty="0">
-                <a:solidFill>
-                  <a:srgbClr val="999999"/>
-                </a:solidFill>
-                <a:latin typeface="Calibri" pitchFamily="34" charset="0"/>
-                <a:ea typeface="Calibri" pitchFamily="34" charset="-122"/>
-                <a:cs typeface="Calibri" pitchFamily="34" charset="-120"/>
-              </a:rPr>
-              <a:t>(always overlapped)</a:t>
+              <a:t>  (always overlapped)</a:t>
             </a:r>
             <a:endParaRPr lang="en-US" sz="800" dirty="0"/>
           </a:p>
@@ -6334,7 +6348,7 @@
                           <a:ea typeface="Calibri" pitchFamily="34" charset="-122"/>
                           <a:cs typeface="Calibri" pitchFamily="34" charset="-120"/>
                         </a:rPr>
-                        <a:t>UFS5 ms</a:t>
+                        <a:t>PCIe5 ms</a:t>
                       </a:r>
                       <a:endParaRPr lang="en-US" sz="800" dirty="0">
                         <a:latin typeface="Calibri" charset="0"/>
@@ -6402,7 +6416,7 @@
                           <a:ea typeface="Calibri" pitchFamily="34" charset="-122"/>
                           <a:cs typeface="Calibri" pitchFamily="34" charset="-120"/>
                         </a:rPr>
-                        <a:t>UFS5 TPS</a:t>
+                        <a:t>PCIe5 TPS</a:t>
                       </a:r>
                       <a:endParaRPr lang="en-US" sz="800" dirty="0">
                         <a:latin typeface="Calibri" charset="0"/>
@@ -6470,7 +6484,7 @@
                           <a:ea typeface="Calibri" pitchFamily="34" charset="-122"/>
                           <a:cs typeface="Calibri" pitchFamily="34" charset="-120"/>
                         </a:rPr>
-                        <a:t>NVMe ms</a:t>
+                        <a:t>PCIe6 ms</a:t>
                       </a:r>
                       <a:endParaRPr lang="en-US" sz="800" dirty="0">
                         <a:latin typeface="Calibri" charset="0"/>
@@ -6538,7 +6552,7 @@
                           <a:ea typeface="Calibri" pitchFamily="34" charset="-122"/>
                           <a:cs typeface="Calibri" pitchFamily="34" charset="-120"/>
                         </a:rPr>
-                        <a:t>NVMe TPS</a:t>
+                        <a:t>PCIe6 TPS</a:t>
                       </a:r>
                       <a:endParaRPr lang="en-US" sz="800" dirty="0">
                         <a:latin typeface="Calibri" charset="0"/>
@@ -6676,7 +6690,7 @@
                           <a:ea typeface="Calibri" pitchFamily="34" charset="-122"/>
                           <a:cs typeface="Calibri" pitchFamily="34" charset="-120"/>
                         </a:rPr>
-                        <a:t>1.826</a:t>
+                        <a:t>1.74</a:t>
                       </a:r>
                       <a:endParaRPr lang="en-US" sz="800" dirty="0">
                         <a:latin typeface="Calibri" charset="0"/>
@@ -6744,7 +6758,7 @@
                           <a:ea typeface="Calibri" pitchFamily="34" charset="-122"/>
                           <a:cs typeface="Calibri" pitchFamily="34" charset="-120"/>
                         </a:rPr>
-                        <a:t>182.6</a:t>
+                        <a:t>110.5</a:t>
                       </a:r>
                       <a:endParaRPr lang="en-US" sz="800" dirty="0">
                         <a:latin typeface="Calibri" charset="0"/>
@@ -6812,7 +6826,7 @@
                           <a:ea typeface="Calibri" pitchFamily="34" charset="-122"/>
                           <a:cs typeface="Calibri" pitchFamily="34" charset="-120"/>
                         </a:rPr>
-                        <a:t>5.5</a:t>
+                        <a:t>9.1</a:t>
                       </a:r>
                       <a:endParaRPr lang="en-US" sz="800" dirty="0">
                         <a:latin typeface="Calibri" charset="0"/>
@@ -6880,7 +6894,7 @@
                           <a:ea typeface="Calibri" pitchFamily="34" charset="-122"/>
                           <a:cs typeface="Calibri" pitchFamily="34" charset="-120"/>
                         </a:rPr>
-                        <a:t>260.9</a:t>
+                        <a:t> 54.4</a:t>
                       </a:r>
                       <a:endParaRPr lang="en-US" sz="800" dirty="0">
                         <a:latin typeface="Calibri" charset="0"/>
@@ -6948,7 +6962,7 @@
                           <a:ea typeface="Calibri" pitchFamily="34" charset="-122"/>
                           <a:cs typeface="Calibri" pitchFamily="34" charset="-120"/>
                         </a:rPr>
-                        <a:t>3.8</a:t>
+                        <a:t>18.4</a:t>
                       </a:r>
                       <a:endParaRPr lang="en-US" sz="800" dirty="0">
                         <a:latin typeface="Calibri" charset="0"/>
@@ -7086,7 +7100,7 @@
                           <a:ea typeface="Calibri" pitchFamily="34" charset="-122"/>
                           <a:cs typeface="Calibri" pitchFamily="34" charset="-120"/>
                         </a:rPr>
-                        <a:t>1.278</a:t>
+                        <a:t>1.22</a:t>
                       </a:r>
                       <a:endParaRPr lang="en-US" sz="800" dirty="0">
                         <a:latin typeface="Calibri" charset="0"/>
@@ -7154,7 +7168,7 @@
                           <a:ea typeface="Calibri" pitchFamily="34" charset="-122"/>
                           <a:cs typeface="Calibri" pitchFamily="34" charset="-120"/>
                         </a:rPr>
-                        <a:t>127.8</a:t>
+                        <a:t> 77.4</a:t>
                       </a:r>
                       <a:endParaRPr lang="en-US" sz="800" dirty="0">
                         <a:latin typeface="Calibri" charset="0"/>
@@ -7222,7 +7236,7 @@
                           <a:ea typeface="Calibri" pitchFamily="34" charset="-122"/>
                           <a:cs typeface="Calibri" pitchFamily="34" charset="-120"/>
                         </a:rPr>
-                        <a:t>7.8</a:t>
+                        <a:t>12.9</a:t>
                       </a:r>
                       <a:endParaRPr lang="en-US" sz="800" dirty="0">
                         <a:latin typeface="Calibri" charset="0"/>
@@ -7290,7 +7304,7 @@
                           <a:ea typeface="Calibri" pitchFamily="34" charset="-122"/>
                           <a:cs typeface="Calibri" pitchFamily="34" charset="-120"/>
                         </a:rPr>
-                        <a:t>182.6</a:t>
+                        <a:t> 38.1</a:t>
                       </a:r>
                       <a:endParaRPr lang="en-US" sz="800" dirty="0">
                         <a:latin typeface="Calibri" charset="0"/>
@@ -7352,13 +7366,13 @@
                       <a:r>
                         <a:rPr lang="en-US" sz="800" b="1" dirty="0">
                           <a:solidFill>
-                            <a:srgbClr val="C84B00"/>
+                            <a:srgbClr val="8A6200"/>
                           </a:solidFill>
                           <a:latin typeface="Calibri" pitchFamily="34" charset="0"/>
                           <a:ea typeface="Calibri" pitchFamily="34" charset="-122"/>
                           <a:cs typeface="Calibri" pitchFamily="34" charset="-120"/>
                         </a:rPr>
-                        <a:t>5.5</a:t>
+                        <a:t>26.2</a:t>
                       </a:r>
                       <a:endParaRPr lang="en-US" sz="800" dirty="0">
                         <a:latin typeface="Calibri" charset="0"/>
@@ -7496,7 +7510,7 @@
                           <a:ea typeface="Calibri" pitchFamily="34" charset="-122"/>
                           <a:cs typeface="Calibri" pitchFamily="34" charset="-120"/>
                         </a:rPr>
-                        <a:t>0.913</a:t>
+                        <a:t>0.87</a:t>
                       </a:r>
                       <a:endParaRPr lang="en-US" sz="800" dirty="0">
                         <a:latin typeface="Calibri" charset="0"/>
@@ -7564,7 +7578,7 @@
                           <a:ea typeface="Calibri" pitchFamily="34" charset="-122"/>
                           <a:cs typeface="Calibri" pitchFamily="34" charset="-120"/>
                         </a:rPr>
-                        <a:t> 91.3</a:t>
+                        <a:t> 55.3</a:t>
                       </a:r>
                       <a:endParaRPr lang="en-US" sz="800" dirty="0">
                         <a:latin typeface="Calibri" charset="0"/>
@@ -7632,7 +7646,7 @@
                           <a:ea typeface="Calibri" pitchFamily="34" charset="-122"/>
                           <a:cs typeface="Calibri" pitchFamily="34" charset="-120"/>
                         </a:rPr>
-                        <a:t>11.0</a:t>
+                        <a:t>18.1</a:t>
                       </a:r>
                       <a:endParaRPr lang="en-US" sz="800" dirty="0">
                         <a:latin typeface="Calibri" charset="0"/>
@@ -7700,7 +7714,7 @@
                           <a:ea typeface="Calibri" pitchFamily="34" charset="-122"/>
                           <a:cs typeface="Calibri" pitchFamily="34" charset="-120"/>
                         </a:rPr>
-                        <a:t>130.4</a:t>
+                        <a:t> 35.3</a:t>
                       </a:r>
                       <a:endParaRPr lang="en-US" sz="800" dirty="0">
                         <a:latin typeface="Calibri" charset="0"/>
@@ -7762,13 +7776,13 @@
                       <a:r>
                         <a:rPr lang="en-US" sz="800" b="1" dirty="0">
                           <a:solidFill>
-                            <a:srgbClr val="8A6200"/>
+                            <a:srgbClr val="1A7A3C"/>
                           </a:solidFill>
                           <a:latin typeface="Calibri" pitchFamily="34" charset="0"/>
                           <a:ea typeface="Calibri" pitchFamily="34" charset="-122"/>
                           <a:cs typeface="Calibri" pitchFamily="34" charset="-120"/>
                         </a:rPr>
-                        <a:t>7.7</a:t>
+                        <a:t>28.3</a:t>
                       </a:r>
                       <a:endParaRPr lang="en-US" sz="800" dirty="0">
                         <a:latin typeface="Calibri" charset="0"/>
@@ -7906,7 +7920,7 @@
                           <a:ea typeface="Calibri" pitchFamily="34" charset="-122"/>
                           <a:cs typeface="Calibri" pitchFamily="34" charset="-120"/>
                         </a:rPr>
-                        <a:t>0.548</a:t>
+                        <a:t>0.52</a:t>
                       </a:r>
                       <a:endParaRPr lang="en-US" sz="800" dirty="0">
                         <a:latin typeface="Calibri" charset="0"/>
@@ -7974,7 +7988,7 @@
                           <a:ea typeface="Calibri" pitchFamily="34" charset="-122"/>
                           <a:cs typeface="Calibri" pitchFamily="34" charset="-120"/>
                         </a:rPr>
-                        <a:t> 54.8</a:t>
+                        <a:t> 36.6</a:t>
                       </a:r>
                       <a:endParaRPr lang="en-US" sz="800" dirty="0">
                         <a:latin typeface="Calibri" charset="0"/>
@@ -8042,7 +8056,7 @@
                           <a:ea typeface="Calibri" pitchFamily="34" charset="-122"/>
                           <a:cs typeface="Calibri" pitchFamily="34" charset="-120"/>
                         </a:rPr>
-                        <a:t>18.3</a:t>
+                        <a:t>27.3</a:t>
                       </a:r>
                       <a:endParaRPr lang="en-US" sz="800" dirty="0">
                         <a:latin typeface="Calibri" charset="0"/>
@@ -8110,7 +8124,7 @@
                           <a:ea typeface="Calibri" pitchFamily="34" charset="-122"/>
                           <a:cs typeface="Calibri" pitchFamily="34" charset="-120"/>
                         </a:rPr>
-                        <a:t> 78.3</a:t>
+                        <a:t> 36.6</a:t>
                       </a:r>
                       <a:endParaRPr lang="en-US" sz="800" dirty="0">
                         <a:latin typeface="Calibri" charset="0"/>
@@ -8172,13 +8186,13 @@
                       <a:r>
                         <a:rPr lang="en-US" sz="800" b="1" dirty="0">
                           <a:solidFill>
-                            <a:srgbClr val="8A6200"/>
+                            <a:srgbClr val="1A7A3C"/>
                           </a:solidFill>
                           <a:latin typeface="Calibri" pitchFamily="34" charset="0"/>
                           <a:ea typeface="Calibri" pitchFamily="34" charset="-122"/>
                           <a:cs typeface="Calibri" pitchFamily="34" charset="-120"/>
                         </a:rPr>
-                        <a:t>12.8</a:t>
+                        <a:t>27.3</a:t>
                       </a:r>
                       <a:endParaRPr lang="en-US" sz="800" dirty="0">
                         <a:latin typeface="Calibri" charset="0"/>
@@ -8316,7 +8330,7 @@
                           <a:ea typeface="Calibri" pitchFamily="34" charset="-122"/>
                           <a:cs typeface="Calibri" pitchFamily="34" charset="-120"/>
                         </a:rPr>
-                        <a:t>0.274</a:t>
+                        <a:t>0.26</a:t>
                       </a:r>
                       <a:endParaRPr lang="en-US" sz="800" dirty="0">
                         <a:latin typeface="Calibri" charset="0"/>
@@ -8384,7 +8398,7 @@
                           <a:ea typeface="Calibri" pitchFamily="34" charset="-122"/>
                           <a:cs typeface="Calibri" pitchFamily="34" charset="-120"/>
                         </a:rPr>
-                        <a:t> 27.4</a:t>
+                        <a:t> 37.5</a:t>
                       </a:r>
                       <a:endParaRPr lang="en-US" sz="800" dirty="0">
                         <a:latin typeface="Calibri" charset="0"/>
@@ -8452,7 +8466,7 @@
                           <a:ea typeface="Calibri" pitchFamily="34" charset="-122"/>
                           <a:cs typeface="Calibri" pitchFamily="34" charset="-120"/>
                         </a:rPr>
-                        <a:t>36.5</a:t>
+                        <a:t>26.7</a:t>
                       </a:r>
                       <a:endParaRPr lang="en-US" sz="800" dirty="0">
                         <a:latin typeface="Calibri" charset="0"/>
@@ -8520,7 +8534,7 @@
                           <a:ea typeface="Calibri" pitchFamily="34" charset="-122"/>
                           <a:cs typeface="Calibri" pitchFamily="34" charset="-120"/>
                         </a:rPr>
-                        <a:t> 39.1</a:t>
+                        <a:t> 37.5</a:t>
                       </a:r>
                       <a:endParaRPr lang="en-US" sz="800" dirty="0">
                         <a:latin typeface="Calibri" charset="0"/>
@@ -8588,7 +8602,7 @@
                           <a:ea typeface="Calibri" pitchFamily="34" charset="-122"/>
                           <a:cs typeface="Calibri" pitchFamily="34" charset="-120"/>
                         </a:rPr>
-                        <a:t>25.6</a:t>
+                        <a:t>26.7</a:t>
                       </a:r>
                       <a:endParaRPr lang="en-US" sz="800" dirty="0">
                         <a:latin typeface="Calibri" charset="0"/>
@@ -8794,7 +8808,7 @@
                           <a:ea typeface="Calibri" pitchFamily="34" charset="-122"/>
                           <a:cs typeface="Calibri" pitchFamily="34" charset="-120"/>
                         </a:rPr>
-                        <a:t> 19.4</a:t>
+                        <a:t> 38.5</a:t>
                       </a:r>
                       <a:endParaRPr lang="en-US" sz="800" dirty="0">
                         <a:latin typeface="Calibri" charset="0"/>
@@ -8862,7 +8876,7 @@
                           <a:ea typeface="Calibri" pitchFamily="34" charset="-122"/>
                           <a:cs typeface="Calibri" pitchFamily="34" charset="-120"/>
                         </a:rPr>
-                        <a:t>51.6</a:t>
+                        <a:t>26.0</a:t>
                       </a:r>
                       <a:endParaRPr lang="en-US" sz="800" dirty="0">
                         <a:latin typeface="Calibri" charset="0"/>
@@ -8930,7 +8944,7 @@
                           <a:ea typeface="Calibri" pitchFamily="34" charset="-122"/>
                           <a:cs typeface="Calibri" pitchFamily="34" charset="-120"/>
                         </a:rPr>
-                        <a:t> 19.4</a:t>
+                        <a:t> 38.5</a:t>
                       </a:r>
                       <a:endParaRPr lang="en-US" sz="800" dirty="0">
                         <a:latin typeface="Calibri" charset="0"/>
@@ -8998,7 +9012,7 @@
                           <a:ea typeface="Calibri" pitchFamily="34" charset="-122"/>
                           <a:cs typeface="Calibri" pitchFamily="34" charset="-120"/>
                         </a:rPr>
-                        <a:t>51.6</a:t>
+                        <a:t>26.0</a:t>
                       </a:r>
                       <a:endParaRPr lang="en-US" sz="800" dirty="0">
                         <a:latin typeface="Calibri" charset="0"/>
@@ -9087,7 +9101,35 @@
                 <a:ea typeface="Calibri" pitchFamily="34" charset="-122"/>
                 <a:cs typeface="Calibri" pitchFamily="34" charset="-120"/>
               </a:rPr>
-              <a:t>GPU mem ceil: </a:t>
+              <a:t>PCIe5→GPU-bnd: ~67% hit  |  PCIe6→GPU-bnd: </a:t>
+            </a:r>
+            <a:pPr indent="0" marL="0">
+              <a:buNone/>
+            </a:pPr>
+            <a:r>
+              <a:rPr lang="en-US" sz="750" b="1" dirty="0">
+                <a:solidFill>
+                  <a:srgbClr val="2458A4"/>
+                </a:solidFill>
+                <a:latin typeface="Calibri" pitchFamily="34" charset="0"/>
+                <a:ea typeface="Calibri" pitchFamily="34" charset="-122"/>
+                <a:cs typeface="Calibri" pitchFamily="34" charset="-120"/>
+              </a:rPr>
+              <a:t>~37% hit</a:t>
+            </a:r>
+            <a:pPr indent="0" marL="0">
+              <a:buNone/>
+            </a:pPr>
+            <a:r>
+              <a:rPr lang="en-US" sz="750" dirty="0">
+                <a:solidFill>
+                  <a:srgbClr val="555555"/>
+                </a:solidFill>
+                <a:latin typeface="Calibri" pitchFamily="34" charset="0"/>
+                <a:ea typeface="Calibri" pitchFamily="34" charset="-122"/>
+                <a:cs typeface="Calibri" pitchFamily="34" charset="-120"/>
+              </a:rPr>
+              <a:t>  |  GPU ceil = </a:t>
             </a:r>
             <a:pPr indent="0" marL="0">
               <a:buNone/>
@@ -9101,7 +9143,7 @@
                 <a:ea typeface="Calibri" pitchFamily="34" charset="-122"/>
                 <a:cs typeface="Calibri" pitchFamily="34" charset="-120"/>
               </a:rPr>
-              <a:t>51.6 tok/s</a:t>
+              <a:t>26.0 tok/s</a:t>
             </a:r>
             <a:pPr indent="0" marL="0">
               <a:buNone/>
@@ -9115,35 +9157,7 @@
                 <a:ea typeface="Calibri" pitchFamily="34" charset="-122"/>
                 <a:cs typeface="Calibri" pitchFamily="34" charset="-120"/>
               </a:rPr>
-              <a:t> (new 546 GB/s)  |  DGX: </a:t>
-            </a:r>
-            <a:pPr indent="0" marL="0">
-              <a:buNone/>
-            </a:pPr>
-            <a:r>
-              <a:rPr lang="en-US" sz="750" b="1" dirty="0">
-                <a:solidFill>
-                  <a:srgbClr val="5A9E5A"/>
-                </a:solidFill>
-                <a:latin typeface="Calibri" pitchFamily="34" charset="0"/>
-                <a:ea typeface="Calibri" pitchFamily="34" charset="-122"/>
-                <a:cs typeface="Calibri" pitchFamily="34" charset="-120"/>
-              </a:rPr>
-              <a:t>25.8 tok/s</a:t>
-            </a:r>
-            <a:pPr indent="0" marL="0">
-              <a:buNone/>
-            </a:pPr>
-            <a:r>
-              <a:rPr lang="en-US" sz="750" dirty="0">
-                <a:solidFill>
-                  <a:srgbClr val="555555"/>
-                </a:solidFill>
-                <a:latin typeface="Calibri" pitchFamily="34" charset="0"/>
-                <a:ea typeface="Calibri" pitchFamily="34" charset="-122"/>
-                <a:cs typeface="Calibri" pitchFamily="34" charset="-120"/>
-              </a:rPr>
-              <a:t> (273 GB/s)  |  UFS5→GPU-bnd at ~90%</a:t>
+              <a:t> (273 GB/s fixed)</a:t>
             </a:r>
             <a:endParaRPr lang="en-US" sz="750" dirty="0"/>
           </a:p>
@@ -9223,7 +9237,7 @@
                 <a:ea typeface="Calibri" pitchFamily="34" charset="-122"/>
                 <a:cs typeface="Calibri" pitchFamily="34" charset="-120"/>
               </a:rPr>
-              <a:t>Performance Summary: UFS 5.0 vs NVMe 7 GB/s  —  New Platform (546 GB/s / 240 TOPS)  |  DGX ref (273 GB/s / 123 TOPS)</a:t>
+              <a:t>Performance Summary: PCIe 5.0 x4 (15.75 GB/s) vs PCIe 6.0 x4 (32 GB/s) NVMe  —  ds4 FlashMoE on GB10 (273 GB/s / 123 TOPS)</a:t>
             </a:r>
             <a:endParaRPr lang="en-US" sz="900" dirty="0"/>
           </a:p>
@@ -9252,12 +9266,11 @@
             <a:tbl>
               <a:tblPr/>
               <a:tblGrid>
-                <a:gridCol w="1828800"/>
-                <a:gridCol w="1280160"/>
-                <a:gridCol w="1280160"/>
-                <a:gridCol w="1005840"/>
-                <a:gridCol w="1188720"/>
-                <a:gridCol w="5248656"/>
+                <a:gridCol w="1920240"/>
+                <a:gridCol w="1645920"/>
+                <a:gridCol w="1645920"/>
+                <a:gridCol w="1225296"/>
+                <a:gridCol w="5394960"/>
               </a:tblGrid>
               <a:tr h="237744">
                 <a:tc>
@@ -9345,7 +9358,7 @@
                           <a:ea typeface="Calibri" pitchFamily="34" charset="-122"/>
                           <a:cs typeface="Calibri" pitchFamily="34" charset="-120"/>
                         </a:rPr>
-                        <a:t>New UFS 5.0</a:t>
+                        <a:t>PCIe 5.0 (15.75 GB/s)</a:t>
                       </a:r>
                       <a:endParaRPr lang="en-US" sz="850" dirty="0">
                         <a:latin typeface="Calibri" charset="0"/>
@@ -9413,7 +9426,7 @@
                           <a:ea typeface="Calibri" pitchFamily="34" charset="-122"/>
                           <a:cs typeface="Calibri" pitchFamily="34" charset="-120"/>
                         </a:rPr>
-                        <a:t>New NVMe 7</a:t>
+                        <a:t>PCIe 6.0 (32 GB/s)</a:t>
                       </a:r>
                       <a:endParaRPr lang="en-US" sz="850" dirty="0">
                         <a:latin typeface="Calibri" charset="0"/>
@@ -9481,75 +9494,7 @@
                           <a:ea typeface="Calibri" pitchFamily="34" charset="-122"/>
                           <a:cs typeface="Calibri" pitchFamily="34" charset="-120"/>
                         </a:rPr>
-                        <a:t>UFS/NVMe</a:t>
-                      </a:r>
-                      <a:endParaRPr lang="en-US" sz="850" dirty="0">
-                        <a:latin typeface="Calibri" charset="0"/>
-                        <a:ea typeface="Calibri" charset="0"/>
-                        <a:cs typeface="Calibri" charset="0"/>
-                      </a:endParaRPr>
-                    </a:p>
-                  </a:txBody>
-                  <a:tcPr marL="91440" marR="91440" marT="45720" marB="45720">
-                    <a:lnL w="6350" cap="flat" cmpd="sng" algn="ctr">
-                      <a:solidFill>
-                        <a:srgbClr val="BFCFE8"/>
-                      </a:solidFill>
-                      <a:prstDash val="solid"/>
-                      <a:round/>
-                      <a:headEnd type="none" w="med" len="med"/>
-                      <a:tailEnd type="none" w="med" len="med"/>
-                    </a:lnL>
-                    <a:lnR w="6350" cap="flat" cmpd="sng" algn="ctr">
-                      <a:solidFill>
-                        <a:srgbClr val="BFCFE8"/>
-                      </a:solidFill>
-                      <a:prstDash val="solid"/>
-                      <a:round/>
-                      <a:headEnd type="none" w="med" len="med"/>
-                      <a:tailEnd type="none" w="med" len="med"/>
-                    </a:lnR>
-                    <a:lnT w="6350" cap="flat" cmpd="sng" algn="ctr">
-                      <a:solidFill>
-                        <a:srgbClr val="BFCFE8"/>
-                      </a:solidFill>
-                      <a:prstDash val="solid"/>
-                      <a:round/>
-                      <a:headEnd type="none" w="med" len="med"/>
-                      <a:tailEnd type="none" w="med" len="med"/>
-                    </a:lnT>
-                    <a:lnB w="6350" cap="flat" cmpd="sng" algn="ctr">
-                      <a:solidFill>
-                        <a:srgbClr val="BFCFE8"/>
-                      </a:solidFill>
-                      <a:prstDash val="solid"/>
-                      <a:round/>
-                      <a:headEnd type="none" w="med" len="med"/>
-                      <a:tailEnd type="none" w="med" len="med"/>
-                    </a:lnB>
-                    <a:solidFill>
-                      <a:srgbClr val="1B3A6B"/>
-                    </a:solidFill>
-                  </a:tcPr>
-                </a:tc>
-                <a:tc>
-                  <a:txBody>
-                    <a:bodyPr/>
-                    <a:lstStyle/>
-                    <a:p>
-                      <a:pPr algn="ctr" indent="0" marL="0">
-                        <a:buNone/>
-                      </a:pPr>
-                      <a:r>
-                        <a:rPr lang="en-US" sz="850" b="1" dirty="0">
-                          <a:solidFill>
-                            <a:srgbClr val="FFFFFF"/>
-                          </a:solidFill>
-                          <a:latin typeface="Calibri" pitchFamily="34" charset="0"/>
-                          <a:ea typeface="Calibri" pitchFamily="34" charset="-122"/>
-                          <a:cs typeface="Calibri" pitchFamily="34" charset="-120"/>
-                        </a:rPr>
-                        <a:t>DGX (123T)</a:t>
+                        <a:t>Improvement</a:t>
                       </a:r>
                       <a:endParaRPr lang="en-US" sz="850" dirty="0">
                         <a:latin typeface="Calibri" charset="0"/>
@@ -9734,75 +9679,7 @@
                       <a:tailEnd type="none" w="med" len="med"/>
                     </a:lnB>
                     <a:solidFill>
-                      <a:srgbClr val="EBF3FC"/>
-                    </a:solidFill>
-                  </a:tcPr>
-                </a:tc>
-                <a:tc>
-                  <a:txBody>
-                    <a:bodyPr/>
-                    <a:lstStyle/>
-                    <a:p>
-                      <a:pPr algn="ctr" indent="0" marL="0">
-                        <a:buNone/>
-                      </a:pPr>
-                      <a:r>
-                        <a:rPr lang="en-US" sz="850" b="1" dirty="0">
-                          <a:solidFill>
-                            <a:srgbClr val="1A7A3C"/>
-                          </a:solidFill>
-                          <a:latin typeface="Calibri" pitchFamily="34" charset="0"/>
-                          <a:ea typeface="Calibri" pitchFamily="34" charset="-122"/>
-                          <a:cs typeface="Calibri" pitchFamily="34" charset="-120"/>
-                        </a:rPr>
-                        <a:t>8.67 s</a:t>
-                      </a:r>
-                      <a:endParaRPr lang="en-US" sz="850" dirty="0">
-                        <a:latin typeface="Calibri" charset="0"/>
-                        <a:ea typeface="Calibri" charset="0"/>
-                        <a:cs typeface="Calibri" charset="0"/>
-                      </a:endParaRPr>
-                    </a:p>
-                  </a:txBody>
-                  <a:tcPr marL="91440" marR="91440" marT="45720" marB="45720">
-                    <a:lnL w="6350" cap="flat" cmpd="sng" algn="ctr">
-                      <a:solidFill>
-                        <a:srgbClr val="BFCFE8"/>
-                      </a:solidFill>
-                      <a:prstDash val="solid"/>
-                      <a:round/>
-                      <a:headEnd type="none" w="med" len="med"/>
-                      <a:tailEnd type="none" w="med" len="med"/>
-                    </a:lnL>
-                    <a:lnR w="6350" cap="flat" cmpd="sng" algn="ctr">
-                      <a:solidFill>
-                        <a:srgbClr val="BFCFE8"/>
-                      </a:solidFill>
-                      <a:prstDash val="solid"/>
-                      <a:round/>
-                      <a:headEnd type="none" w="med" len="med"/>
-                      <a:tailEnd type="none" w="med" len="med"/>
-                    </a:lnR>
-                    <a:lnT w="6350" cap="flat" cmpd="sng" algn="ctr">
-                      <a:solidFill>
-                        <a:srgbClr val="BFCFE8"/>
-                      </a:solidFill>
-                      <a:prstDash val="solid"/>
-                      <a:round/>
-                      <a:headEnd type="none" w="med" len="med"/>
-                      <a:tailEnd type="none" w="med" len="med"/>
-                    </a:lnT>
-                    <a:lnB w="6350" cap="flat" cmpd="sng" algn="ctr">
-                      <a:solidFill>
-                        <a:srgbClr val="BFCFE8"/>
-                      </a:solidFill>
-                      <a:prstDash val="solid"/>
-                      <a:round/>
-                      <a:headEnd type="none" w="med" len="med"/>
-                      <a:tailEnd type="none" w="med" len="med"/>
-                    </a:lnB>
-                    <a:solidFill>
-                      <a:srgbClr val="EBF3FC"/>
+                      <a:srgbClr val="FFFFFF"/>
                     </a:solidFill>
                   </a:tcPr>
                 </a:tc>
@@ -9823,281 +9700,7 @@
                           <a:ea typeface="Calibri" pitchFamily="34" charset="-122"/>
                           <a:cs typeface="Calibri" pitchFamily="34" charset="-120"/>
                         </a:rPr>
-                        <a:t>12.38 s</a:t>
-                      </a:r>
-                      <a:endParaRPr lang="en-US" sz="850" dirty="0">
-                        <a:latin typeface="Calibri" charset="0"/>
-                        <a:ea typeface="Calibri" charset="0"/>
-                        <a:cs typeface="Calibri" charset="0"/>
-                      </a:endParaRPr>
-                    </a:p>
-                  </a:txBody>
-                  <a:tcPr marL="91440" marR="91440" marT="45720" marB="45720">
-                    <a:lnL w="6350" cap="flat" cmpd="sng" algn="ctr">
-                      <a:solidFill>
-                        <a:srgbClr val="BFCFE8"/>
-                      </a:solidFill>
-                      <a:prstDash val="solid"/>
-                      <a:round/>
-                      <a:headEnd type="none" w="med" len="med"/>
-                      <a:tailEnd type="none" w="med" len="med"/>
-                    </a:lnL>
-                    <a:lnR w="6350" cap="flat" cmpd="sng" algn="ctr">
-                      <a:solidFill>
-                        <a:srgbClr val="BFCFE8"/>
-                      </a:solidFill>
-                      <a:prstDash val="solid"/>
-                      <a:round/>
-                      <a:headEnd type="none" w="med" len="med"/>
-                      <a:tailEnd type="none" w="med" len="med"/>
-                    </a:lnR>
-                    <a:lnT w="6350" cap="flat" cmpd="sng" algn="ctr">
-                      <a:solidFill>
-                        <a:srgbClr val="BFCFE8"/>
-                      </a:solidFill>
-                      <a:prstDash val="solid"/>
-                      <a:round/>
-                      <a:headEnd type="none" w="med" len="med"/>
-                      <a:tailEnd type="none" w="med" len="med"/>
-                    </a:lnT>
-                    <a:lnB w="6350" cap="flat" cmpd="sng" algn="ctr">
-                      <a:solidFill>
-                        <a:srgbClr val="BFCFE8"/>
-                      </a:solidFill>
-                      <a:prstDash val="solid"/>
-                      <a:round/>
-                      <a:headEnd type="none" w="med" len="med"/>
-                      <a:tailEnd type="none" w="med" len="med"/>
-                    </a:lnB>
-                    <a:solidFill>
-                      <a:srgbClr val="EBF3FC"/>
-                    </a:solidFill>
-                  </a:tcPr>
-                </a:tc>
-                <a:tc>
-                  <a:txBody>
-                    <a:bodyPr/>
-                    <a:lstStyle/>
-                    <a:p>
-                      <a:pPr algn="ctr" indent="0" marL="0">
-                        <a:buNone/>
-                      </a:pPr>
-                      <a:r>
-                        <a:rPr lang="en-US" sz="850" b="1" dirty="0">
-                          <a:solidFill>
-                            <a:srgbClr val="1A7A3C"/>
-                          </a:solidFill>
-                          <a:latin typeface="Calibri" pitchFamily="34" charset="0"/>
-                          <a:ea typeface="Calibri" pitchFamily="34" charset="-122"/>
-                          <a:cs typeface="Calibri" pitchFamily="34" charset="-120"/>
-                        </a:rPr>
-                        <a:t>1.43×</a:t>
-                      </a:r>
-                      <a:endParaRPr lang="en-US" sz="850" dirty="0">
-                        <a:latin typeface="Calibri" charset="0"/>
-                        <a:ea typeface="Calibri" charset="0"/>
-                        <a:cs typeface="Calibri" charset="0"/>
-                      </a:endParaRPr>
-                    </a:p>
-                  </a:txBody>
-                  <a:tcPr marL="91440" marR="91440" marT="45720" marB="45720">
-                    <a:lnL w="6350" cap="flat" cmpd="sng" algn="ctr">
-                      <a:solidFill>
-                        <a:srgbClr val="BFCFE8"/>
-                      </a:solidFill>
-                      <a:prstDash val="solid"/>
-                      <a:round/>
-                      <a:headEnd type="none" w="med" len="med"/>
-                      <a:tailEnd type="none" w="med" len="med"/>
-                    </a:lnL>
-                    <a:lnR w="6350" cap="flat" cmpd="sng" algn="ctr">
-                      <a:solidFill>
-                        <a:srgbClr val="BFCFE8"/>
-                      </a:solidFill>
-                      <a:prstDash val="solid"/>
-                      <a:round/>
-                      <a:headEnd type="none" w="med" len="med"/>
-                      <a:tailEnd type="none" w="med" len="med"/>
-                    </a:lnR>
-                    <a:lnT w="6350" cap="flat" cmpd="sng" algn="ctr">
-                      <a:solidFill>
-                        <a:srgbClr val="BFCFE8"/>
-                      </a:solidFill>
-                      <a:prstDash val="solid"/>
-                      <a:round/>
-                      <a:headEnd type="none" w="med" len="med"/>
-                      <a:tailEnd type="none" w="med" len="med"/>
-                    </a:lnT>
-                    <a:lnB w="6350" cap="flat" cmpd="sng" algn="ctr">
-                      <a:solidFill>
-                        <a:srgbClr val="BFCFE8"/>
-                      </a:solidFill>
-                      <a:prstDash val="solid"/>
-                      <a:round/>
-                      <a:headEnd type="none" w="med" len="med"/>
-                      <a:tailEnd type="none" w="med" len="med"/>
-                    </a:lnB>
-                    <a:solidFill>
-                      <a:srgbClr val="EBF3FC"/>
-                    </a:solidFill>
-                  </a:tcPr>
-                </a:tc>
-                <a:tc>
-                  <a:txBody>
-                    <a:bodyPr/>
-                    <a:lstStyle/>
-                    <a:p>
-                      <a:pPr algn="ctr" indent="0" marL="0">
-                        <a:buNone/>
-                      </a:pPr>
-                      <a:r>
-                        <a:rPr lang="en-US" sz="850" dirty="0">
-                          <a:solidFill>
-                            <a:srgbClr val="555555"/>
-                          </a:solidFill>
-                          <a:latin typeface="Calibri" pitchFamily="34" charset="0"/>
-                          <a:ea typeface="Calibri" pitchFamily="34" charset="-122"/>
-                          <a:cs typeface="Calibri" pitchFamily="34" charset="-120"/>
-                        </a:rPr>
-                        <a:t>8.67 s</a:t>
-                      </a:r>
-                      <a:endParaRPr lang="en-US" sz="850" dirty="0">
-                        <a:latin typeface="Calibri" charset="0"/>
-                        <a:ea typeface="Calibri" charset="0"/>
-                        <a:cs typeface="Calibri" charset="0"/>
-                      </a:endParaRPr>
-                    </a:p>
-                  </a:txBody>
-                  <a:tcPr marL="91440" marR="91440" marT="45720" marB="45720">
-                    <a:lnL w="6350" cap="flat" cmpd="sng" algn="ctr">
-                      <a:solidFill>
-                        <a:srgbClr val="BFCFE8"/>
-                      </a:solidFill>
-                      <a:prstDash val="solid"/>
-                      <a:round/>
-                      <a:headEnd type="none" w="med" len="med"/>
-                      <a:tailEnd type="none" w="med" len="med"/>
-                    </a:lnL>
-                    <a:lnR w="6350" cap="flat" cmpd="sng" algn="ctr">
-                      <a:solidFill>
-                        <a:srgbClr val="BFCFE8"/>
-                      </a:solidFill>
-                      <a:prstDash val="solid"/>
-                      <a:round/>
-                      <a:headEnd type="none" w="med" len="med"/>
-                      <a:tailEnd type="none" w="med" len="med"/>
-                    </a:lnR>
-                    <a:lnT w="6350" cap="flat" cmpd="sng" algn="ctr">
-                      <a:solidFill>
-                        <a:srgbClr val="BFCFE8"/>
-                      </a:solidFill>
-                      <a:prstDash val="solid"/>
-                      <a:round/>
-                      <a:headEnd type="none" w="med" len="med"/>
-                      <a:tailEnd type="none" w="med" len="med"/>
-                    </a:lnT>
-                    <a:lnB w="6350" cap="flat" cmpd="sng" algn="ctr">
-                      <a:solidFill>
-                        <a:srgbClr val="BFCFE8"/>
-                      </a:solidFill>
-                      <a:prstDash val="solid"/>
-                      <a:round/>
-                      <a:headEnd type="none" w="med" len="med"/>
-                      <a:tailEnd type="none" w="med" len="med"/>
-                    </a:lnB>
-                    <a:solidFill>
-                      <a:srgbClr val="EBF3FC"/>
-                    </a:solidFill>
-                  </a:tcPr>
-                </a:tc>
-                <a:tc>
-                  <a:txBody>
-                    <a:bodyPr/>
-                    <a:lstStyle/>
-                    <a:p>
-                      <a:pPr algn="l" indent="0" marL="0">
-                        <a:buNone/>
-                      </a:pPr>
-                      <a:r>
-                        <a:rPr lang="en-US" sz="850" dirty="0">
-                          <a:solidFill>
-                            <a:srgbClr val="555555"/>
-                          </a:solidFill>
-                          <a:latin typeface="Calibri" pitchFamily="34" charset="0"/>
-                          <a:ea typeface="Calibri" pitchFamily="34" charset="-122"/>
-                          <a:cs typeface="Calibri" pitchFamily="34" charset="-120"/>
-                        </a:rPr>
-                        <a:t>Storage BW (platform-independent)</a:t>
-                      </a:r>
-                      <a:endParaRPr lang="en-US" sz="850" dirty="0">
-                        <a:latin typeface="Calibri" charset="0"/>
-                        <a:ea typeface="Calibri" charset="0"/>
-                        <a:cs typeface="Calibri" charset="0"/>
-                      </a:endParaRPr>
-                    </a:p>
-                  </a:txBody>
-                  <a:tcPr marL="91440" marR="91440" marT="45720" marB="45720">
-                    <a:lnL w="6350" cap="flat" cmpd="sng" algn="ctr">
-                      <a:solidFill>
-                        <a:srgbClr val="BFCFE8"/>
-                      </a:solidFill>
-                      <a:prstDash val="solid"/>
-                      <a:round/>
-                      <a:headEnd type="none" w="med" len="med"/>
-                      <a:tailEnd type="none" w="med" len="med"/>
-                    </a:lnL>
-                    <a:lnR w="6350" cap="flat" cmpd="sng" algn="ctr">
-                      <a:solidFill>
-                        <a:srgbClr val="BFCFE8"/>
-                      </a:solidFill>
-                      <a:prstDash val="solid"/>
-                      <a:round/>
-                      <a:headEnd type="none" w="med" len="med"/>
-                      <a:tailEnd type="none" w="med" len="med"/>
-                    </a:lnR>
-                    <a:lnT w="6350" cap="flat" cmpd="sng" algn="ctr">
-                      <a:solidFill>
-                        <a:srgbClr val="BFCFE8"/>
-                      </a:solidFill>
-                      <a:prstDash val="solid"/>
-                      <a:round/>
-                      <a:headEnd type="none" w="med" len="med"/>
-                      <a:tailEnd type="none" w="med" len="med"/>
-                    </a:lnT>
-                    <a:lnB w="6350" cap="flat" cmpd="sng" algn="ctr">
-                      <a:solidFill>
-                        <a:srgbClr val="BFCFE8"/>
-                      </a:solidFill>
-                      <a:prstDash val="solid"/>
-                      <a:round/>
-                      <a:headEnd type="none" w="med" len="med"/>
-                      <a:tailEnd type="none" w="med" len="med"/>
-                    </a:lnB>
-                    <a:solidFill>
-                      <a:srgbClr val="EBF3FC"/>
-                    </a:solidFill>
-                  </a:tcPr>
-                </a:tc>
-              </a:tr>
-              <a:tr h="237744">
-                <a:tc>
-                  <a:txBody>
-                    <a:bodyPr/>
-                    <a:lstStyle/>
-                    <a:p>
-                      <a:pPr algn="l" indent="0" marL="0">
-                        <a:buNone/>
-                      </a:pPr>
-                      <a:r>
-                        <a:rPr lang="en-US" sz="850" dirty="0">
-                          <a:solidFill>
-                            <a:srgbClr val="1B2A4A"/>
-                          </a:solidFill>
-                          <a:latin typeface="Calibri" pitchFamily="34" charset="0"/>
-                          <a:ea typeface="Calibri" pitchFamily="34" charset="-122"/>
-                          <a:cs typeface="Calibri" pitchFamily="34" charset="-120"/>
-                        </a:rPr>
-                        <a:t>Prefill C=512</a:t>
+                        <a:t>20.55 s</a:t>
                       </a:r>
                       <a:endParaRPr lang="en-US" sz="850" dirty="0">
                         <a:latin typeface="Calibri" charset="0"/>
@@ -10165,7 +9768,213 @@
                           <a:ea typeface="Calibri" pitchFamily="34" charset="-122"/>
                           <a:cs typeface="Calibri" pitchFamily="34" charset="-120"/>
                         </a:rPr>
-                        <a:t>2,804 tok/s</a:t>
+                        <a:t>10.12 s</a:t>
+                      </a:r>
+                      <a:endParaRPr lang="en-US" sz="850" dirty="0">
+                        <a:latin typeface="Calibri" charset="0"/>
+                        <a:ea typeface="Calibri" charset="0"/>
+                        <a:cs typeface="Calibri" charset="0"/>
+                      </a:endParaRPr>
+                    </a:p>
+                  </a:txBody>
+                  <a:tcPr marL="91440" marR="91440" marT="45720" marB="45720">
+                    <a:lnL w="6350" cap="flat" cmpd="sng" algn="ctr">
+                      <a:solidFill>
+                        <a:srgbClr val="BFCFE8"/>
+                      </a:solidFill>
+                      <a:prstDash val="solid"/>
+                      <a:round/>
+                      <a:headEnd type="none" w="med" len="med"/>
+                      <a:tailEnd type="none" w="med" len="med"/>
+                    </a:lnL>
+                    <a:lnR w="6350" cap="flat" cmpd="sng" algn="ctr">
+                      <a:solidFill>
+                        <a:srgbClr val="BFCFE8"/>
+                      </a:solidFill>
+                      <a:prstDash val="solid"/>
+                      <a:round/>
+                      <a:headEnd type="none" w="med" len="med"/>
+                      <a:tailEnd type="none" w="med" len="med"/>
+                    </a:lnR>
+                    <a:lnT w="6350" cap="flat" cmpd="sng" algn="ctr">
+                      <a:solidFill>
+                        <a:srgbClr val="BFCFE8"/>
+                      </a:solidFill>
+                      <a:prstDash val="solid"/>
+                      <a:round/>
+                      <a:headEnd type="none" w="med" len="med"/>
+                      <a:tailEnd type="none" w="med" len="med"/>
+                    </a:lnT>
+                    <a:lnB w="6350" cap="flat" cmpd="sng" algn="ctr">
+                      <a:solidFill>
+                        <a:srgbClr val="BFCFE8"/>
+                      </a:solidFill>
+                      <a:prstDash val="solid"/>
+                      <a:round/>
+                      <a:headEnd type="none" w="med" len="med"/>
+                      <a:tailEnd type="none" w="med" len="med"/>
+                    </a:lnB>
+                    <a:solidFill>
+                      <a:srgbClr val="FFFFFF"/>
+                    </a:solidFill>
+                  </a:tcPr>
+                </a:tc>
+                <a:tc>
+                  <a:txBody>
+                    <a:bodyPr/>
+                    <a:lstStyle/>
+                    <a:p>
+                      <a:pPr algn="ctr" indent="0" marL="0">
+                        <a:buNone/>
+                      </a:pPr>
+                      <a:r>
+                        <a:rPr lang="en-US" sz="850" b="1" dirty="0">
+                          <a:solidFill>
+                            <a:srgbClr val="1A7A3C"/>
+                          </a:solidFill>
+                          <a:latin typeface="Calibri" pitchFamily="34" charset="0"/>
+                          <a:ea typeface="Calibri" pitchFamily="34" charset="-122"/>
+                          <a:cs typeface="Calibri" pitchFamily="34" charset="-120"/>
+                        </a:rPr>
+                        <a:t>2.03× faster</a:t>
+                      </a:r>
+                      <a:endParaRPr lang="en-US" sz="850" dirty="0">
+                        <a:latin typeface="Calibri" charset="0"/>
+                        <a:ea typeface="Calibri" charset="0"/>
+                        <a:cs typeface="Calibri" charset="0"/>
+                      </a:endParaRPr>
+                    </a:p>
+                  </a:txBody>
+                  <a:tcPr marL="91440" marR="91440" marT="45720" marB="45720">
+                    <a:lnL w="6350" cap="flat" cmpd="sng" algn="ctr">
+                      <a:solidFill>
+                        <a:srgbClr val="BFCFE8"/>
+                      </a:solidFill>
+                      <a:prstDash val="solid"/>
+                      <a:round/>
+                      <a:headEnd type="none" w="med" len="med"/>
+                      <a:tailEnd type="none" w="med" len="med"/>
+                    </a:lnL>
+                    <a:lnR w="6350" cap="flat" cmpd="sng" algn="ctr">
+                      <a:solidFill>
+                        <a:srgbClr val="BFCFE8"/>
+                      </a:solidFill>
+                      <a:prstDash val="solid"/>
+                      <a:round/>
+                      <a:headEnd type="none" w="med" len="med"/>
+                      <a:tailEnd type="none" w="med" len="med"/>
+                    </a:lnR>
+                    <a:lnT w="6350" cap="flat" cmpd="sng" algn="ctr">
+                      <a:solidFill>
+                        <a:srgbClr val="BFCFE8"/>
+                      </a:solidFill>
+                      <a:prstDash val="solid"/>
+                      <a:round/>
+                      <a:headEnd type="none" w="med" len="med"/>
+                      <a:tailEnd type="none" w="med" len="med"/>
+                    </a:lnT>
+                    <a:lnB w="6350" cap="flat" cmpd="sng" algn="ctr">
+                      <a:solidFill>
+                        <a:srgbClr val="BFCFE8"/>
+                      </a:solidFill>
+                      <a:prstDash val="solid"/>
+                      <a:round/>
+                      <a:headEnd type="none" w="med" len="med"/>
+                      <a:tailEnd type="none" w="med" len="med"/>
+                    </a:lnB>
+                    <a:solidFill>
+                      <a:srgbClr val="FFFFFF"/>
+                    </a:solidFill>
+                  </a:tcPr>
+                </a:tc>
+                <a:tc>
+                  <a:txBody>
+                    <a:bodyPr/>
+                    <a:lstStyle/>
+                    <a:p>
+                      <a:pPr algn="l" indent="0" marL="0">
+                        <a:buNone/>
+                      </a:pPr>
+                      <a:r>
+                        <a:rPr lang="en-US" sz="850" dirty="0">
+                          <a:solidFill>
+                            <a:srgbClr val="555555"/>
+                          </a:solidFill>
+                          <a:latin typeface="Calibri" pitchFamily="34" charset="0"/>
+                          <a:ea typeface="Calibri" pitchFamily="34" charset="-122"/>
+                          <a:cs typeface="Calibri" pitchFamily="34" charset="-120"/>
+                        </a:rPr>
+                        <a:t>Storage BW (I/O-bound both)</a:t>
+                      </a:r>
+                      <a:endParaRPr lang="en-US" sz="850" dirty="0">
+                        <a:latin typeface="Calibri" charset="0"/>
+                        <a:ea typeface="Calibri" charset="0"/>
+                        <a:cs typeface="Calibri" charset="0"/>
+                      </a:endParaRPr>
+                    </a:p>
+                  </a:txBody>
+                  <a:tcPr marL="91440" marR="91440" marT="45720" marB="45720">
+                    <a:lnL w="6350" cap="flat" cmpd="sng" algn="ctr">
+                      <a:solidFill>
+                        <a:srgbClr val="BFCFE8"/>
+                      </a:solidFill>
+                      <a:prstDash val="solid"/>
+                      <a:round/>
+                      <a:headEnd type="none" w="med" len="med"/>
+                      <a:tailEnd type="none" w="med" len="med"/>
+                    </a:lnL>
+                    <a:lnR w="6350" cap="flat" cmpd="sng" algn="ctr">
+                      <a:solidFill>
+                        <a:srgbClr val="BFCFE8"/>
+                      </a:solidFill>
+                      <a:prstDash val="solid"/>
+                      <a:round/>
+                      <a:headEnd type="none" w="med" len="med"/>
+                      <a:tailEnd type="none" w="med" len="med"/>
+                    </a:lnR>
+                    <a:lnT w="6350" cap="flat" cmpd="sng" algn="ctr">
+                      <a:solidFill>
+                        <a:srgbClr val="BFCFE8"/>
+                      </a:solidFill>
+                      <a:prstDash val="solid"/>
+                      <a:round/>
+                      <a:headEnd type="none" w="med" len="med"/>
+                      <a:tailEnd type="none" w="med" len="med"/>
+                    </a:lnT>
+                    <a:lnB w="6350" cap="flat" cmpd="sng" algn="ctr">
+                      <a:solidFill>
+                        <a:srgbClr val="BFCFE8"/>
+                      </a:solidFill>
+                      <a:prstDash val="solid"/>
+                      <a:round/>
+                      <a:headEnd type="none" w="med" len="med"/>
+                      <a:tailEnd type="none" w="med" len="med"/>
+                    </a:lnB>
+                    <a:solidFill>
+                      <a:srgbClr val="FFFFFF"/>
+                    </a:solidFill>
+                  </a:tcPr>
+                </a:tc>
+              </a:tr>
+              <a:tr h="237744">
+                <a:tc>
+                  <a:txBody>
+                    <a:bodyPr/>
+                    <a:lstStyle/>
+                    <a:p>
+                      <a:pPr algn="l" indent="0" marL="0">
+                        <a:buNone/>
+                      </a:pPr>
+                      <a:r>
+                        <a:rPr lang="en-US" sz="850" dirty="0">
+                          <a:solidFill>
+                            <a:srgbClr val="1B2A4A"/>
+                          </a:solidFill>
+                          <a:latin typeface="Calibri" pitchFamily="34" charset="0"/>
+                          <a:ea typeface="Calibri" pitchFamily="34" charset="-122"/>
+                          <a:cs typeface="Calibri" pitchFamily="34" charset="-120"/>
+                        </a:rPr>
+                        <a:t>Prefill C=128</a:t>
                       </a:r>
                       <a:endParaRPr lang="en-US" sz="850" dirty="0">
                         <a:latin typeface="Calibri" charset="0"/>
@@ -10233,7 +10042,7 @@
                           <a:ea typeface="Calibri" pitchFamily="34" charset="-122"/>
                           <a:cs typeface="Calibri" pitchFamily="34" charset="-120"/>
                         </a:rPr>
-                        <a:t>1,963 tok/s</a:t>
+                        <a:t>403 tok/s</a:t>
                       </a:r>
                       <a:endParaRPr lang="en-US" sz="850" dirty="0">
                         <a:latin typeface="Calibri" charset="0"/>
@@ -10301,7 +10110,7 @@
                           <a:ea typeface="Calibri" pitchFamily="34" charset="-122"/>
                           <a:cs typeface="Calibri" pitchFamily="34" charset="-120"/>
                         </a:rPr>
-                        <a:t>1.43×</a:t>
+                        <a:t>806 tok/s</a:t>
                       </a:r>
                       <a:endParaRPr lang="en-US" sz="850" dirty="0">
                         <a:latin typeface="Calibri" charset="0"/>
@@ -10361,15 +10170,15 @@
                         <a:buNone/>
                       </a:pPr>
                       <a:r>
-                        <a:rPr lang="en-US" sz="850" dirty="0">
+                        <a:rPr lang="en-US" sz="850" b="1" dirty="0">
                           <a:solidFill>
-                            <a:srgbClr val="555555"/>
+                            <a:srgbClr val="1A7A3C"/>
                           </a:solidFill>
                           <a:latin typeface="Calibri" pitchFamily="34" charset="0"/>
                           <a:ea typeface="Calibri" pitchFamily="34" charset="-122"/>
                           <a:cs typeface="Calibri" pitchFamily="34" charset="-120"/>
                         </a:rPr>
-                        <a:t>2,804</a:t>
+                        <a:t>2.03×</a:t>
                       </a:r>
                       <a:endParaRPr lang="en-US" sz="850" dirty="0">
                         <a:latin typeface="Calibri" charset="0"/>
@@ -10437,7 +10246,7 @@
                           <a:ea typeface="Calibri" pitchFamily="34" charset="-122"/>
                           <a:cs typeface="Calibri" pitchFamily="34" charset="-120"/>
                         </a:rPr>
-                        <a:t>IO-bound (all platforms, same TPS)</a:t>
+                        <a:t>GPU Mem BW-bound (C × BW / model_size)</a:t>
                       </a:r>
                       <a:endParaRPr lang="en-US" sz="850" dirty="0">
                         <a:latin typeface="Calibri" charset="0"/>
@@ -10499,7 +10308,7 @@
                         <a:buNone/>
                       </a:pPr>
                       <a:r>
-                        <a:rPr lang="en-US" sz="850" b="1" dirty="0">
+                        <a:rPr lang="en-US" sz="850" dirty="0">
                           <a:solidFill>
                             <a:srgbClr val="1B2A4A"/>
                           </a:solidFill>
@@ -10554,7 +10363,7 @@
                       <a:tailEnd type="none" w="med" len="med"/>
                     </a:lnB>
                     <a:solidFill>
-                      <a:srgbClr val="FFF4CC"/>
+                      <a:srgbClr val="FFFFFF"/>
                     </a:solidFill>
                   </a:tcPr>
                 </a:tc>
@@ -10569,13 +10378,13 @@
                       <a:r>
                         <a:rPr lang="en-US" sz="850" b="1" dirty="0">
                           <a:solidFill>
-                            <a:srgbClr val="8A6200"/>
+                            <a:srgbClr val="C84B00"/>
                           </a:solidFill>
                           <a:latin typeface="Calibri" pitchFamily="34" charset="0"/>
                           <a:ea typeface="Calibri" pitchFamily="34" charset="-122"/>
                           <a:cs typeface="Calibri" pitchFamily="34" charset="-120"/>
                         </a:rPr>
-                        <a:t>7,700 tok/s</a:t>
+                        <a:t>2,985 tok/s</a:t>
                       </a:r>
                       <a:endParaRPr lang="en-US" sz="850" dirty="0">
                         <a:latin typeface="Calibri" charset="0"/>
@@ -10622,7 +10431,7 @@
                       <a:tailEnd type="none" w="med" len="med"/>
                     </a:lnB>
                     <a:solidFill>
-                      <a:srgbClr val="FFF4CC"/>
+                      <a:srgbClr val="FFFFFF"/>
                     </a:solidFill>
                   </a:tcPr>
                 </a:tc>
@@ -10643,7 +10452,7 @@
                           <a:ea typeface="Calibri" pitchFamily="34" charset="-122"/>
                           <a:cs typeface="Calibri" pitchFamily="34" charset="-120"/>
                         </a:rPr>
-                        <a:t>7,851 tok/s</a:t>
+                        <a:t>2,985 tok/s</a:t>
                       </a:r>
                       <a:endParaRPr lang="en-US" sz="850" dirty="0">
                         <a:latin typeface="Calibri" charset="0"/>
@@ -10690,7 +10499,7 @@
                       <a:tailEnd type="none" w="med" len="med"/>
                     </a:lnB>
                     <a:solidFill>
-                      <a:srgbClr val="FFF4CC"/>
+                      <a:srgbClr val="FFFFFF"/>
                     </a:solidFill>
                   </a:tcPr>
                 </a:tc>
@@ -10705,13 +10514,13 @@
                       <a:r>
                         <a:rPr lang="en-US" sz="850" b="1" dirty="0">
                           <a:solidFill>
-                            <a:srgbClr val="C84B00"/>
+                            <a:srgbClr val="555555"/>
                           </a:solidFill>
                           <a:latin typeface="Calibri" pitchFamily="34" charset="0"/>
                           <a:ea typeface="Calibri" pitchFamily="34" charset="-122"/>
                           <a:cs typeface="Calibri" pitchFamily="34" charset="-120"/>
                         </a:rPr>
-                        <a:t>NVMe +2% ↑</a:t>
+                        <a:t>= Compute</a:t>
                       </a:r>
                       <a:endParaRPr lang="en-US" sz="850" dirty="0">
                         <a:latin typeface="Calibri" charset="0"/>
@@ -10758,75 +10567,7 @@
                       <a:tailEnd type="none" w="med" len="med"/>
                     </a:lnB>
                     <a:solidFill>
-                      <a:srgbClr val="FFF4CC"/>
-                    </a:solidFill>
-                  </a:tcPr>
-                </a:tc>
-                <a:tc>
-                  <a:txBody>
-                    <a:bodyPr/>
-                    <a:lstStyle/>
-                    <a:p>
-                      <a:pPr algn="ctr" indent="0" marL="0">
-                        <a:buNone/>
-                      </a:pPr>
-                      <a:r>
-                        <a:rPr lang="en-US" sz="850" dirty="0">
-                          <a:solidFill>
-                            <a:srgbClr val="555555"/>
-                          </a:solidFill>
-                          <a:latin typeface="Calibri" pitchFamily="34" charset="0"/>
-                          <a:ea typeface="Calibri" pitchFamily="34" charset="-122"/>
-                          <a:cs typeface="Calibri" pitchFamily="34" charset="-120"/>
-                        </a:rPr>
-                        <a:t>3,947</a:t>
-                      </a:r>
-                      <a:endParaRPr lang="en-US" sz="850" dirty="0">
-                        <a:latin typeface="Calibri" charset="0"/>
-                        <a:ea typeface="Calibri" charset="0"/>
-                        <a:cs typeface="Calibri" charset="0"/>
-                      </a:endParaRPr>
-                    </a:p>
-                  </a:txBody>
-                  <a:tcPr marL="91440" marR="91440" marT="45720" marB="45720">
-                    <a:lnL w="6350" cap="flat" cmpd="sng" algn="ctr">
-                      <a:solidFill>
-                        <a:srgbClr val="BFCFE8"/>
-                      </a:solidFill>
-                      <a:prstDash val="solid"/>
-                      <a:round/>
-                      <a:headEnd type="none" w="med" len="med"/>
-                      <a:tailEnd type="none" w="med" len="med"/>
-                    </a:lnL>
-                    <a:lnR w="6350" cap="flat" cmpd="sng" algn="ctr">
-                      <a:solidFill>
-                        <a:srgbClr val="BFCFE8"/>
-                      </a:solidFill>
-                      <a:prstDash val="solid"/>
-                      <a:round/>
-                      <a:headEnd type="none" w="med" len="med"/>
-                      <a:tailEnd type="none" w="med" len="med"/>
-                    </a:lnR>
-                    <a:lnT w="6350" cap="flat" cmpd="sng" algn="ctr">
-                      <a:solidFill>
-                        <a:srgbClr val="BFCFE8"/>
-                      </a:solidFill>
-                      <a:prstDash val="solid"/>
-                      <a:round/>
-                      <a:headEnd type="none" w="med" len="med"/>
-                      <a:tailEnd type="none" w="med" len="med"/>
-                    </a:lnT>
-                    <a:lnB w="6350" cap="flat" cmpd="sng" algn="ctr">
-                      <a:solidFill>
-                        <a:srgbClr val="BFCFE8"/>
-                      </a:solidFill>
-                      <a:prstDash val="solid"/>
-                      <a:round/>
-                      <a:headEnd type="none" w="med" len="med"/>
-                      <a:tailEnd type="none" w="med" len="med"/>
-                    </a:lnB>
-                    <a:solidFill>
-                      <a:srgbClr val="FFF4CC"/>
+                      <a:srgbClr val="FFFFFF"/>
                     </a:solidFill>
                   </a:tcPr>
                 </a:tc>
@@ -10847,7 +10588,7 @@
                           <a:ea typeface="Calibri" pitchFamily="34" charset="-122"/>
                           <a:cs typeface="Calibri" pitchFamily="34" charset="-120"/>
                         </a:rPr>
-                        <a:t>New: UFS5=CPU-bnd, NVMe=IO-bnd; DGX: CPU</a:t>
+                        <a:t>Compute-bound (both identical)</a:t>
                       </a:r>
                       <a:endParaRPr lang="en-US" sz="850" dirty="0">
                         <a:latin typeface="Calibri" charset="0"/>
@@ -10894,7 +10635,7 @@
                       <a:tailEnd type="none" w="med" len="med"/>
                     </a:lnB>
                     <a:solidFill>
-                      <a:srgbClr val="FFF4CC"/>
+                      <a:srgbClr val="FFFFFF"/>
                     </a:solidFill>
                   </a:tcPr>
                 </a:tc>
@@ -10979,81 +10720,13 @@
                       <a:r>
                         <a:rPr lang="en-US" sz="850" b="1" dirty="0">
                           <a:solidFill>
-                            <a:srgbClr val="1A7A3C"/>
-                          </a:solidFill>
-                          <a:latin typeface="Calibri" pitchFamily="34" charset="0"/>
-                          <a:ea typeface="Calibri" pitchFamily="34" charset="-122"/>
-                          <a:cs typeface="Calibri" pitchFamily="34" charset="-120"/>
-                        </a:rPr>
-                        <a:t>5.5 tok/s</a:t>
-                      </a:r>
-                      <a:endParaRPr lang="en-US" sz="850" dirty="0">
-                        <a:latin typeface="Calibri" charset="0"/>
-                        <a:ea typeface="Calibri" charset="0"/>
-                        <a:cs typeface="Calibri" charset="0"/>
-                      </a:endParaRPr>
-                    </a:p>
-                  </a:txBody>
-                  <a:tcPr marL="91440" marR="91440" marT="45720" marB="45720">
-                    <a:lnL w="6350" cap="flat" cmpd="sng" algn="ctr">
-                      <a:solidFill>
-                        <a:srgbClr val="BFCFE8"/>
-                      </a:solidFill>
-                      <a:prstDash val="solid"/>
-                      <a:round/>
-                      <a:headEnd type="none" w="med" len="med"/>
-                      <a:tailEnd type="none" w="med" len="med"/>
-                    </a:lnL>
-                    <a:lnR w="6350" cap="flat" cmpd="sng" algn="ctr">
-                      <a:solidFill>
-                        <a:srgbClr val="BFCFE8"/>
-                      </a:solidFill>
-                      <a:prstDash val="solid"/>
-                      <a:round/>
-                      <a:headEnd type="none" w="med" len="med"/>
-                      <a:tailEnd type="none" w="med" len="med"/>
-                    </a:lnR>
-                    <a:lnT w="6350" cap="flat" cmpd="sng" algn="ctr">
-                      <a:solidFill>
-                        <a:srgbClr val="BFCFE8"/>
-                      </a:solidFill>
-                      <a:prstDash val="solid"/>
-                      <a:round/>
-                      <a:headEnd type="none" w="med" len="med"/>
-                      <a:tailEnd type="none" w="med" len="med"/>
-                    </a:lnT>
-                    <a:lnB w="6350" cap="flat" cmpd="sng" algn="ctr">
-                      <a:solidFill>
-                        <a:srgbClr val="BFCFE8"/>
-                      </a:solidFill>
-                      <a:prstDash val="solid"/>
-                      <a:round/>
-                      <a:headEnd type="none" w="med" len="med"/>
-                      <a:tailEnd type="none" w="med" len="med"/>
-                    </a:lnB>
-                    <a:solidFill>
-                      <a:srgbClr val="FFFFFF"/>
-                    </a:solidFill>
-                  </a:tcPr>
-                </a:tc>
-                <a:tc>
-                  <a:txBody>
-                    <a:bodyPr/>
-                    <a:lstStyle/>
-                    <a:p>
-                      <a:pPr algn="ctr" indent="0" marL="0">
-                        <a:buNone/>
-                      </a:pPr>
-                      <a:r>
-                        <a:rPr lang="en-US" sz="850" b="1" dirty="0">
-                          <a:solidFill>
                             <a:srgbClr val="C84B00"/>
                           </a:solidFill>
                           <a:latin typeface="Calibri" pitchFamily="34" charset="0"/>
                           <a:ea typeface="Calibri" pitchFamily="34" charset="-122"/>
                           <a:cs typeface="Calibri" pitchFamily="34" charset="-120"/>
                         </a:rPr>
-                        <a:t>3.8 tok/s</a:t>
+                        <a:t>9.1 tok/s</a:t>
                       </a:r>
                       <a:endParaRPr lang="en-US" sz="850" dirty="0">
                         <a:latin typeface="Calibri" charset="0"/>
@@ -11121,7 +10794,7 @@
                           <a:ea typeface="Calibri" pitchFamily="34" charset="-122"/>
                           <a:cs typeface="Calibri" pitchFamily="34" charset="-120"/>
                         </a:rPr>
-                        <a:t>1.43×</a:t>
+                        <a:t>18.4 tok/s</a:t>
                       </a:r>
                       <a:endParaRPr lang="en-US" sz="850" dirty="0">
                         <a:latin typeface="Calibri" charset="0"/>
@@ -11181,15 +10854,15 @@
                         <a:buNone/>
                       </a:pPr>
                       <a:r>
-                        <a:rPr lang="en-US" sz="850" dirty="0">
+                        <a:rPr lang="en-US" sz="850" b="1" dirty="0">
                           <a:solidFill>
-                            <a:srgbClr val="555555"/>
+                            <a:srgbClr val="1A7A3C"/>
                           </a:solidFill>
                           <a:latin typeface="Calibri" pitchFamily="34" charset="0"/>
                           <a:ea typeface="Calibri" pitchFamily="34" charset="-122"/>
                           <a:cs typeface="Calibri" pitchFamily="34" charset="-120"/>
                         </a:rPr>
-                        <a:t>5.5 tok/s</a:t>
+                        <a:t>2.03×</a:t>
                       </a:r>
                       <a:endParaRPr lang="en-US" sz="850" dirty="0">
                         <a:latin typeface="Calibri" charset="0"/>
@@ -11257,7 +10930,7 @@
                           <a:ea typeface="Calibri" pitchFamily="34" charset="-122"/>
                           <a:cs typeface="Calibri" pitchFamily="34" charset="-120"/>
                         </a:rPr>
-                        <a:t>Cold SSD (all)</a:t>
+                        <a:t>Cold NVMe bottleneck</a:t>
                       </a:r>
                       <a:endParaRPr lang="en-US" sz="850" dirty="0">
                         <a:latin typeface="Calibri" charset="0"/>
@@ -11327,7 +11000,7 @@
                           <a:ea typeface="Calibri" pitchFamily="34" charset="-122"/>
                           <a:cs typeface="Calibri" pitchFamily="34" charset="-120"/>
                         </a:rPr>
-                        <a:t>Decode 85% hot</a:t>
+                        <a:t>Decode ~50% hot</a:t>
                       </a:r>
                       <a:endParaRPr lang="en-US" sz="850" dirty="0">
                         <a:latin typeface="Calibri" charset="0"/>
@@ -11374,7 +11047,75 @@
                       <a:tailEnd type="none" w="med" len="med"/>
                     </a:lnB>
                     <a:solidFill>
-                      <a:srgbClr val="EBF3FC"/>
+                      <a:srgbClr val="FFFFFF"/>
+                    </a:solidFill>
+                  </a:tcPr>
+                </a:tc>
+                <a:tc>
+                  <a:txBody>
+                    <a:bodyPr/>
+                    <a:lstStyle/>
+                    <a:p>
+                      <a:pPr algn="ctr" indent="0" marL="0">
+                        <a:buNone/>
+                      </a:pPr>
+                      <a:r>
+                        <a:rPr lang="en-US" sz="850" b="1" dirty="0">
+                          <a:solidFill>
+                            <a:srgbClr val="C84B00"/>
+                          </a:solidFill>
+                          <a:latin typeface="Calibri" pitchFamily="34" charset="0"/>
+                          <a:ea typeface="Calibri" pitchFamily="34" charset="-122"/>
+                          <a:cs typeface="Calibri" pitchFamily="34" charset="-120"/>
+                        </a:rPr>
+                        <a:t>18.1 tok/s</a:t>
+                      </a:r>
+                      <a:endParaRPr lang="en-US" sz="850" dirty="0">
+                        <a:latin typeface="Calibri" charset="0"/>
+                        <a:ea typeface="Calibri" charset="0"/>
+                        <a:cs typeface="Calibri" charset="0"/>
+                      </a:endParaRPr>
+                    </a:p>
+                  </a:txBody>
+                  <a:tcPr marL="91440" marR="91440" marT="45720" marB="45720">
+                    <a:lnL w="6350" cap="flat" cmpd="sng" algn="ctr">
+                      <a:solidFill>
+                        <a:srgbClr val="BFCFE8"/>
+                      </a:solidFill>
+                      <a:prstDash val="solid"/>
+                      <a:round/>
+                      <a:headEnd type="none" w="med" len="med"/>
+                      <a:tailEnd type="none" w="med" len="med"/>
+                    </a:lnL>
+                    <a:lnR w="6350" cap="flat" cmpd="sng" algn="ctr">
+                      <a:solidFill>
+                        <a:srgbClr val="BFCFE8"/>
+                      </a:solidFill>
+                      <a:prstDash val="solid"/>
+                      <a:round/>
+                      <a:headEnd type="none" w="med" len="med"/>
+                      <a:tailEnd type="none" w="med" len="med"/>
+                    </a:lnR>
+                    <a:lnT w="6350" cap="flat" cmpd="sng" algn="ctr">
+                      <a:solidFill>
+                        <a:srgbClr val="BFCFE8"/>
+                      </a:solidFill>
+                      <a:prstDash val="solid"/>
+                      <a:round/>
+                      <a:headEnd type="none" w="med" len="med"/>
+                      <a:tailEnd type="none" w="med" len="med"/>
+                    </a:lnT>
+                    <a:lnB w="6350" cap="flat" cmpd="sng" algn="ctr">
+                      <a:solidFill>
+                        <a:srgbClr val="BFCFE8"/>
+                      </a:solidFill>
+                      <a:prstDash val="solid"/>
+                      <a:round/>
+                      <a:headEnd type="none" w="med" len="med"/>
+                      <a:tailEnd type="none" w="med" len="med"/>
+                    </a:lnB>
+                    <a:solidFill>
+                      <a:srgbClr val="FFFFFF"/>
                     </a:solidFill>
                   </a:tcPr>
                 </a:tc>
@@ -11395,7 +11136,7 @@
                           <a:ea typeface="Calibri" pitchFamily="34" charset="-122"/>
                           <a:cs typeface="Calibri" pitchFamily="34" charset="-120"/>
                         </a:rPr>
-                        <a:t>36.5 tok/s</a:t>
+                        <a:t>28.3 tok/s ★</a:t>
                       </a:r>
                       <a:endParaRPr lang="en-US" sz="850" dirty="0">
                         <a:latin typeface="Calibri" charset="0"/>
@@ -11442,75 +11183,7 @@
                       <a:tailEnd type="none" w="med" len="med"/>
                     </a:lnB>
                     <a:solidFill>
-                      <a:srgbClr val="EBF3FC"/>
-                    </a:solidFill>
-                  </a:tcPr>
-                </a:tc>
-                <a:tc>
-                  <a:txBody>
-                    <a:bodyPr/>
-                    <a:lstStyle/>
-                    <a:p>
-                      <a:pPr algn="ctr" indent="0" marL="0">
-                        <a:buNone/>
-                      </a:pPr>
-                      <a:r>
-                        <a:rPr lang="en-US" sz="850" b="1" dirty="0">
-                          <a:solidFill>
-                            <a:srgbClr val="C84B00"/>
-                          </a:solidFill>
-                          <a:latin typeface="Calibri" pitchFamily="34" charset="0"/>
-                          <a:ea typeface="Calibri" pitchFamily="34" charset="-122"/>
-                          <a:cs typeface="Calibri" pitchFamily="34" charset="-120"/>
-                        </a:rPr>
-                        <a:t>25.6 tok/s</a:t>
-                      </a:r>
-                      <a:endParaRPr lang="en-US" sz="850" dirty="0">
-                        <a:latin typeface="Calibri" charset="0"/>
-                        <a:ea typeface="Calibri" charset="0"/>
-                        <a:cs typeface="Calibri" charset="0"/>
-                      </a:endParaRPr>
-                    </a:p>
-                  </a:txBody>
-                  <a:tcPr marL="91440" marR="91440" marT="45720" marB="45720">
-                    <a:lnL w="6350" cap="flat" cmpd="sng" algn="ctr">
-                      <a:solidFill>
-                        <a:srgbClr val="BFCFE8"/>
-                      </a:solidFill>
-                      <a:prstDash val="solid"/>
-                      <a:round/>
-                      <a:headEnd type="none" w="med" len="med"/>
-                      <a:tailEnd type="none" w="med" len="med"/>
-                    </a:lnL>
-                    <a:lnR w="6350" cap="flat" cmpd="sng" algn="ctr">
-                      <a:solidFill>
-                        <a:srgbClr val="BFCFE8"/>
-                      </a:solidFill>
-                      <a:prstDash val="solid"/>
-                      <a:round/>
-                      <a:headEnd type="none" w="med" len="med"/>
-                      <a:tailEnd type="none" w="med" len="med"/>
-                    </a:lnR>
-                    <a:lnT w="6350" cap="flat" cmpd="sng" algn="ctr">
-                      <a:solidFill>
-                        <a:srgbClr val="BFCFE8"/>
-                      </a:solidFill>
-                      <a:prstDash val="solid"/>
-                      <a:round/>
-                      <a:headEnd type="none" w="med" len="med"/>
-                      <a:tailEnd type="none" w="med" len="med"/>
-                    </a:lnT>
-                    <a:lnB w="6350" cap="flat" cmpd="sng" algn="ctr">
-                      <a:solidFill>
-                        <a:srgbClr val="BFCFE8"/>
-                      </a:solidFill>
-                      <a:prstDash val="solid"/>
-                      <a:round/>
-                      <a:headEnd type="none" w="med" len="med"/>
-                      <a:tailEnd type="none" w="med" len="med"/>
-                    </a:lnB>
-                    <a:solidFill>
-                      <a:srgbClr val="EBF3FC"/>
+                      <a:srgbClr val="FFFFFF"/>
                     </a:solidFill>
                   </a:tcPr>
                 </a:tc>
@@ -11531,7 +11204,7 @@
                           <a:ea typeface="Calibri" pitchFamily="34" charset="-122"/>
                           <a:cs typeface="Calibri" pitchFamily="34" charset="-120"/>
                         </a:rPr>
-                        <a:t>1.43×</a:t>
+                        <a:t>PCIe6 peak</a:t>
                       </a:r>
                       <a:endParaRPr lang="en-US" sz="850" dirty="0">
                         <a:latin typeface="Calibri" charset="0"/>
@@ -11578,75 +11251,7 @@
                       <a:tailEnd type="none" w="med" len="med"/>
                     </a:lnB>
                     <a:solidFill>
-                      <a:srgbClr val="EBF3FC"/>
-                    </a:solidFill>
-                  </a:tcPr>
-                </a:tc>
-                <a:tc>
-                  <a:txBody>
-                    <a:bodyPr/>
-                    <a:lstStyle/>
-                    <a:p>
-                      <a:pPr algn="ctr" indent="0" marL="0">
-                        <a:buNone/>
-                      </a:pPr>
-                      <a:r>
-                        <a:rPr lang="en-US" sz="850" dirty="0">
-                          <a:solidFill>
-                            <a:srgbClr val="555555"/>
-                          </a:solidFill>
-                          <a:latin typeface="Calibri" pitchFamily="34" charset="0"/>
-                          <a:ea typeface="Calibri" pitchFamily="34" charset="-122"/>
-                          <a:cs typeface="Calibri" pitchFamily="34" charset="-120"/>
-                        </a:rPr>
-                        <a:t>~26 tok/s</a:t>
-                      </a:r>
-                      <a:endParaRPr lang="en-US" sz="850" dirty="0">
-                        <a:latin typeface="Calibri" charset="0"/>
-                        <a:ea typeface="Calibri" charset="0"/>
-                        <a:cs typeface="Calibri" charset="0"/>
-                      </a:endParaRPr>
-                    </a:p>
-                  </a:txBody>
-                  <a:tcPr marL="91440" marR="91440" marT="45720" marB="45720">
-                    <a:lnL w="6350" cap="flat" cmpd="sng" algn="ctr">
-                      <a:solidFill>
-                        <a:srgbClr val="BFCFE8"/>
-                      </a:solidFill>
-                      <a:prstDash val="solid"/>
-                      <a:round/>
-                      <a:headEnd type="none" w="med" len="med"/>
-                      <a:tailEnd type="none" w="med" len="med"/>
-                    </a:lnL>
-                    <a:lnR w="6350" cap="flat" cmpd="sng" algn="ctr">
-                      <a:solidFill>
-                        <a:srgbClr val="BFCFE8"/>
-                      </a:solidFill>
-                      <a:prstDash val="solid"/>
-                      <a:round/>
-                      <a:headEnd type="none" w="med" len="med"/>
-                      <a:tailEnd type="none" w="med" len="med"/>
-                    </a:lnR>
-                    <a:lnT w="6350" cap="flat" cmpd="sng" algn="ctr">
-                      <a:solidFill>
-                        <a:srgbClr val="BFCFE8"/>
-                      </a:solidFill>
-                      <a:prstDash val="solid"/>
-                      <a:round/>
-                      <a:headEnd type="none" w="med" len="med"/>
-                      <a:tailEnd type="none" w="med" len="med"/>
-                    </a:lnT>
-                    <a:lnB w="6350" cap="flat" cmpd="sng" algn="ctr">
-                      <a:solidFill>
-                        <a:srgbClr val="BFCFE8"/>
-                      </a:solidFill>
-                      <a:prstDash val="solid"/>
-                      <a:round/>
-                      <a:headEnd type="none" w="med" len="med"/>
-                      <a:tailEnd type="none" w="med" len="med"/>
-                    </a:lnB>
-                    <a:solidFill>
-                      <a:srgbClr val="EBF3FC"/>
+                      <a:srgbClr val="FFFFFF"/>
                     </a:solidFill>
                   </a:tcPr>
                 </a:tc>
@@ -11667,7 +11272,7 @@
                           <a:ea typeface="Calibri" pitchFamily="34" charset="-122"/>
                           <a:cs typeface="Calibri" pitchFamily="34" charset="-120"/>
                         </a:rPr>
-                        <a:t>New=SSD-bnd (36.5); DGX=GPU-bnd (~26)</a:t>
+                        <a:t>PCIe5=SSD-bnd; PCIe6=GPU-bnd (peak at ~37% hit)</a:t>
                       </a:r>
                       <a:endParaRPr lang="en-US" sz="850" dirty="0">
                         <a:latin typeface="Calibri" charset="0"/>
@@ -11714,7 +11319,7 @@
                       <a:tailEnd type="none" w="med" len="med"/>
                     </a:lnB>
                     <a:solidFill>
-                      <a:srgbClr val="EBF3FC"/>
+                      <a:srgbClr val="FFFFFF"/>
                     </a:solidFill>
                   </a:tcPr>
                 </a:tc>
@@ -11737,7 +11342,7 @@
                           <a:ea typeface="Calibri" pitchFamily="34" charset="-122"/>
                           <a:cs typeface="Calibri" pitchFamily="34" charset="-120"/>
                         </a:rPr>
-                        <a:t>Decode 100% hot</a:t>
+                        <a:t>Decode ≥70% hot</a:t>
                       </a:r>
                       <a:endParaRPr lang="en-US" sz="850" dirty="0">
                         <a:latin typeface="Calibri" charset="0"/>
@@ -11784,7 +11389,75 @@
                       <a:tailEnd type="none" w="med" len="med"/>
                     </a:lnB>
                     <a:solidFill>
-                      <a:srgbClr val="F0F0F0"/>
+                      <a:srgbClr val="FFFFFF"/>
+                    </a:solidFill>
+                  </a:tcPr>
+                </a:tc>
+                <a:tc>
+                  <a:txBody>
+                    <a:bodyPr/>
+                    <a:lstStyle/>
+                    <a:p>
+                      <a:pPr algn="ctr" indent="0" marL="0">
+                        <a:buNone/>
+                      </a:pPr>
+                      <a:r>
+                        <a:rPr lang="en-US" sz="850" b="1" dirty="0">
+                          <a:solidFill>
+                            <a:srgbClr val="C84B00"/>
+                          </a:solidFill>
+                          <a:latin typeface="Calibri" pitchFamily="34" charset="0"/>
+                          <a:ea typeface="Calibri" pitchFamily="34" charset="-122"/>
+                          <a:cs typeface="Calibri" pitchFamily="34" charset="-120"/>
+                        </a:rPr>
+                        <a:t>~27 tok/s</a:t>
+                      </a:r>
+                      <a:endParaRPr lang="en-US" sz="850" dirty="0">
+                        <a:latin typeface="Calibri" charset="0"/>
+                        <a:ea typeface="Calibri" charset="0"/>
+                        <a:cs typeface="Calibri" charset="0"/>
+                      </a:endParaRPr>
+                    </a:p>
+                  </a:txBody>
+                  <a:tcPr marL="91440" marR="91440" marT="45720" marB="45720">
+                    <a:lnL w="6350" cap="flat" cmpd="sng" algn="ctr">
+                      <a:solidFill>
+                        <a:srgbClr val="BFCFE8"/>
+                      </a:solidFill>
+                      <a:prstDash val="solid"/>
+                      <a:round/>
+                      <a:headEnd type="none" w="med" len="med"/>
+                      <a:tailEnd type="none" w="med" len="med"/>
+                    </a:lnL>
+                    <a:lnR w="6350" cap="flat" cmpd="sng" algn="ctr">
+                      <a:solidFill>
+                        <a:srgbClr val="BFCFE8"/>
+                      </a:solidFill>
+                      <a:prstDash val="solid"/>
+                      <a:round/>
+                      <a:headEnd type="none" w="med" len="med"/>
+                      <a:tailEnd type="none" w="med" len="med"/>
+                    </a:lnR>
+                    <a:lnT w="6350" cap="flat" cmpd="sng" algn="ctr">
+                      <a:solidFill>
+                        <a:srgbClr val="BFCFE8"/>
+                      </a:solidFill>
+                      <a:prstDash val="solid"/>
+                      <a:round/>
+                      <a:headEnd type="none" w="med" len="med"/>
+                      <a:tailEnd type="none" w="med" len="med"/>
+                    </a:lnT>
+                    <a:lnB w="6350" cap="flat" cmpd="sng" algn="ctr">
+                      <a:solidFill>
+                        <a:srgbClr val="BFCFE8"/>
+                      </a:solidFill>
+                      <a:prstDash val="solid"/>
+                      <a:round/>
+                      <a:headEnd type="none" w="med" len="med"/>
+                      <a:tailEnd type="none" w="med" len="med"/>
+                    </a:lnB>
+                    <a:solidFill>
+                      <a:srgbClr val="FFFFFF"/>
                     </a:solidFill>
                   </a:tcPr>
                 </a:tc>
@@ -11805,7 +11478,7 @@
                           <a:ea typeface="Calibri" pitchFamily="34" charset="-122"/>
                           <a:cs typeface="Calibri" pitchFamily="34" charset="-120"/>
                         </a:rPr>
-                        <a:t>51.6 tok/s</a:t>
+                        <a:t>~27 tok/s</a:t>
                       </a:r>
                       <a:endParaRPr lang="en-US" sz="850" dirty="0">
                         <a:latin typeface="Calibri" charset="0"/>
@@ -11852,7 +11525,7 @@
                       <a:tailEnd type="none" w="med" len="med"/>
                     </a:lnB>
                     <a:solidFill>
-                      <a:srgbClr val="F0F0F0"/>
+                      <a:srgbClr val="FFFFFF"/>
                     </a:solidFill>
                   </a:tcPr>
                 </a:tc>
@@ -11867,13 +11540,13 @@
                       <a:r>
                         <a:rPr lang="en-US" sz="850" b="1" dirty="0">
                           <a:solidFill>
-                            <a:srgbClr val="C84B00"/>
+                            <a:srgbClr val="555555"/>
                           </a:solidFill>
                           <a:latin typeface="Calibri" pitchFamily="34" charset="0"/>
                           <a:ea typeface="Calibri" pitchFamily="34" charset="-122"/>
                           <a:cs typeface="Calibri" pitchFamily="34" charset="-120"/>
                         </a:rPr>
-                        <a:t>51.6 tok/s</a:t>
+                        <a:t>≈1.0× (tied)</a:t>
                       </a:r>
                       <a:endParaRPr lang="en-US" sz="850" dirty="0">
                         <a:latin typeface="Calibri" charset="0"/>
@@ -11920,143 +11593,7 @@
                       <a:tailEnd type="none" w="med" len="med"/>
                     </a:lnB>
                     <a:solidFill>
-                      <a:srgbClr val="F0F0F0"/>
-                    </a:solidFill>
-                  </a:tcPr>
-                </a:tc>
-                <a:tc>
-                  <a:txBody>
-                    <a:bodyPr/>
-                    <a:lstStyle/>
-                    <a:p>
-                      <a:pPr algn="ctr" indent="0" marL="0">
-                        <a:buNone/>
-                      </a:pPr>
-                      <a:r>
-                        <a:rPr lang="en-US" sz="850" b="1" dirty="0">
-                          <a:solidFill>
-                            <a:srgbClr val="1A7A3C"/>
-                          </a:solidFill>
-                          <a:latin typeface="Calibri" pitchFamily="34" charset="0"/>
-                          <a:ea typeface="Calibri" pitchFamily="34" charset="-122"/>
-                          <a:cs typeface="Calibri" pitchFamily="34" charset="-120"/>
-                        </a:rPr>
-                        <a:t>2× vs DGX</a:t>
-                      </a:r>
-                      <a:endParaRPr lang="en-US" sz="850" dirty="0">
-                        <a:latin typeface="Calibri" charset="0"/>
-                        <a:ea typeface="Calibri" charset="0"/>
-                        <a:cs typeface="Calibri" charset="0"/>
-                      </a:endParaRPr>
-                    </a:p>
-                  </a:txBody>
-                  <a:tcPr marL="91440" marR="91440" marT="45720" marB="45720">
-                    <a:lnL w="6350" cap="flat" cmpd="sng" algn="ctr">
-                      <a:solidFill>
-                        <a:srgbClr val="BFCFE8"/>
-                      </a:solidFill>
-                      <a:prstDash val="solid"/>
-                      <a:round/>
-                      <a:headEnd type="none" w="med" len="med"/>
-                      <a:tailEnd type="none" w="med" len="med"/>
-                    </a:lnL>
-                    <a:lnR w="6350" cap="flat" cmpd="sng" algn="ctr">
-                      <a:solidFill>
-                        <a:srgbClr val="BFCFE8"/>
-                      </a:solidFill>
-                      <a:prstDash val="solid"/>
-                      <a:round/>
-                      <a:headEnd type="none" w="med" len="med"/>
-                      <a:tailEnd type="none" w="med" len="med"/>
-                    </a:lnR>
-                    <a:lnT w="6350" cap="flat" cmpd="sng" algn="ctr">
-                      <a:solidFill>
-                        <a:srgbClr val="BFCFE8"/>
-                      </a:solidFill>
-                      <a:prstDash val="solid"/>
-                      <a:round/>
-                      <a:headEnd type="none" w="med" len="med"/>
-                      <a:tailEnd type="none" w="med" len="med"/>
-                    </a:lnT>
-                    <a:lnB w="6350" cap="flat" cmpd="sng" algn="ctr">
-                      <a:solidFill>
-                        <a:srgbClr val="BFCFE8"/>
-                      </a:solidFill>
-                      <a:prstDash val="solid"/>
-                      <a:round/>
-                      <a:headEnd type="none" w="med" len="med"/>
-                      <a:tailEnd type="none" w="med" len="med"/>
-                    </a:lnB>
-                    <a:solidFill>
-                      <a:srgbClr val="F0F0F0"/>
-                    </a:solidFill>
-                  </a:tcPr>
-                </a:tc>
-                <a:tc>
-                  <a:txBody>
-                    <a:bodyPr/>
-                    <a:lstStyle/>
-                    <a:p>
-                      <a:pPr algn="ctr" indent="0" marL="0">
-                        <a:buNone/>
-                      </a:pPr>
-                      <a:r>
-                        <a:rPr lang="en-US" sz="850" dirty="0">
-                          <a:solidFill>
-                            <a:srgbClr val="555555"/>
-                          </a:solidFill>
-                          <a:latin typeface="Calibri" pitchFamily="34" charset="0"/>
-                          <a:ea typeface="Calibri" pitchFamily="34" charset="-122"/>
-                          <a:cs typeface="Calibri" pitchFamily="34" charset="-120"/>
-                        </a:rPr>
-                        <a:t>25.8 tok/s</a:t>
-                      </a:r>
-                      <a:endParaRPr lang="en-US" sz="850" dirty="0">
-                        <a:latin typeface="Calibri" charset="0"/>
-                        <a:ea typeface="Calibri" charset="0"/>
-                        <a:cs typeface="Calibri" charset="0"/>
-                      </a:endParaRPr>
-                    </a:p>
-                  </a:txBody>
-                  <a:tcPr marL="91440" marR="91440" marT="45720" marB="45720">
-                    <a:lnL w="6350" cap="flat" cmpd="sng" algn="ctr">
-                      <a:solidFill>
-                        <a:srgbClr val="BFCFE8"/>
-                      </a:solidFill>
-                      <a:prstDash val="solid"/>
-                      <a:round/>
-                      <a:headEnd type="none" w="med" len="med"/>
-                      <a:tailEnd type="none" w="med" len="med"/>
-                    </a:lnL>
-                    <a:lnR w="6350" cap="flat" cmpd="sng" algn="ctr">
-                      <a:solidFill>
-                        <a:srgbClr val="BFCFE8"/>
-                      </a:solidFill>
-                      <a:prstDash val="solid"/>
-                      <a:round/>
-                      <a:headEnd type="none" w="med" len="med"/>
-                      <a:tailEnd type="none" w="med" len="med"/>
-                    </a:lnR>
-                    <a:lnT w="6350" cap="flat" cmpd="sng" algn="ctr">
-                      <a:solidFill>
-                        <a:srgbClr val="BFCFE8"/>
-                      </a:solidFill>
-                      <a:prstDash val="solid"/>
-                      <a:round/>
-                      <a:headEnd type="none" w="med" len="med"/>
-                      <a:tailEnd type="none" w="med" len="med"/>
-                    </a:lnT>
-                    <a:lnB w="6350" cap="flat" cmpd="sng" algn="ctr">
-                      <a:solidFill>
-                        <a:srgbClr val="BFCFE8"/>
-                      </a:solidFill>
-                      <a:prstDash val="solid"/>
-                      <a:round/>
-                      <a:headEnd type="none" w="med" len="med"/>
-                      <a:tailEnd type="none" w="med" len="med"/>
-                    </a:lnB>
-                    <a:solidFill>
-                      <a:srgbClr val="F0F0F0"/>
+                      <a:srgbClr val="FFFFFF"/>
                     </a:solidFill>
                   </a:tcPr>
                 </a:tc>
@@ -12077,7 +11614,7 @@
                           <a:ea typeface="Calibri" pitchFamily="34" charset="-122"/>
                           <a:cs typeface="Calibri" pitchFamily="34" charset="-120"/>
                         </a:rPr>
-                        <a:t>GPU memory ceiling (546 GB/s = 2× DGX)</a:t>
+                        <a:t>GPU memory ceiling (both) @ 273 GB/s</a:t>
                       </a:r>
                       <a:endParaRPr lang="en-US" sz="850" dirty="0">
                         <a:latin typeface="Calibri" charset="0"/>
@@ -12124,7 +11661,7 @@
                       <a:tailEnd type="none" w="med" len="med"/>
                     </a:lnB>
                     <a:solidFill>
-                      <a:srgbClr val="F0F0F0"/>
+                      <a:srgbClr val="FFFFFF"/>
                     </a:solidFill>
                   </a:tcPr>
                 </a:tc>
@@ -12166,7 +11703,7 @@
                 <a:ea typeface="Calibri" pitchFamily="34" charset="-122"/>
                 <a:cs typeface="Calibri" pitchFamily="34" charset="-120"/>
               </a:rPr>
-              <a:t>* New platform: 546 GB/s memory BW, 240 TOPS BF16; DGX (GB10): 273 GB/s, 123 TOPS. ds4 FlashMoE: 43 layers, 256 experts/layer, 6 active, chunk C=2048, expert=7.078 MB. UFS 5.0: 46.6 Gbps/lane × 2 lanes → 10 GB/s payload. Per-layer linear FLOPs=566.2 MFLOPs (excl. lm_head). Compute ceiling=240T/25.41G=9,445; with C=2048 attn=240T/31.17G=7,700 tok/s.</a:t>
+              <a:t>* GB10: 273 GB/s GPU mem BW, 123 TOPS FP16. ds4 FlashMoE: 43 layers, 256 experts/layer, 6 active, expert=6.75 MB (Q4), total expert IO/token=258×6.75=1.74 GB. PCIe 5.0 x4: 32GT/s×4×128/130/8=15.75 GB/s; PCIe 6.0 x4: 64GT/s×4/8=32 GB/s. Decode: bottleneck=max(cold_storage_time, GPU_mem_time); PCIe5→GPU-bnd@~67% hit; PCIe6→GPU-bnd@~37%. GPU ceiling: 10.5 GB/273 GB/s=38.5 ms=26 tok/s.</a:t>
             </a:r>
             <a:endParaRPr lang="en-US" sz="650" dirty="0"/>
           </a:p>

</xml_diff>

<commit_message>
新增 TTFT 性能分析；修正 Prefill 列数据至 PCIe5/PCIe6 on 123T
Prefill 列更新 (PCIe5=15.75 GB/s, PCIe6=32 GB/s, 123T):
- IO/layer: PCIe5=2.57ms, PCIe6=1.27ms; Compute/layer=C×4.603µs
- 交叉点: PCIe6 C≥275 tok, PCIe5 C≥559 tok; 算力天花板=5,052 tok/s
- 折线图替换为 TTFT mini-table (L≤256/L=512/L≥559 三行)

汇总表新增 TTFT 三行:
- TTFT L≤256: PCIe5=110.5ms / PCIe6=54.4ms → 2.03× (IO-bound)
- TTFT L=512: PCIe5=110.5ms / PCIe6=101.4ms → 1.09× (P5=IO; P6=CPU)
- TTFT L≥559: 两者均 ~405ms/2K-tok → 1.0× (CPU-bound，NVMe升级无收益)

修正 Summary 中错误的 Prefill TPS 数值 (403/2985→1158/5052)

Co-Authored-By: Claude Sonnet 4.6 <noreply@anthropic.com>
</commit_message>
<xml_diff>
--- a/ds4_gb10/docs/ufs5_analysis_slide.pptx
+++ b/ds4_gb10/docs/ufs5_analysis_slide.pptx
@@ -401,538 +401,6 @@
 </file>
 
 <file path=ppt/charts/chart2.xml><?xml version="1.0" encoding="utf-8"?>
-<c:chartSpace xmlns:c="http://schemas.openxmlformats.org/drawingml/2006/chart" xmlns:a="http://schemas.openxmlformats.org/drawingml/2006/main" xmlns:r="http://schemas.openxmlformats.org/officeDocument/2006/relationships">
-  <c:date1904 val="0"/>
-  <c:roundedCorners val="1"/>
-  <c:chart>
-    <c:autoTitleDeleted val="1"/>
-    <c:plotArea>
-      <c:layout/>
-      <c:lineChart>
-        <c:varyColors val="0"/>
-        <c:ser>
-          <c:idx val="0"/>
-          <c:order val="0"/>
-          <c:tx>
-            <c:strRef>
-              <c:f>Sheet1!$B$1</c:f>
-              <c:strCache>
-                <c:ptCount val="1"/>
-                <c:pt idx="0">
-                  <c:v>UFS5(New)</c:v>
-                </c:pt>
-              </c:strCache>
-            </c:strRef>
-          </c:tx>
-          <c:spPr>
-            <a:solidFill>
-              <a:srgbClr val="1A7A3C"/>
-            </a:solidFill>
-            <a:ln w="25400" cap="flat">
-              <a:solidFill>
-                <a:srgbClr val="1A7A3C"/>
-              </a:solidFill>
-              <a:prstDash val="solid"/>
-              <a:round/>
-            </a:ln>
-            <a:effectLst/>
-          </c:spPr>
-          <c:invertIfNegative val="0"/>
-          <c:dLbls>
-            <c:numFmt formatCode="#,##0" sourceLinked="0"/>
-            <c:txPr>
-              <a:bodyPr/>
-              <a:lstStyle/>
-              <a:p>
-                <a:pPr>
-                  <a:defRPr b="0" i="0" strike="noStrike" sz="1200" u="none">
-                    <a:solidFill>
-                      <a:srgbClr val="000000"/>
-                    </a:solidFill>
-                    <a:latin typeface="Arial"/>
-                  </a:defRPr>
-                </a:pPr>
-              </a:p>
-            </c:txPr>
-            <c:showLegendKey val="0"/>
-            <c:showVal val="0"/>
-            <c:showCatName val="0"/>
-            <c:showSerName val="0"/>
-            <c:showPercent val="0"/>
-            <c:showBubbleSize val="0"/>
-            <c:showLeaderLines val="0"/>
-          </c:dLbls>
-          <c:marker>
-            <c:symbol val="circle"/>
-            <c:size val="6"/>
-            <c:spPr>
-              <a:solidFill>
-                <a:srgbClr val="1A7A3C"/>
-              </a:solidFill>
-              <a:ln w="9525" cap="flat">
-                <a:solidFill>
-                  <a:srgbClr val="1A7A3C"/>
-                </a:solidFill>
-                <a:prstDash val="solid"/>
-                <a:round/>
-              </a:ln>
-              <a:effectLst/>
-            </c:spPr>
-          </c:marker>
-          <c:cat>
-            <c:multiLvlStrRef>
-              <c:f>Sheet1!$A$2:$A$6</c:f>
-              <c:multiLvlStrCache>
-                <c:ptCount val="5"/>
-                <c:lvl>
-                  <c:pt idx="0">
-                    <c:v>512</c:v>
-                  </c:pt>
-                  <c:pt idx="1">
-                    <c:v>1K</c:v>
-                  </c:pt>
-                  <c:pt idx="2">
-                    <c:v>1.8K</c:v>
-                  </c:pt>
-                  <c:pt idx="3">
-                    <c:v>2K</c:v>
-                  </c:pt>
-                  <c:pt idx="4">
-                    <c:v>4K</c:v>
-                  </c:pt>
-                </c:lvl>
-              </c:multiLvlStrCache>
-            </c:multiLvlStrRef>
-          </c:cat>
-          <c:val>
-            <c:numRef>
-              <c:f>Sheet1!$B$2:$B$6</c:f>
-              <c:numCache>
-                <c:formatCode>General</c:formatCode>
-                <c:ptCount val="5"/>
-                <c:pt idx="0">
-                  <c:v>2804</c:v>
-                </c:pt>
-                <c:pt idx="1">
-                  <c:v>5608</c:v>
-                </c:pt>
-                <c:pt idx="2">
-                  <c:v>9445</c:v>
-                </c:pt>
-                <c:pt idx="3">
-                  <c:v>7700</c:v>
-                </c:pt>
-                <c:pt idx="4">
-                  <c:v>9445</c:v>
-                </c:pt>
-              </c:numCache>
-            </c:numRef>
-          </c:val>
-          <c:smooth val="0"/>
-        </c:ser>
-        <c:ser>
-          <c:idx val="1"/>
-          <c:order val="1"/>
-          <c:tx>
-            <c:strRef>
-              <c:f>Sheet1!$C$1</c:f>
-              <c:strCache>
-                <c:ptCount val="1"/>
-                <c:pt idx="0">
-                  <c:v>NVMe(New)</c:v>
-                </c:pt>
-              </c:strCache>
-            </c:strRef>
-          </c:tx>
-          <c:spPr>
-            <a:solidFill>
-              <a:srgbClr val="C84B00"/>
-            </a:solidFill>
-            <a:ln w="25400" cap="flat">
-              <a:solidFill>
-                <a:srgbClr val="C84B00"/>
-              </a:solidFill>
-              <a:prstDash val="solid"/>
-              <a:round/>
-            </a:ln>
-            <a:effectLst/>
-          </c:spPr>
-          <c:invertIfNegative val="0"/>
-          <c:dLbls>
-            <c:numFmt formatCode="#,##0" sourceLinked="0"/>
-            <c:txPr>
-              <a:bodyPr/>
-              <a:lstStyle/>
-              <a:p>
-                <a:pPr>
-                  <a:defRPr b="0" i="0" strike="noStrike" sz="1200" u="none">
-                    <a:solidFill>
-                      <a:srgbClr val="000000"/>
-                    </a:solidFill>
-                    <a:latin typeface="Arial"/>
-                  </a:defRPr>
-                </a:pPr>
-              </a:p>
-            </c:txPr>
-            <c:showLegendKey val="0"/>
-            <c:showVal val="0"/>
-            <c:showCatName val="0"/>
-            <c:showSerName val="0"/>
-            <c:showPercent val="0"/>
-            <c:showBubbleSize val="0"/>
-            <c:showLeaderLines val="0"/>
-          </c:dLbls>
-          <c:marker>
-            <c:symbol val="circle"/>
-            <c:size val="6"/>
-            <c:spPr>
-              <a:solidFill>
-                <a:srgbClr val="C84B00"/>
-              </a:solidFill>
-              <a:ln w="9525" cap="flat">
-                <a:solidFill>
-                  <a:srgbClr val="C84B00"/>
-                </a:solidFill>
-                <a:prstDash val="solid"/>
-                <a:round/>
-              </a:ln>
-              <a:effectLst/>
-            </c:spPr>
-          </c:marker>
-          <c:cat>
-            <c:multiLvlStrRef>
-              <c:f>Sheet1!$A$2:$A$6</c:f>
-              <c:multiLvlStrCache>
-                <c:ptCount val="5"/>
-                <c:lvl>
-                  <c:pt idx="0">
-                    <c:v>512</c:v>
-                  </c:pt>
-                  <c:pt idx="1">
-                    <c:v>1K</c:v>
-                  </c:pt>
-                  <c:pt idx="2">
-                    <c:v>1.8K</c:v>
-                  </c:pt>
-                  <c:pt idx="3">
-                    <c:v>2K</c:v>
-                  </c:pt>
-                  <c:pt idx="4">
-                    <c:v>4K</c:v>
-                  </c:pt>
-                </c:lvl>
-              </c:multiLvlStrCache>
-            </c:multiLvlStrRef>
-          </c:cat>
-          <c:val>
-            <c:numRef>
-              <c:f>Sheet1!$C$2:$C$6</c:f>
-              <c:numCache>
-                <c:formatCode>General</c:formatCode>
-                <c:ptCount val="5"/>
-                <c:pt idx="0">
-                  <c:v>1963</c:v>
-                </c:pt>
-                <c:pt idx="1">
-                  <c:v>3925</c:v>
-                </c:pt>
-                <c:pt idx="2">
-                  <c:v>6900</c:v>
-                </c:pt>
-                <c:pt idx="3">
-                  <c:v>7851</c:v>
-                </c:pt>
-                <c:pt idx="4">
-                  <c:v>9445</c:v>
-                </c:pt>
-              </c:numCache>
-            </c:numRef>
-          </c:val>
-          <c:smooth val="0"/>
-        </c:ser>
-        <c:ser>
-          <c:idx val="2"/>
-          <c:order val="2"/>
-          <c:tx>
-            <c:strRef>
-              <c:f>Sheet1!$D$1</c:f>
-              <c:strCache>
-                <c:ptCount val="1"/>
-                <c:pt idx="0">
-                  <c:v>Comp.Ceil</c:v>
-                </c:pt>
-              </c:strCache>
-            </c:strRef>
-          </c:tx>
-          <c:spPr>
-            <a:solidFill>
-              <a:srgbClr val="AAAAAA"/>
-            </a:solidFill>
-            <a:ln w="25400" cap="flat">
-              <a:solidFill>
-                <a:srgbClr val="AAAAAA"/>
-              </a:solidFill>
-              <a:prstDash val="solid"/>
-              <a:round/>
-            </a:ln>
-            <a:effectLst/>
-          </c:spPr>
-          <c:invertIfNegative val="0"/>
-          <c:dLbls>
-            <c:numFmt formatCode="#,##0" sourceLinked="0"/>
-            <c:txPr>
-              <a:bodyPr/>
-              <a:lstStyle/>
-              <a:p>
-                <a:pPr>
-                  <a:defRPr b="0" i="0" strike="noStrike" sz="1200" u="none">
-                    <a:solidFill>
-                      <a:srgbClr val="000000"/>
-                    </a:solidFill>
-                    <a:latin typeface="Arial"/>
-                  </a:defRPr>
-                </a:pPr>
-              </a:p>
-            </c:txPr>
-            <c:showLegendKey val="0"/>
-            <c:showVal val="0"/>
-            <c:showCatName val="0"/>
-            <c:showSerName val="0"/>
-            <c:showPercent val="0"/>
-            <c:showBubbleSize val="0"/>
-            <c:showLeaderLines val="0"/>
-          </c:dLbls>
-          <c:marker>
-            <c:symbol val="circle"/>
-            <c:size val="6"/>
-            <c:spPr>
-              <a:solidFill>
-                <a:srgbClr val="AAAAAA"/>
-              </a:solidFill>
-              <a:ln w="9525" cap="flat">
-                <a:solidFill>
-                  <a:srgbClr val="AAAAAA"/>
-                </a:solidFill>
-                <a:prstDash val="solid"/>
-                <a:round/>
-              </a:ln>
-              <a:effectLst/>
-            </c:spPr>
-          </c:marker>
-          <c:cat>
-            <c:multiLvlStrRef>
-              <c:f>Sheet1!$A$2:$A$6</c:f>
-              <c:multiLvlStrCache>
-                <c:ptCount val="5"/>
-                <c:lvl>
-                  <c:pt idx="0">
-                    <c:v>512</c:v>
-                  </c:pt>
-                  <c:pt idx="1">
-                    <c:v>1K</c:v>
-                  </c:pt>
-                  <c:pt idx="2">
-                    <c:v>1.8K</c:v>
-                  </c:pt>
-                  <c:pt idx="3">
-                    <c:v>2K</c:v>
-                  </c:pt>
-                  <c:pt idx="4">
-                    <c:v>4K</c:v>
-                  </c:pt>
-                </c:lvl>
-              </c:multiLvlStrCache>
-            </c:multiLvlStrRef>
-          </c:cat>
-          <c:val>
-            <c:numRef>
-              <c:f>Sheet1!$D$2:$D$6</c:f>
-              <c:numCache>
-                <c:formatCode>General</c:formatCode>
-                <c:ptCount val="5"/>
-                <c:pt idx="0">
-                  <c:v>9445</c:v>
-                </c:pt>
-                <c:pt idx="1">
-                  <c:v>9445</c:v>
-                </c:pt>
-                <c:pt idx="2">
-                  <c:v>9445</c:v>
-                </c:pt>
-                <c:pt idx="3">
-                  <c:v>9445</c:v>
-                </c:pt>
-                <c:pt idx="4">
-                  <c:v>9445</c:v>
-                </c:pt>
-              </c:numCache>
-            </c:numRef>
-          </c:val>
-          <c:smooth val="0"/>
-        </c:ser>
-        <c:dLbls>
-          <c:numFmt formatCode="#,##0" sourceLinked="0"/>
-          <c:txPr>
-            <a:bodyPr/>
-            <a:lstStyle/>
-            <a:p>
-              <a:pPr>
-                <a:defRPr b="0" i="0" strike="noStrike" sz="1200" u="none">
-                  <a:solidFill>
-                    <a:srgbClr val="000000"/>
-                  </a:solidFill>
-                  <a:latin typeface="Arial"/>
-                </a:defRPr>
-              </a:pPr>
-            </a:p>
-          </c:txPr>
-          <c:showLegendKey val="0"/>
-          <c:showVal val="0"/>
-          <c:showCatName val="0"/>
-          <c:showSerName val="0"/>
-          <c:showPercent val="0"/>
-          <c:showBubbleSize val="0"/>
-          <c:showLeaderLines val="0"/>
-        </c:dLbls>
-        <c:marker val="1"/>
-        <c:axId val="2094734554"/>
-        <c:axId val="2094734552"/>
-        <c:axId val="2094734556"/>
-      </c:lineChart>
-      <c:catAx>
-        <c:axId val="2094734554"/>
-        <c:scaling>
-          <c:orientation val="minMax"/>
-        </c:scaling>
-        <c:delete val="0"/>
-        <c:axPos val="b"/>
-        <c:numFmt formatCode="General" sourceLinked="1"/>
-        <c:majorTickMark val="out"/>
-        <c:minorTickMark val="none"/>
-        <c:tickLblPos val="low"/>
-        <c:spPr>
-          <a:ln w="12700" cap="flat">
-            <a:solidFill>
-              <a:srgbClr val="888888"/>
-            </a:solidFill>
-            <a:prstDash val="solid"/>
-            <a:round/>
-          </a:ln>
-        </c:spPr>
-        <c:txPr>
-          <a:bodyPr/>
-          <a:lstStyle/>
-          <a:p>
-            <a:pPr>
-              <a:defRPr sz="700" b="0" i="0" u="none" strike="noStrike">
-                <a:solidFill>
-                  <a:srgbClr val="777777"/>
-                </a:solidFill>
-                <a:latin typeface="Arial"/>
-              </a:defRPr>
-            </a:pPr>
-            <a:endParaRPr lang="en-US"/>
-          </a:p>
-        </c:txPr>
-        <c:crossAx val="2094734552"/>
-        <c:crosses val="autoZero"/>
-        <c:auto val="1"/>
-        <c:lblAlgn val="ctr"/>
-        <c:noMultiLvlLbl val="1"/>
-      </c:catAx>
-      <c:valAx>
-        <c:axId val="2094734552"/>
-        <c:scaling>
-          <c:orientation val="minMax"/>
-          <c:max val="11000"/>
-          <c:min val="0"/>
-        </c:scaling>
-        <c:delete val="0"/>
-        <c:axPos val="l"/>
-        <c:majorGridlines>
-          <c:spPr>
-            <a:ln w="3810" cap="flat">
-              <a:solidFill>
-                <a:srgbClr val="EEEEEE"/>
-              </a:solidFill>
-              <a:prstDash val="solid"/>
-              <a:round/>
-            </a:ln>
-          </c:spPr>
-        </c:majorGridlines>
-        <c:numFmt formatCode="General" sourceLinked="0"/>
-        <c:majorTickMark val="out"/>
-        <c:minorTickMark val="none"/>
-        <c:tickLblPos val="nextTo"/>
-        <c:spPr>
-          <a:ln w="12700" cap="flat">
-            <a:solidFill>
-              <a:srgbClr val="888888"/>
-            </a:solidFill>
-            <a:prstDash val="solid"/>
-            <a:round/>
-          </a:ln>
-        </c:spPr>
-        <c:txPr>
-          <a:bodyPr/>
-          <a:lstStyle/>
-          <a:p>
-            <a:pPr>
-              <a:defRPr sz="700" b="0" i="0" u="none" strike="noStrike">
-                <a:solidFill>
-                  <a:srgbClr val="777777"/>
-                </a:solidFill>
-                <a:latin typeface="Arial"/>
-              </a:defRPr>
-            </a:pPr>
-            <a:endParaRPr lang="en-US"/>
-          </a:p>
-        </c:txPr>
-        <c:crossAx val="2094734554"/>
-        <c:crosses val="autoZero"/>
-        <c:crossBetween val="between"/>
-      </c:valAx>
-      <c:spPr>
-        <a:noFill/>
-        <a:ln>
-          <a:noFill/>
-        </a:ln>
-        <a:effectLst/>
-      </c:spPr>
-    </c:plotArea>
-    <c:legend>
-      <c:legendPos val="b"/>
-      <c:overlay val="0"/>
-      <c:txPr>
-        <a:bodyPr/>
-        <a:lstStyle/>
-        <a:p>
-          <a:pPr>
-            <a:defRPr sz="700">      </a:defRPr>
-          </a:pPr>
-          <a:endParaRPr lang="en-US"/>
-        </a:p>
-      </c:txPr>
-    </c:legend>
-    <c:plotVisOnly val="1"/>
-    <c:dispBlanksAs val="span"/>
-  </c:chart>
-  <c:spPr>
-    <a:solidFill>
-      <a:srgbClr val="FFFFFF"/>
-    </a:solidFill>
-    <a:ln>
-      <a:noFill/>
-    </a:ln>
-    <a:effectLst/>
-  </c:spPr>
-  <c:externalData r:id="rId1">
-    <c:autoUpdate val="0"/>
-  </c:externalData>
-</c:chartSpace>
-</file>
-
-<file path=ppt/charts/chart3.xml><?xml version="1.0" encoding="utf-8"?>
 <c:chartSpace xmlns:c="http://schemas.openxmlformats.org/drawingml/2006/chart" xmlns:a="http://schemas.openxmlformats.org/drawingml/2006/main" xmlns:r="http://schemas.openxmlformats.org/officeDocument/2006/relationships">
   <c:date1904 val="0"/>
   <c:roundedCorners val="1"/>
@@ -2426,7 +1894,7 @@
                 <a:ea typeface="Calibri" pitchFamily="34" charset="-122"/>
                 <a:cs typeface="Calibri" pitchFamily="34" charset="-120"/>
               </a:rPr>
-              <a:t>. Prefill C ≥ 1,024: compute-bound for both; storage upgrade provides no prefill benefit.</a:t>
+              <a:t>. Prefill/TTFT: PCIe6 only helps for C &lt; 559 tokens (IO-bound) — TTFT 54 ms vs 110 ms at L=128; at C≥559 both CPU-bound at 5,052 tok/s ceiling.</a:t>
             </a:r>
             <a:endParaRPr lang="en-US" sz="1050" dirty="0"/>
           </a:p>
@@ -3185,7 +2653,7 @@
                 <a:ea typeface="Calibri" pitchFamily="34" charset="-122"/>
                 <a:cs typeface="Calibri" pitchFamily="34" charset="-120"/>
               </a:rPr>
-              <a:t>IO/layer UFS5.0: </a:t>
+              <a:t>IO/layer PCIe5: </a:t>
             </a:r>
             <a:pPr algn="l" indent="0" marL="0">
               <a:buNone/>
@@ -3193,13 +2661,13 @@
             <a:r>
               <a:rPr lang="en-US" sz="800" b="1" dirty="0">
                 <a:solidFill>
-                  <a:srgbClr val="1A7A3C"/>
+                  <a:srgbClr val="C84B00"/>
                 </a:solidFill>
                 <a:latin typeface="Calibri" pitchFamily="34" charset="0"/>
                 <a:ea typeface="Calibri" pitchFamily="34" charset="-122"/>
                 <a:cs typeface="Calibri" pitchFamily="34" charset="-120"/>
               </a:rPr>
-              <a:t>6×7.08MB/10GB/s = 4.25 ms</a:t>
+              <a:t>6×6.75MB/15.75 GB/s = 2.57 ms</a:t>
             </a:r>
             <a:endParaRPr lang="en-US" sz="800" dirty="0"/>
           </a:p>
@@ -3216,7 +2684,7 @@
                 <a:ea typeface="Calibri" pitchFamily="34" charset="-122"/>
                 <a:cs typeface="Calibri" pitchFamily="34" charset="-120"/>
               </a:rPr>
-              <a:t>IO/layer NVMe 7: </a:t>
+              <a:t>IO/layer PCIe6: </a:t>
             </a:r>
             <a:pPr algn="l" indent="0" marL="0">
               <a:buNone/>
@@ -3224,13 +2692,13 @@
             <a:r>
               <a:rPr lang="en-US" sz="800" b="1" dirty="0">
                 <a:solidFill>
-                  <a:srgbClr val="C84B00"/>
+                  <a:srgbClr val="1A7A3C"/>
                 </a:solidFill>
                 <a:latin typeface="Calibri" pitchFamily="34" charset="0"/>
                 <a:ea typeface="Calibri" pitchFamily="34" charset="-122"/>
                 <a:cs typeface="Calibri" pitchFamily="34" charset="-120"/>
               </a:rPr>
-              <a:t>6×7.08MB/7GB/s  = 6.07 ms</a:t>
+              <a:t>6×6.75MB/32 GB/s    = 1.27 ms</a:t>
             </a:r>
             <a:endParaRPr lang="en-US" sz="800" dirty="0"/>
           </a:p>
@@ -3247,7 +2715,7 @@
                 <a:ea typeface="Calibri" pitchFamily="34" charset="-122"/>
                 <a:cs typeface="Calibri" pitchFamily="34" charset="-120"/>
               </a:rPr>
-              <a:t>Compute/layer (240T, C=2K): </a:t>
+              <a:t>Compute/layer (123T, C=2K): </a:t>
             </a:r>
             <a:pPr algn="l" indent="0" marL="0">
               <a:buNone/>
@@ -3261,7 +2729,7 @@
                 <a:ea typeface="Calibri" pitchFamily="34" charset="-122"/>
                 <a:cs typeface="Calibri" pitchFamily="34" charset="-120"/>
               </a:rPr>
-              <a:t>4.83 ms</a:t>
+              <a:t>9.43 ms  </a:t>
             </a:r>
             <a:pPr algn="l" indent="0" marL="0">
               <a:buNone/>
@@ -3275,7 +2743,7 @@
                 <a:ea typeface="Calibri" pitchFamily="34" charset="-122"/>
                 <a:cs typeface="Calibri" pitchFamily="34" charset="-120"/>
               </a:rPr>
-              <a:t>  [DGX 123T: 9.43 ms]</a:t>
+              <a:t>Crossover: PCIe5≥559, PCIe6≥275 tok</a:t>
             </a:r>
             <a:endParaRPr lang="en-US" sz="800" dirty="0"/>
           </a:p>
@@ -3397,7 +2865,7 @@
                           <a:ea typeface="Calibri" pitchFamily="34" charset="-122"/>
                           <a:cs typeface="Calibri" pitchFamily="34" charset="-120"/>
                         </a:rPr>
-                        <a:t>Compute</a:t>
+                        <a:t>CPU/layer</a:t>
                       </a:r>
                       <a:endParaRPr lang="en-US" sz="800" dirty="0">
                         <a:latin typeface="Calibri" charset="0"/>
@@ -3465,7 +2933,7 @@
                           <a:ea typeface="Calibri" pitchFamily="34" charset="-122"/>
                           <a:cs typeface="Calibri" pitchFamily="34" charset="-120"/>
                         </a:rPr>
-                        <a:t>UFS5 TPS</a:t>
+                        <a:t>PCIe5 TPS</a:t>
                       </a:r>
                       <a:endParaRPr lang="en-US" sz="800" dirty="0">
                         <a:latin typeface="Calibri" charset="0"/>
@@ -3601,7 +3069,7 @@
                           <a:ea typeface="Calibri" pitchFamily="34" charset="-122"/>
                           <a:cs typeface="Calibri" pitchFamily="34" charset="-120"/>
                         </a:rPr>
-                        <a:t>NVMe TPS</a:t>
+                        <a:t>PCIe6 TPS</a:t>
                       </a:r>
                       <a:endParaRPr lang="en-US" sz="800" dirty="0">
                         <a:latin typeface="Calibri" charset="0"/>
@@ -3739,7 +3207,7 @@
                           <a:ea typeface="Calibri" pitchFamily="34" charset="-122"/>
                           <a:cs typeface="Calibri" pitchFamily="34" charset="-120"/>
                         </a:rPr>
-                        <a:t>512</a:t>
+                        <a:t>128</a:t>
                       </a:r>
                       <a:endParaRPr lang="en-US" sz="800" dirty="0">
                         <a:latin typeface="Calibri" charset="0"/>
@@ -3807,7 +3275,7 @@
                           <a:ea typeface="Calibri" pitchFamily="34" charset="-122"/>
                           <a:cs typeface="Calibri" pitchFamily="34" charset="-120"/>
                         </a:rPr>
-                        <a:t>1.21ms</a:t>
+                        <a:t>0.59ms</a:t>
                       </a:r>
                       <a:endParaRPr lang="en-US" sz="800" dirty="0">
                         <a:latin typeface="Calibri" charset="0"/>
@@ -3875,7 +3343,7 @@
                           <a:ea typeface="Calibri" pitchFamily="34" charset="-122"/>
                           <a:cs typeface="Calibri" pitchFamily="34" charset="-120"/>
                         </a:rPr>
-                        <a:t>2,804</a:t>
+                        <a:t>1,158</a:t>
                       </a:r>
                       <a:endParaRPr lang="en-US" sz="800" dirty="0">
                         <a:latin typeface="Calibri" charset="0"/>
@@ -4011,7 +3479,7 @@
                           <a:ea typeface="Calibri" pitchFamily="34" charset="-122"/>
                           <a:cs typeface="Calibri" pitchFamily="34" charset="-120"/>
                         </a:rPr>
-                        <a:t>1,963</a:t>
+                        <a:t>2,352</a:t>
                       </a:r>
                       <a:endParaRPr lang="en-US" sz="800" dirty="0">
                         <a:latin typeface="Calibri" charset="0"/>
@@ -4141,15 +3609,15 @@
                         <a:buNone/>
                       </a:pPr>
                       <a:r>
-                        <a:rPr lang="en-US" sz="800" dirty="0">
-                          <a:solidFill>
-                            <a:srgbClr val="555555"/>
-                          </a:solidFill>
-                          <a:latin typeface="Calibri" pitchFamily="34" charset="0"/>
-                          <a:ea typeface="Calibri" pitchFamily="34" charset="-122"/>
-                          <a:cs typeface="Calibri" pitchFamily="34" charset="-120"/>
-                        </a:rPr>
-                        <a:t>1,024</a:t>
+                        <a:rPr lang="en-US" sz="800" b="1" dirty="0">
+                          <a:solidFill>
+                            <a:srgbClr val="1A7A3C"/>
+                          </a:solidFill>
+                          <a:latin typeface="Calibri" pitchFamily="34" charset="0"/>
+                          <a:ea typeface="Calibri" pitchFamily="34" charset="-122"/>
+                          <a:cs typeface="Calibri" pitchFamily="34" charset="-120"/>
+                        </a:rPr>
+                        <a:t>275★</a:t>
                       </a:r>
                       <a:endParaRPr lang="en-US" sz="800" dirty="0">
                         <a:latin typeface="Calibri" charset="0"/>
@@ -4196,7 +3664,7 @@
                       <a:tailEnd type="none" w="med" len="med"/>
                     </a:lnB>
                     <a:solidFill>
-                      <a:srgbClr val="FFFFFF"/>
+                      <a:srgbClr val="E8F4FF"/>
                     </a:solidFill>
                   </a:tcPr>
                 </a:tc>
@@ -4209,15 +3677,15 @@
                         <a:buNone/>
                       </a:pPr>
                       <a:r>
-                        <a:rPr lang="en-US" sz="800" dirty="0">
-                          <a:solidFill>
-                            <a:srgbClr val="555555"/>
-                          </a:solidFill>
-                          <a:latin typeface="Calibri" pitchFamily="34" charset="0"/>
-                          <a:ea typeface="Calibri" pitchFamily="34" charset="-122"/>
-                          <a:cs typeface="Calibri" pitchFamily="34" charset="-120"/>
-                        </a:rPr>
-                        <a:t>2.42ms</a:t>
+                        <a:rPr lang="en-US" sz="800" b="1" dirty="0">
+                          <a:solidFill>
+                            <a:srgbClr val="1A7A3C"/>
+                          </a:solidFill>
+                          <a:latin typeface="Calibri" pitchFamily="34" charset="0"/>
+                          <a:ea typeface="Calibri" pitchFamily="34" charset="-122"/>
+                          <a:cs typeface="Calibri" pitchFamily="34" charset="-120"/>
+                        </a:rPr>
+                        <a:t>1.27ms</a:t>
                       </a:r>
                       <a:endParaRPr lang="en-US" sz="800" dirty="0">
                         <a:latin typeface="Calibri" charset="0"/>
@@ -4264,7 +3732,7 @@
                       <a:tailEnd type="none" w="med" len="med"/>
                     </a:lnB>
                     <a:solidFill>
-                      <a:srgbClr val="FFFFFF"/>
+                      <a:srgbClr val="E8F4FF"/>
                     </a:solidFill>
                   </a:tcPr>
                 </a:tc>
@@ -4285,7 +3753,7 @@
                           <a:ea typeface="Calibri" pitchFamily="34" charset="-122"/>
                           <a:cs typeface="Calibri" pitchFamily="34" charset="-120"/>
                         </a:rPr>
-                        <a:t>5,608</a:t>
+                        <a:t>2,488</a:t>
                       </a:r>
                       <a:endParaRPr lang="en-US" sz="800" dirty="0">
                         <a:latin typeface="Calibri" charset="0"/>
@@ -4332,7 +3800,7 @@
                       <a:tailEnd type="none" w="med" len="med"/>
                     </a:lnB>
                     <a:solidFill>
-                      <a:srgbClr val="FFFFFF"/>
+                      <a:srgbClr val="E8F4FF"/>
                     </a:solidFill>
                   </a:tcPr>
                 </a:tc>
@@ -4400,7 +3868,7 @@
                       <a:tailEnd type="none" w="med" len="med"/>
                     </a:lnB>
                     <a:solidFill>
-                      <a:srgbClr val="FFFFFF"/>
+                      <a:srgbClr val="E8F4FF"/>
                     </a:solidFill>
                   </a:tcPr>
                 </a:tc>
@@ -4415,13 +3883,13 @@
                       <a:r>
                         <a:rPr lang="en-US" sz="800" b="1" dirty="0">
                           <a:solidFill>
-                            <a:srgbClr val="C84B00"/>
-                          </a:solidFill>
-                          <a:latin typeface="Calibri" pitchFamily="34" charset="0"/>
-                          <a:ea typeface="Calibri" pitchFamily="34" charset="-122"/>
-                          <a:cs typeface="Calibri" pitchFamily="34" charset="-120"/>
-                        </a:rPr>
-                        <a:t>3,925</a:t>
+                            <a:srgbClr val="1A7A3C"/>
+                          </a:solidFill>
+                          <a:latin typeface="Calibri" pitchFamily="34" charset="0"/>
+                          <a:ea typeface="Calibri" pitchFamily="34" charset="-122"/>
+                          <a:cs typeface="Calibri" pitchFamily="34" charset="-120"/>
+                        </a:rPr>
+                        <a:t>5,052</a:t>
                       </a:r>
                       <a:endParaRPr lang="en-US" sz="800" dirty="0">
                         <a:latin typeface="Calibri" charset="0"/>
@@ -4468,7 +3936,7 @@
                       <a:tailEnd type="none" w="med" len="med"/>
                     </a:lnB>
                     <a:solidFill>
-                      <a:srgbClr val="FFFFFF"/>
+                      <a:srgbClr val="E8F4FF"/>
                     </a:solidFill>
                   </a:tcPr>
                 </a:tc>
@@ -4483,13 +3951,13 @@
                       <a:r>
                         <a:rPr lang="en-US" sz="800" b="1" dirty="0">
                           <a:solidFill>
-                            <a:srgbClr val="C84B00"/>
-                          </a:solidFill>
-                          <a:latin typeface="Calibri" pitchFamily="34" charset="0"/>
-                          <a:ea typeface="Calibri" pitchFamily="34" charset="-122"/>
-                          <a:cs typeface="Calibri" pitchFamily="34" charset="-120"/>
-                        </a:rPr>
-                        <a:t>IO✗</a:t>
+                            <a:srgbClr val="1A7A3C"/>
+                          </a:solidFill>
+                          <a:latin typeface="Calibri" pitchFamily="34" charset="0"/>
+                          <a:ea typeface="Calibri" pitchFamily="34" charset="-122"/>
+                          <a:cs typeface="Calibri" pitchFamily="34" charset="-120"/>
+                        </a:rPr>
+                        <a:t>cross✓</a:t>
                       </a:r>
                       <a:endParaRPr lang="en-US" sz="800" dirty="0">
                         <a:latin typeface="Calibri" charset="0"/>
@@ -4536,7 +4004,7 @@
                       <a:tailEnd type="none" w="med" len="med"/>
                     </a:lnB>
                     <a:solidFill>
-                      <a:srgbClr val="FFFFFF"/>
+                      <a:srgbClr val="E8F4FF"/>
                     </a:solidFill>
                   </a:tcPr>
                 </a:tc>
@@ -4551,15 +4019,151 @@
                         <a:buNone/>
                       </a:pPr>
                       <a:r>
+                        <a:rPr lang="en-US" sz="800" dirty="0">
+                          <a:solidFill>
+                            <a:srgbClr val="555555"/>
+                          </a:solidFill>
+                          <a:latin typeface="Calibri" pitchFamily="34" charset="0"/>
+                          <a:ea typeface="Calibri" pitchFamily="34" charset="-122"/>
+                          <a:cs typeface="Calibri" pitchFamily="34" charset="-120"/>
+                        </a:rPr>
+                        <a:t>512</a:t>
+                      </a:r>
+                      <a:endParaRPr lang="en-US" sz="800" dirty="0">
+                        <a:latin typeface="Calibri" charset="0"/>
+                        <a:ea typeface="Calibri" charset="0"/>
+                        <a:cs typeface="Calibri" charset="0"/>
+                      </a:endParaRPr>
+                    </a:p>
+                  </a:txBody>
+                  <a:tcPr marL="91440" marR="91440" marT="45720" marB="45720">
+                    <a:lnL w="6350" cap="flat" cmpd="sng" algn="ctr">
+                      <a:solidFill>
+                        <a:srgbClr val="BFCFE8"/>
+                      </a:solidFill>
+                      <a:prstDash val="solid"/>
+                      <a:round/>
+                      <a:headEnd type="none" w="med" len="med"/>
+                      <a:tailEnd type="none" w="med" len="med"/>
+                    </a:lnL>
+                    <a:lnR w="6350" cap="flat" cmpd="sng" algn="ctr">
+                      <a:solidFill>
+                        <a:srgbClr val="BFCFE8"/>
+                      </a:solidFill>
+                      <a:prstDash val="solid"/>
+                      <a:round/>
+                      <a:headEnd type="none" w="med" len="med"/>
+                      <a:tailEnd type="none" w="med" len="med"/>
+                    </a:lnR>
+                    <a:lnT w="6350" cap="flat" cmpd="sng" algn="ctr">
+                      <a:solidFill>
+                        <a:srgbClr val="BFCFE8"/>
+                      </a:solidFill>
+                      <a:prstDash val="solid"/>
+                      <a:round/>
+                      <a:headEnd type="none" w="med" len="med"/>
+                      <a:tailEnd type="none" w="med" len="med"/>
+                    </a:lnT>
+                    <a:lnB w="6350" cap="flat" cmpd="sng" algn="ctr">
+                      <a:solidFill>
+                        <a:srgbClr val="BFCFE8"/>
+                      </a:solidFill>
+                      <a:prstDash val="solid"/>
+                      <a:round/>
+                      <a:headEnd type="none" w="med" len="med"/>
+                      <a:tailEnd type="none" w="med" len="med"/>
+                    </a:lnB>
+                    <a:solidFill>
+                      <a:srgbClr val="FFFFFF"/>
+                    </a:solidFill>
+                  </a:tcPr>
+                </a:tc>
+                <a:tc>
+                  <a:txBody>
+                    <a:bodyPr/>
+                    <a:lstStyle/>
+                    <a:p>
+                      <a:pPr algn="ctr" indent="0" marL="0">
+                        <a:buNone/>
+                      </a:pPr>
+                      <a:r>
+                        <a:rPr lang="en-US" sz="800" dirty="0">
+                          <a:solidFill>
+                            <a:srgbClr val="555555"/>
+                          </a:solidFill>
+                          <a:latin typeface="Calibri" pitchFamily="34" charset="0"/>
+                          <a:ea typeface="Calibri" pitchFamily="34" charset="-122"/>
+                          <a:cs typeface="Calibri" pitchFamily="34" charset="-120"/>
+                        </a:rPr>
+                        <a:t>2.36ms</a:t>
+                      </a:r>
+                      <a:endParaRPr lang="en-US" sz="800" dirty="0">
+                        <a:latin typeface="Calibri" charset="0"/>
+                        <a:ea typeface="Calibri" charset="0"/>
+                        <a:cs typeface="Calibri" charset="0"/>
+                      </a:endParaRPr>
+                    </a:p>
+                  </a:txBody>
+                  <a:tcPr marL="91440" marR="91440" marT="45720" marB="45720">
+                    <a:lnL w="6350" cap="flat" cmpd="sng" algn="ctr">
+                      <a:solidFill>
+                        <a:srgbClr val="BFCFE8"/>
+                      </a:solidFill>
+                      <a:prstDash val="solid"/>
+                      <a:round/>
+                      <a:headEnd type="none" w="med" len="med"/>
+                      <a:tailEnd type="none" w="med" len="med"/>
+                    </a:lnL>
+                    <a:lnR w="6350" cap="flat" cmpd="sng" algn="ctr">
+                      <a:solidFill>
+                        <a:srgbClr val="BFCFE8"/>
+                      </a:solidFill>
+                      <a:prstDash val="solid"/>
+                      <a:round/>
+                      <a:headEnd type="none" w="med" len="med"/>
+                      <a:tailEnd type="none" w="med" len="med"/>
+                    </a:lnR>
+                    <a:lnT w="6350" cap="flat" cmpd="sng" algn="ctr">
+                      <a:solidFill>
+                        <a:srgbClr val="BFCFE8"/>
+                      </a:solidFill>
+                      <a:prstDash val="solid"/>
+                      <a:round/>
+                      <a:headEnd type="none" w="med" len="med"/>
+                      <a:tailEnd type="none" w="med" len="med"/>
+                    </a:lnT>
+                    <a:lnB w="6350" cap="flat" cmpd="sng" algn="ctr">
+                      <a:solidFill>
+                        <a:srgbClr val="BFCFE8"/>
+                      </a:solidFill>
+                      <a:prstDash val="solid"/>
+                      <a:round/>
+                      <a:headEnd type="none" w="med" len="med"/>
+                      <a:tailEnd type="none" w="med" len="med"/>
+                    </a:lnB>
+                    <a:solidFill>
+                      <a:srgbClr val="FFFFFF"/>
+                    </a:solidFill>
+                  </a:tcPr>
+                </a:tc>
+                <a:tc>
+                  <a:txBody>
+                    <a:bodyPr/>
+                    <a:lstStyle/>
+                    <a:p>
+                      <a:pPr algn="ctr" indent="0" marL="0">
+                        <a:buNone/>
+                      </a:pPr>
+                      <a:r>
                         <a:rPr lang="en-US" sz="800" b="1" dirty="0">
                           <a:solidFill>
-                            <a:srgbClr val="2458A4"/>
-                          </a:solidFill>
-                          <a:latin typeface="Calibri" pitchFamily="34" charset="0"/>
-                          <a:ea typeface="Calibri" pitchFamily="34" charset="-122"/>
-                          <a:cs typeface="Calibri" pitchFamily="34" charset="-120"/>
-                        </a:rPr>
-                        <a:t>1,800★</a:t>
+                            <a:srgbClr val="C84B00"/>
+                          </a:solidFill>
+                          <a:latin typeface="Calibri" pitchFamily="34" charset="0"/>
+                          <a:ea typeface="Calibri" pitchFamily="34" charset="-122"/>
+                          <a:cs typeface="Calibri" pitchFamily="34" charset="-120"/>
+                        </a:rPr>
+                        <a:t>4,631</a:t>
                       </a:r>
                       <a:endParaRPr lang="en-US" sz="800" dirty="0">
                         <a:latin typeface="Calibri" charset="0"/>
@@ -4606,7 +4210,7 @@
                       <a:tailEnd type="none" w="med" len="med"/>
                     </a:lnB>
                     <a:solidFill>
-                      <a:srgbClr val="FFF4CC"/>
+                      <a:srgbClr val="FFFFFF"/>
                     </a:solidFill>
                   </a:tcPr>
                 </a:tc>
@@ -4621,13 +4225,13 @@
                       <a:r>
                         <a:rPr lang="en-US" sz="800" b="1" dirty="0">
                           <a:solidFill>
-                            <a:srgbClr val="2458A4"/>
-                          </a:solidFill>
-                          <a:latin typeface="Calibri" pitchFamily="34" charset="0"/>
-                          <a:ea typeface="Calibri" pitchFamily="34" charset="-122"/>
-                          <a:cs typeface="Calibri" pitchFamily="34" charset="-120"/>
-                        </a:rPr>
-                        <a:t>4.25ms</a:t>
+                            <a:srgbClr val="C84B00"/>
+                          </a:solidFill>
+                          <a:latin typeface="Calibri" pitchFamily="34" charset="0"/>
+                          <a:ea typeface="Calibri" pitchFamily="34" charset="-122"/>
+                          <a:cs typeface="Calibri" pitchFamily="34" charset="-120"/>
+                        </a:rPr>
+                        <a:t>IO✗</a:t>
                       </a:r>
                       <a:endParaRPr lang="en-US" sz="800" dirty="0">
                         <a:latin typeface="Calibri" charset="0"/>
@@ -4674,7 +4278,7 @@
                       <a:tailEnd type="none" w="med" len="med"/>
                     </a:lnB>
                     <a:solidFill>
-                      <a:srgbClr val="FFF4CC"/>
+                      <a:srgbClr val="FFFFFF"/>
                     </a:solidFill>
                   </a:tcPr>
                 </a:tc>
@@ -4695,7 +4299,7 @@
                           <a:ea typeface="Calibri" pitchFamily="34" charset="-122"/>
                           <a:cs typeface="Calibri" pitchFamily="34" charset="-120"/>
                         </a:rPr>
-                        <a:t>9,445</a:t>
+                        <a:t>5,052</a:t>
                       </a:r>
                       <a:endParaRPr lang="en-US" sz="800" dirty="0">
                         <a:latin typeface="Calibri" charset="0"/>
@@ -4742,7 +4346,7 @@
                       <a:tailEnd type="none" w="med" len="med"/>
                     </a:lnB>
                     <a:solidFill>
-                      <a:srgbClr val="FFF4CC"/>
+                      <a:srgbClr val="FFFFFF"/>
                     </a:solidFill>
                   </a:tcPr>
                 </a:tc>
@@ -4757,13 +4361,13 @@
                       <a:r>
                         <a:rPr lang="en-US" sz="800" b="1" dirty="0">
                           <a:solidFill>
-                            <a:srgbClr val="2458A4"/>
-                          </a:solidFill>
-                          <a:latin typeface="Calibri" pitchFamily="34" charset="0"/>
-                          <a:ea typeface="Calibri" pitchFamily="34" charset="-122"/>
-                          <a:cs typeface="Calibri" pitchFamily="34" charset="-120"/>
-                        </a:rPr>
-                        <a:t>cross</a:t>
+                            <a:srgbClr val="1A7A3C"/>
+                          </a:solidFill>
+                          <a:latin typeface="Calibri" pitchFamily="34" charset="0"/>
+                          <a:ea typeface="Calibri" pitchFamily="34" charset="-122"/>
+                          <a:cs typeface="Calibri" pitchFamily="34" charset="-120"/>
+                        </a:rPr>
+                        <a:t>CPU✓</a:t>
                       </a:r>
                       <a:endParaRPr lang="en-US" sz="800" dirty="0">
                         <a:latin typeface="Calibri" charset="0"/>
@@ -4810,143 +4414,7 @@
                       <a:tailEnd type="none" w="med" len="med"/>
                     </a:lnB>
                     <a:solidFill>
-                      <a:srgbClr val="FFF4CC"/>
-                    </a:solidFill>
-                  </a:tcPr>
-                </a:tc>
-                <a:tc>
-                  <a:txBody>
-                    <a:bodyPr/>
-                    <a:lstStyle/>
-                    <a:p>
-                      <a:pPr algn="ctr" indent="0" marL="0">
-                        <a:buNone/>
-                      </a:pPr>
-                      <a:r>
-                        <a:rPr lang="en-US" sz="800" b="1" dirty="0">
-                          <a:solidFill>
-                            <a:srgbClr val="C84B00"/>
-                          </a:solidFill>
-                          <a:latin typeface="Calibri" pitchFamily="34" charset="0"/>
-                          <a:ea typeface="Calibri" pitchFamily="34" charset="-122"/>
-                          <a:cs typeface="Calibri" pitchFamily="34" charset="-120"/>
-                        </a:rPr>
-                        <a:t>6,900</a:t>
-                      </a:r>
-                      <a:endParaRPr lang="en-US" sz="800" dirty="0">
-                        <a:latin typeface="Calibri" charset="0"/>
-                        <a:ea typeface="Calibri" charset="0"/>
-                        <a:cs typeface="Calibri" charset="0"/>
-                      </a:endParaRPr>
-                    </a:p>
-                  </a:txBody>
-                  <a:tcPr marL="91440" marR="91440" marT="45720" marB="45720">
-                    <a:lnL w="6350" cap="flat" cmpd="sng" algn="ctr">
-                      <a:solidFill>
-                        <a:srgbClr val="BFCFE8"/>
-                      </a:solidFill>
-                      <a:prstDash val="solid"/>
-                      <a:round/>
-                      <a:headEnd type="none" w="med" len="med"/>
-                      <a:tailEnd type="none" w="med" len="med"/>
-                    </a:lnL>
-                    <a:lnR w="6350" cap="flat" cmpd="sng" algn="ctr">
-                      <a:solidFill>
-                        <a:srgbClr val="BFCFE8"/>
-                      </a:solidFill>
-                      <a:prstDash val="solid"/>
-                      <a:round/>
-                      <a:headEnd type="none" w="med" len="med"/>
-                      <a:tailEnd type="none" w="med" len="med"/>
-                    </a:lnR>
-                    <a:lnT w="6350" cap="flat" cmpd="sng" algn="ctr">
-                      <a:solidFill>
-                        <a:srgbClr val="BFCFE8"/>
-                      </a:solidFill>
-                      <a:prstDash val="solid"/>
-                      <a:round/>
-                      <a:headEnd type="none" w="med" len="med"/>
-                      <a:tailEnd type="none" w="med" len="med"/>
-                    </a:lnT>
-                    <a:lnB w="6350" cap="flat" cmpd="sng" algn="ctr">
-                      <a:solidFill>
-                        <a:srgbClr val="BFCFE8"/>
-                      </a:solidFill>
-                      <a:prstDash val="solid"/>
-                      <a:round/>
-                      <a:headEnd type="none" w="med" len="med"/>
-                      <a:tailEnd type="none" w="med" len="med"/>
-                    </a:lnB>
-                    <a:solidFill>
-                      <a:srgbClr val="FFF4CC"/>
-                    </a:solidFill>
-                  </a:tcPr>
-                </a:tc>
-                <a:tc>
-                  <a:txBody>
-                    <a:bodyPr/>
-                    <a:lstStyle/>
-                    <a:p>
-                      <a:pPr algn="ctr" indent="0" marL="0">
-                        <a:buNone/>
-                      </a:pPr>
-                      <a:r>
-                        <a:rPr lang="en-US" sz="800" b="1" dirty="0">
-                          <a:solidFill>
-                            <a:srgbClr val="C84B00"/>
-                          </a:solidFill>
-                          <a:latin typeface="Calibri" pitchFamily="34" charset="0"/>
-                          <a:ea typeface="Calibri" pitchFamily="34" charset="-122"/>
-                          <a:cs typeface="Calibri" pitchFamily="34" charset="-120"/>
-                        </a:rPr>
-                        <a:t>IO✗</a:t>
-                      </a:r>
-                      <a:endParaRPr lang="en-US" sz="800" dirty="0">
-                        <a:latin typeface="Calibri" charset="0"/>
-                        <a:ea typeface="Calibri" charset="0"/>
-                        <a:cs typeface="Calibri" charset="0"/>
-                      </a:endParaRPr>
-                    </a:p>
-                  </a:txBody>
-                  <a:tcPr marL="91440" marR="91440" marT="45720" marB="45720">
-                    <a:lnL w="6350" cap="flat" cmpd="sng" algn="ctr">
-                      <a:solidFill>
-                        <a:srgbClr val="BFCFE8"/>
-                      </a:solidFill>
-                      <a:prstDash val="solid"/>
-                      <a:round/>
-                      <a:headEnd type="none" w="med" len="med"/>
-                      <a:tailEnd type="none" w="med" len="med"/>
-                    </a:lnL>
-                    <a:lnR w="6350" cap="flat" cmpd="sng" algn="ctr">
-                      <a:solidFill>
-                        <a:srgbClr val="BFCFE8"/>
-                      </a:solidFill>
-                      <a:prstDash val="solid"/>
-                      <a:round/>
-                      <a:headEnd type="none" w="med" len="med"/>
-                      <a:tailEnd type="none" w="med" len="med"/>
-                    </a:lnR>
-                    <a:lnT w="6350" cap="flat" cmpd="sng" algn="ctr">
-                      <a:solidFill>
-                        <a:srgbClr val="BFCFE8"/>
-                      </a:solidFill>
-                      <a:prstDash val="solid"/>
-                      <a:round/>
-                      <a:headEnd type="none" w="med" len="med"/>
-                      <a:tailEnd type="none" w="med" len="med"/>
-                    </a:lnT>
-                    <a:lnB w="6350" cap="flat" cmpd="sng" algn="ctr">
-                      <a:solidFill>
-                        <a:srgbClr val="BFCFE8"/>
-                      </a:solidFill>
-                      <a:prstDash val="solid"/>
-                      <a:round/>
-                      <a:headEnd type="none" w="med" len="med"/>
-                      <a:tailEnd type="none" w="med" len="med"/>
-                    </a:lnB>
-                    <a:solidFill>
-                      <a:srgbClr val="FFF4CC"/>
+                      <a:srgbClr val="FFFFFF"/>
                     </a:solidFill>
                   </a:tcPr>
                 </a:tc>
@@ -4963,13 +4431,13 @@
                       <a:r>
                         <a:rPr lang="en-US" sz="800" b="1" dirty="0">
                           <a:solidFill>
-                            <a:srgbClr val="1B2A4A"/>
-                          </a:solidFill>
-                          <a:latin typeface="Calibri" pitchFamily="34" charset="0"/>
-                          <a:ea typeface="Calibri" pitchFamily="34" charset="-122"/>
-                          <a:cs typeface="Calibri" pitchFamily="34" charset="-120"/>
-                        </a:rPr>
-                        <a:t>2,048▶</a:t>
+                            <a:srgbClr val="C84B00"/>
+                          </a:solidFill>
+                          <a:latin typeface="Calibri" pitchFamily="34" charset="0"/>
+                          <a:ea typeface="Calibri" pitchFamily="34" charset="-122"/>
+                          <a:cs typeface="Calibri" pitchFamily="34" charset="-120"/>
+                        </a:rPr>
+                        <a:t>559★</a:t>
                       </a:r>
                       <a:endParaRPr lang="en-US" sz="800" dirty="0">
                         <a:latin typeface="Calibri" charset="0"/>
@@ -5016,7 +4484,7 @@
                       <a:tailEnd type="none" w="med" len="med"/>
                     </a:lnB>
                     <a:solidFill>
-                      <a:srgbClr val="DCF0E4"/>
+                      <a:srgbClr val="FFF4CC"/>
                     </a:solidFill>
                   </a:tcPr>
                 </a:tc>
@@ -5031,13 +4499,13 @@
                       <a:r>
                         <a:rPr lang="en-US" sz="800" b="1" dirty="0">
                           <a:solidFill>
-                            <a:srgbClr val="1B2A4A"/>
-                          </a:solidFill>
-                          <a:latin typeface="Calibri" pitchFamily="34" charset="0"/>
-                          <a:ea typeface="Calibri" pitchFamily="34" charset="-122"/>
-                          <a:cs typeface="Calibri" pitchFamily="34" charset="-120"/>
-                        </a:rPr>
-                        <a:t>4.83ms</a:t>
+                            <a:srgbClr val="C84B00"/>
+                          </a:solidFill>
+                          <a:latin typeface="Calibri" pitchFamily="34" charset="0"/>
+                          <a:ea typeface="Calibri" pitchFamily="34" charset="-122"/>
+                          <a:cs typeface="Calibri" pitchFamily="34" charset="-120"/>
+                        </a:rPr>
+                        <a:t>2.57ms</a:t>
                       </a:r>
                       <a:endParaRPr lang="en-US" sz="800" dirty="0">
                         <a:latin typeface="Calibri" charset="0"/>
@@ -5084,7 +4552,7 @@
                       <a:tailEnd type="none" w="med" len="med"/>
                     </a:lnB>
                     <a:solidFill>
-                      <a:srgbClr val="DCF0E4"/>
+                      <a:srgbClr val="FFF4CC"/>
                     </a:solidFill>
                   </a:tcPr>
                 </a:tc>
@@ -5099,13 +4567,13 @@
                       <a:r>
                         <a:rPr lang="en-US" sz="800" b="1" dirty="0">
                           <a:solidFill>
-                            <a:srgbClr val="8A6200"/>
-                          </a:solidFill>
-                          <a:latin typeface="Calibri" pitchFamily="34" charset="0"/>
-                          <a:ea typeface="Calibri" pitchFamily="34" charset="-122"/>
-                          <a:cs typeface="Calibri" pitchFamily="34" charset="-120"/>
-                        </a:rPr>
-                        <a:t>7,700✓</a:t>
+                            <a:srgbClr val="1A7A3C"/>
+                          </a:solidFill>
+                          <a:latin typeface="Calibri" pitchFamily="34" charset="0"/>
+                          <a:ea typeface="Calibri" pitchFamily="34" charset="-122"/>
+                          <a:cs typeface="Calibri" pitchFamily="34" charset="-120"/>
+                        </a:rPr>
+                        <a:t>5,052</a:t>
                       </a:r>
                       <a:endParaRPr lang="en-US" sz="800" dirty="0">
                         <a:latin typeface="Calibri" charset="0"/>
@@ -5152,7 +4620,7 @@
                       <a:tailEnd type="none" w="med" len="med"/>
                     </a:lnB>
                     <a:solidFill>
-                      <a:srgbClr val="DCF0E4"/>
+                      <a:srgbClr val="FFF4CC"/>
                     </a:solidFill>
                   </a:tcPr>
                 </a:tc>
@@ -5167,12 +4635,148 @@
                       <a:r>
                         <a:rPr lang="en-US" sz="800" b="1" dirty="0">
                           <a:solidFill>
+                            <a:srgbClr val="C84B00"/>
+                          </a:solidFill>
+                          <a:latin typeface="Calibri" pitchFamily="34" charset="0"/>
+                          <a:ea typeface="Calibri" pitchFamily="34" charset="-122"/>
+                          <a:cs typeface="Calibri" pitchFamily="34" charset="-120"/>
+                        </a:rPr>
+                        <a:t>cross✓</a:t>
+                      </a:r>
+                      <a:endParaRPr lang="en-US" sz="800" dirty="0">
+                        <a:latin typeface="Calibri" charset="0"/>
+                        <a:ea typeface="Calibri" charset="0"/>
+                        <a:cs typeface="Calibri" charset="0"/>
+                      </a:endParaRPr>
+                    </a:p>
+                  </a:txBody>
+                  <a:tcPr marL="91440" marR="91440" marT="45720" marB="45720">
+                    <a:lnL w="6350" cap="flat" cmpd="sng" algn="ctr">
+                      <a:solidFill>
+                        <a:srgbClr val="BFCFE8"/>
+                      </a:solidFill>
+                      <a:prstDash val="solid"/>
+                      <a:round/>
+                      <a:headEnd type="none" w="med" len="med"/>
+                      <a:tailEnd type="none" w="med" len="med"/>
+                    </a:lnL>
+                    <a:lnR w="6350" cap="flat" cmpd="sng" algn="ctr">
+                      <a:solidFill>
+                        <a:srgbClr val="BFCFE8"/>
+                      </a:solidFill>
+                      <a:prstDash val="solid"/>
+                      <a:round/>
+                      <a:headEnd type="none" w="med" len="med"/>
+                      <a:tailEnd type="none" w="med" len="med"/>
+                    </a:lnR>
+                    <a:lnT w="6350" cap="flat" cmpd="sng" algn="ctr">
+                      <a:solidFill>
+                        <a:srgbClr val="BFCFE8"/>
+                      </a:solidFill>
+                      <a:prstDash val="solid"/>
+                      <a:round/>
+                      <a:headEnd type="none" w="med" len="med"/>
+                      <a:tailEnd type="none" w="med" len="med"/>
+                    </a:lnT>
+                    <a:lnB w="6350" cap="flat" cmpd="sng" algn="ctr">
+                      <a:solidFill>
+                        <a:srgbClr val="BFCFE8"/>
+                      </a:solidFill>
+                      <a:prstDash val="solid"/>
+                      <a:round/>
+                      <a:headEnd type="none" w="med" len="med"/>
+                      <a:tailEnd type="none" w="med" len="med"/>
+                    </a:lnB>
+                    <a:solidFill>
+                      <a:srgbClr val="FFF4CC"/>
+                    </a:solidFill>
+                  </a:tcPr>
+                </a:tc>
+                <a:tc>
+                  <a:txBody>
+                    <a:bodyPr/>
+                    <a:lstStyle/>
+                    <a:p>
+                      <a:pPr algn="ctr" indent="0" marL="0">
+                        <a:buNone/>
+                      </a:pPr>
+                      <a:r>
+                        <a:rPr lang="en-US" sz="800" b="1" dirty="0">
+                          <a:solidFill>
                             <a:srgbClr val="1A7A3C"/>
                           </a:solidFill>
                           <a:latin typeface="Calibri" pitchFamily="34" charset="0"/>
                           <a:ea typeface="Calibri" pitchFamily="34" charset="-122"/>
                           <a:cs typeface="Calibri" pitchFamily="34" charset="-120"/>
                         </a:rPr>
+                        <a:t>5,052</a:t>
+                      </a:r>
+                      <a:endParaRPr lang="en-US" sz="800" dirty="0">
+                        <a:latin typeface="Calibri" charset="0"/>
+                        <a:ea typeface="Calibri" charset="0"/>
+                        <a:cs typeface="Calibri" charset="0"/>
+                      </a:endParaRPr>
+                    </a:p>
+                  </a:txBody>
+                  <a:tcPr marL="91440" marR="91440" marT="45720" marB="45720">
+                    <a:lnL w="6350" cap="flat" cmpd="sng" algn="ctr">
+                      <a:solidFill>
+                        <a:srgbClr val="BFCFE8"/>
+                      </a:solidFill>
+                      <a:prstDash val="solid"/>
+                      <a:round/>
+                      <a:headEnd type="none" w="med" len="med"/>
+                      <a:tailEnd type="none" w="med" len="med"/>
+                    </a:lnL>
+                    <a:lnR w="6350" cap="flat" cmpd="sng" algn="ctr">
+                      <a:solidFill>
+                        <a:srgbClr val="BFCFE8"/>
+                      </a:solidFill>
+                      <a:prstDash val="solid"/>
+                      <a:round/>
+                      <a:headEnd type="none" w="med" len="med"/>
+                      <a:tailEnd type="none" w="med" len="med"/>
+                    </a:lnR>
+                    <a:lnT w="6350" cap="flat" cmpd="sng" algn="ctr">
+                      <a:solidFill>
+                        <a:srgbClr val="BFCFE8"/>
+                      </a:solidFill>
+                      <a:prstDash val="solid"/>
+                      <a:round/>
+                      <a:headEnd type="none" w="med" len="med"/>
+                      <a:tailEnd type="none" w="med" len="med"/>
+                    </a:lnT>
+                    <a:lnB w="6350" cap="flat" cmpd="sng" algn="ctr">
+                      <a:solidFill>
+                        <a:srgbClr val="BFCFE8"/>
+                      </a:solidFill>
+                      <a:prstDash val="solid"/>
+                      <a:round/>
+                      <a:headEnd type="none" w="med" len="med"/>
+                      <a:tailEnd type="none" w="med" len="med"/>
+                    </a:lnB>
+                    <a:solidFill>
+                      <a:srgbClr val="FFF4CC"/>
+                    </a:solidFill>
+                  </a:tcPr>
+                </a:tc>
+                <a:tc>
+                  <a:txBody>
+                    <a:bodyPr/>
+                    <a:lstStyle/>
+                    <a:p>
+                      <a:pPr algn="ctr" indent="0" marL="0">
+                        <a:buNone/>
+                      </a:pPr>
+                      <a:r>
+                        <a:rPr lang="en-US" sz="800" b="1" dirty="0">
+                          <a:solidFill>
+                            <a:srgbClr val="1A7A3C"/>
+                          </a:solidFill>
+                          <a:latin typeface="Calibri" pitchFamily="34" charset="0"/>
+                          <a:ea typeface="Calibri" pitchFamily="34" charset="-122"/>
+                          <a:cs typeface="Calibri" pitchFamily="34" charset="-120"/>
+                        </a:rPr>
                         <a:t>CPU✓</a:t>
                       </a:r>
                       <a:endParaRPr lang="en-US" sz="800" dirty="0">
@@ -5220,143 +4824,7 @@
                       <a:tailEnd type="none" w="med" len="med"/>
                     </a:lnB>
                     <a:solidFill>
-                      <a:srgbClr val="DCF0E4"/>
-                    </a:solidFill>
-                  </a:tcPr>
-                </a:tc>
-                <a:tc>
-                  <a:txBody>
-                    <a:bodyPr/>
-                    <a:lstStyle/>
-                    <a:p>
-                      <a:pPr algn="ctr" indent="0" marL="0">
-                        <a:buNone/>
-                      </a:pPr>
-                      <a:r>
-                        <a:rPr lang="en-US" sz="800" b="1" dirty="0">
-                          <a:solidFill>
-                            <a:srgbClr val="1A7A3C"/>
-                          </a:solidFill>
-                          <a:latin typeface="Calibri" pitchFamily="34" charset="0"/>
-                          <a:ea typeface="Calibri" pitchFamily="34" charset="-122"/>
-                          <a:cs typeface="Calibri" pitchFamily="34" charset="-120"/>
-                        </a:rPr>
-                        <a:t>7,851★</a:t>
-                      </a:r>
-                      <a:endParaRPr lang="en-US" sz="800" dirty="0">
-                        <a:latin typeface="Calibri" charset="0"/>
-                        <a:ea typeface="Calibri" charset="0"/>
-                        <a:cs typeface="Calibri" charset="0"/>
-                      </a:endParaRPr>
-                    </a:p>
-                  </a:txBody>
-                  <a:tcPr marL="91440" marR="91440" marT="45720" marB="45720">
-                    <a:lnL w="6350" cap="flat" cmpd="sng" algn="ctr">
-                      <a:solidFill>
-                        <a:srgbClr val="BFCFE8"/>
-                      </a:solidFill>
-                      <a:prstDash val="solid"/>
-                      <a:round/>
-                      <a:headEnd type="none" w="med" len="med"/>
-                      <a:tailEnd type="none" w="med" len="med"/>
-                    </a:lnL>
-                    <a:lnR w="6350" cap="flat" cmpd="sng" algn="ctr">
-                      <a:solidFill>
-                        <a:srgbClr val="BFCFE8"/>
-                      </a:solidFill>
-                      <a:prstDash val="solid"/>
-                      <a:round/>
-                      <a:headEnd type="none" w="med" len="med"/>
-                      <a:tailEnd type="none" w="med" len="med"/>
-                    </a:lnR>
-                    <a:lnT w="6350" cap="flat" cmpd="sng" algn="ctr">
-                      <a:solidFill>
-                        <a:srgbClr val="BFCFE8"/>
-                      </a:solidFill>
-                      <a:prstDash val="solid"/>
-                      <a:round/>
-                      <a:headEnd type="none" w="med" len="med"/>
-                      <a:tailEnd type="none" w="med" len="med"/>
-                    </a:lnT>
-                    <a:lnB w="6350" cap="flat" cmpd="sng" algn="ctr">
-                      <a:solidFill>
-                        <a:srgbClr val="BFCFE8"/>
-                      </a:solidFill>
-                      <a:prstDash val="solid"/>
-                      <a:round/>
-                      <a:headEnd type="none" w="med" len="med"/>
-                      <a:tailEnd type="none" w="med" len="med"/>
-                    </a:lnB>
-                    <a:solidFill>
-                      <a:srgbClr val="DCF0E4"/>
-                    </a:solidFill>
-                  </a:tcPr>
-                </a:tc>
-                <a:tc>
-                  <a:txBody>
-                    <a:bodyPr/>
-                    <a:lstStyle/>
-                    <a:p>
-                      <a:pPr algn="ctr" indent="0" marL="0">
-                        <a:buNone/>
-                      </a:pPr>
-                      <a:r>
-                        <a:rPr lang="en-US" sz="800" b="1" dirty="0">
-                          <a:solidFill>
-                            <a:srgbClr val="C84B00"/>
-                          </a:solidFill>
-                          <a:latin typeface="Calibri" pitchFamily="34" charset="0"/>
-                          <a:ea typeface="Calibri" pitchFamily="34" charset="-122"/>
-                          <a:cs typeface="Calibri" pitchFamily="34" charset="-120"/>
-                        </a:rPr>
-                        <a:t>IO&gt;CPU</a:t>
-                      </a:r>
-                      <a:endParaRPr lang="en-US" sz="800" dirty="0">
-                        <a:latin typeface="Calibri" charset="0"/>
-                        <a:ea typeface="Calibri" charset="0"/>
-                        <a:cs typeface="Calibri" charset="0"/>
-                      </a:endParaRPr>
-                    </a:p>
-                  </a:txBody>
-                  <a:tcPr marL="91440" marR="91440" marT="45720" marB="45720">
-                    <a:lnL w="6350" cap="flat" cmpd="sng" algn="ctr">
-                      <a:solidFill>
-                        <a:srgbClr val="BFCFE8"/>
-                      </a:solidFill>
-                      <a:prstDash val="solid"/>
-                      <a:round/>
-                      <a:headEnd type="none" w="med" len="med"/>
-                      <a:tailEnd type="none" w="med" len="med"/>
-                    </a:lnL>
-                    <a:lnR w="6350" cap="flat" cmpd="sng" algn="ctr">
-                      <a:solidFill>
-                        <a:srgbClr val="BFCFE8"/>
-                      </a:solidFill>
-                      <a:prstDash val="solid"/>
-                      <a:round/>
-                      <a:headEnd type="none" w="med" len="med"/>
-                      <a:tailEnd type="none" w="med" len="med"/>
-                    </a:lnR>
-                    <a:lnT w="6350" cap="flat" cmpd="sng" algn="ctr">
-                      <a:solidFill>
-                        <a:srgbClr val="BFCFE8"/>
-                      </a:solidFill>
-                      <a:prstDash val="solid"/>
-                      <a:round/>
-                      <a:headEnd type="none" w="med" len="med"/>
-                      <a:tailEnd type="none" w="med" len="med"/>
-                    </a:lnT>
-                    <a:lnB w="6350" cap="flat" cmpd="sng" algn="ctr">
-                      <a:solidFill>
-                        <a:srgbClr val="BFCFE8"/>
-                      </a:solidFill>
-                      <a:prstDash val="solid"/>
-                      <a:round/>
-                      <a:headEnd type="none" w="med" len="med"/>
-                      <a:tailEnd type="none" w="med" len="med"/>
-                    </a:lnB>
-                    <a:solidFill>
-                      <a:srgbClr val="DCF0E4"/>
+                      <a:srgbClr val="FFF4CC"/>
                     </a:solidFill>
                   </a:tcPr>
                 </a:tc>
@@ -5379,7 +4847,7 @@
                           <a:ea typeface="Calibri" pitchFamily="34" charset="-122"/>
                           <a:cs typeface="Calibri" pitchFamily="34" charset="-120"/>
                         </a:rPr>
-                        <a:t>4,096</a:t>
+                        <a:t>≥1,024</a:t>
                       </a:r>
                       <a:endParaRPr lang="en-US" sz="800" dirty="0">
                         <a:latin typeface="Calibri" charset="0"/>
@@ -5447,7 +4915,7 @@
                           <a:ea typeface="Calibri" pitchFamily="34" charset="-122"/>
                           <a:cs typeface="Calibri" pitchFamily="34" charset="-120"/>
                         </a:rPr>
-                        <a:t>9.67ms</a:t>
+                        <a:t>≥4.71ms</a:t>
                       </a:r>
                       <a:endParaRPr lang="en-US" sz="800" dirty="0">
                         <a:latin typeface="Calibri" charset="0"/>
@@ -5515,7 +4983,7 @@
                           <a:ea typeface="Calibri" pitchFamily="34" charset="-122"/>
                           <a:cs typeface="Calibri" pitchFamily="34" charset="-120"/>
                         </a:rPr>
-                        <a:t>9,445</a:t>
+                        <a:t>5,052</a:t>
                       </a:r>
                       <a:endParaRPr lang="en-US" sz="800" dirty="0">
                         <a:latin typeface="Calibri" charset="0"/>
@@ -5651,7 +5119,7 @@
                           <a:ea typeface="Calibri" pitchFamily="34" charset="-122"/>
                           <a:cs typeface="Calibri" pitchFamily="34" charset="-120"/>
                         </a:rPr>
-                        <a:t>9,445</a:t>
+                        <a:t>5,052</a:t>
                       </a:r>
                       <a:endParaRPr lang="en-US" sz="800" dirty="0">
                         <a:latin typeface="Calibri" charset="0"/>
@@ -5722,6 +5190,1134 @@
                         <a:t>CPU✓</a:t>
                       </a:r>
                       <a:endParaRPr lang="en-US" sz="800" dirty="0">
+                        <a:latin typeface="Calibri" charset="0"/>
+                        <a:ea typeface="Calibri" charset="0"/>
+                        <a:cs typeface="Calibri" charset="0"/>
+                      </a:endParaRPr>
+                    </a:p>
+                  </a:txBody>
+                  <a:tcPr marL="91440" marR="91440" marT="45720" marB="45720">
+                    <a:lnL w="6350" cap="flat" cmpd="sng" algn="ctr">
+                      <a:solidFill>
+                        <a:srgbClr val="BFCFE8"/>
+                      </a:solidFill>
+                      <a:prstDash val="solid"/>
+                      <a:round/>
+                      <a:headEnd type="none" w="med" len="med"/>
+                      <a:tailEnd type="none" w="med" len="med"/>
+                    </a:lnL>
+                    <a:lnR w="6350" cap="flat" cmpd="sng" algn="ctr">
+                      <a:solidFill>
+                        <a:srgbClr val="BFCFE8"/>
+                      </a:solidFill>
+                      <a:prstDash val="solid"/>
+                      <a:round/>
+                      <a:headEnd type="none" w="med" len="med"/>
+                      <a:tailEnd type="none" w="med" len="med"/>
+                    </a:lnR>
+                    <a:lnT w="6350" cap="flat" cmpd="sng" algn="ctr">
+                      <a:solidFill>
+                        <a:srgbClr val="BFCFE8"/>
+                      </a:solidFill>
+                      <a:prstDash val="solid"/>
+                      <a:round/>
+                      <a:headEnd type="none" w="med" len="med"/>
+                      <a:tailEnd type="none" w="med" len="med"/>
+                    </a:lnT>
+                    <a:lnB w="6350" cap="flat" cmpd="sng" algn="ctr">
+                      <a:solidFill>
+                        <a:srgbClr val="BFCFE8"/>
+                      </a:solidFill>
+                      <a:prstDash val="solid"/>
+                      <a:round/>
+                      <a:headEnd type="none" w="med" len="med"/>
+                      <a:tailEnd type="none" w="med" len="med"/>
+                    </a:lnB>
+                    <a:solidFill>
+                      <a:srgbClr val="EBF3FC"/>
+                    </a:solidFill>
+                  </a:tcPr>
+                </a:tc>
+              </a:tr>
+            </a:tbl>
+          </a:graphicData>
+        </a:graphic>
+      </p:graphicFrame>
+      <p:graphicFrame>
+        <p:nvGraphicFramePr>
+          <p:cNvPr id="3" name="Table 1"/>
+          <p:cNvGraphicFramePr>
+            <a:graphicFrameLocks noGrp="1"/>
+          </p:cNvGraphicFramePr>
+          <p:nvPr>
+            <p:extLst>
+              <p:ext uri="{D42A27DB-BD31-4B8C-83A1-F6EECF244321}">
+                <p14:modId xmlns:p14="http://schemas.microsoft.com/office/powerpoint/2010/main" val="1579011935"/>
+              </p:ext>
+            </p:extLst>
+          </p:nvPr>
+        </p:nvGraphicFramePr>
+        <p:xfrm>
+          <a:off x="3840480" y="3493008"/>
+          <a:ext cx="3346704" cy="914400"/>
+        </p:xfrm>
+        <a:graphic>
+          <a:graphicData uri="http://schemas.openxmlformats.org/drawingml/2006/table">
+            <a:tbl>
+              <a:tblPr/>
+              <a:tblGrid>
+                <a:gridCol w="1005840"/>
+                <a:gridCol w="768096"/>
+                <a:gridCol w="768096"/>
+                <a:gridCol w="804672"/>
+              </a:tblGrid>
+              <a:tr h="164592">
+                <a:tc>
+                  <a:txBody>
+                    <a:bodyPr/>
+                    <a:lstStyle/>
+                    <a:p>
+                      <a:pPr algn="l" indent="0" marL="0">
+                        <a:buNone/>
+                      </a:pPr>
+                      <a:r>
+                        <a:rPr lang="en-US" sz="700" b="1" dirty="0">
+                          <a:solidFill>
+                            <a:srgbClr val="FFFFFF"/>
+                          </a:solidFill>
+                          <a:latin typeface="Calibri" pitchFamily="34" charset="0"/>
+                          <a:ea typeface="Calibri" pitchFamily="34" charset="-122"/>
+                          <a:cs typeface="Calibri" pitchFamily="34" charset="-120"/>
+                        </a:rPr>
+                        <a:t>TTFT — Prompt Length L</a:t>
+                      </a:r>
+                      <a:endParaRPr lang="en-US" sz="700" dirty="0">
+                        <a:latin typeface="Calibri" charset="0"/>
+                        <a:ea typeface="Calibri" charset="0"/>
+                        <a:cs typeface="Calibri" charset="0"/>
+                      </a:endParaRPr>
+                    </a:p>
+                  </a:txBody>
+                  <a:tcPr marL="91440" marR="91440" marT="45720" marB="45720">
+                    <a:lnL w="6350" cap="flat" cmpd="sng" algn="ctr">
+                      <a:solidFill>
+                        <a:srgbClr val="BFCFE8"/>
+                      </a:solidFill>
+                      <a:prstDash val="solid"/>
+                      <a:round/>
+                      <a:headEnd type="none" w="med" len="med"/>
+                      <a:tailEnd type="none" w="med" len="med"/>
+                    </a:lnL>
+                    <a:lnR w="6350" cap="flat" cmpd="sng" algn="ctr">
+                      <a:solidFill>
+                        <a:srgbClr val="BFCFE8"/>
+                      </a:solidFill>
+                      <a:prstDash val="solid"/>
+                      <a:round/>
+                      <a:headEnd type="none" w="med" len="med"/>
+                      <a:tailEnd type="none" w="med" len="med"/>
+                    </a:lnR>
+                    <a:lnT w="6350" cap="flat" cmpd="sng" algn="ctr">
+                      <a:solidFill>
+                        <a:srgbClr val="BFCFE8"/>
+                      </a:solidFill>
+                      <a:prstDash val="solid"/>
+                      <a:round/>
+                      <a:headEnd type="none" w="med" len="med"/>
+                      <a:tailEnd type="none" w="med" len="med"/>
+                    </a:lnT>
+                    <a:lnB w="6350" cap="flat" cmpd="sng" algn="ctr">
+                      <a:solidFill>
+                        <a:srgbClr val="BFCFE8"/>
+                      </a:solidFill>
+                      <a:prstDash val="solid"/>
+                      <a:round/>
+                      <a:headEnd type="none" w="med" len="med"/>
+                      <a:tailEnd type="none" w="med" len="med"/>
+                    </a:lnB>
+                    <a:solidFill>
+                      <a:srgbClr val="1B2A4A"/>
+                    </a:solidFill>
+                  </a:tcPr>
+                </a:tc>
+                <a:tc>
+                  <a:txBody>
+                    <a:bodyPr/>
+                    <a:lstStyle/>
+                    <a:p>
+                      <a:pPr algn="ctr" indent="0" marL="0">
+                        <a:buNone/>
+                      </a:pPr>
+                      <a:r>
+                        <a:rPr lang="en-US" sz="700" b="1" dirty="0">
+                          <a:solidFill>
+                            <a:srgbClr val="FFFFFF"/>
+                          </a:solidFill>
+                          <a:latin typeface="Calibri" pitchFamily="34" charset="0"/>
+                          <a:ea typeface="Calibri" pitchFamily="34" charset="-122"/>
+                          <a:cs typeface="Calibri" pitchFamily="34" charset="-120"/>
+                        </a:rPr>
+                        <a:t>PCIe5 TTFT</a:t>
+                      </a:r>
+                      <a:endParaRPr lang="en-US" sz="700" dirty="0">
+                        <a:latin typeface="Calibri" charset="0"/>
+                        <a:ea typeface="Calibri" charset="0"/>
+                        <a:cs typeface="Calibri" charset="0"/>
+                      </a:endParaRPr>
+                    </a:p>
+                  </a:txBody>
+                  <a:tcPr marL="91440" marR="91440" marT="45720" marB="45720">
+                    <a:lnL w="6350" cap="flat" cmpd="sng" algn="ctr">
+                      <a:solidFill>
+                        <a:srgbClr val="BFCFE8"/>
+                      </a:solidFill>
+                      <a:prstDash val="solid"/>
+                      <a:round/>
+                      <a:headEnd type="none" w="med" len="med"/>
+                      <a:tailEnd type="none" w="med" len="med"/>
+                    </a:lnL>
+                    <a:lnR w="6350" cap="flat" cmpd="sng" algn="ctr">
+                      <a:solidFill>
+                        <a:srgbClr val="BFCFE8"/>
+                      </a:solidFill>
+                      <a:prstDash val="solid"/>
+                      <a:round/>
+                      <a:headEnd type="none" w="med" len="med"/>
+                      <a:tailEnd type="none" w="med" len="med"/>
+                    </a:lnR>
+                    <a:lnT w="6350" cap="flat" cmpd="sng" algn="ctr">
+                      <a:solidFill>
+                        <a:srgbClr val="BFCFE8"/>
+                      </a:solidFill>
+                      <a:prstDash val="solid"/>
+                      <a:round/>
+                      <a:headEnd type="none" w="med" len="med"/>
+                      <a:tailEnd type="none" w="med" len="med"/>
+                    </a:lnT>
+                    <a:lnB w="6350" cap="flat" cmpd="sng" algn="ctr">
+                      <a:solidFill>
+                        <a:srgbClr val="BFCFE8"/>
+                      </a:solidFill>
+                      <a:prstDash val="solid"/>
+                      <a:round/>
+                      <a:headEnd type="none" w="med" len="med"/>
+                      <a:tailEnd type="none" w="med" len="med"/>
+                    </a:lnB>
+                    <a:solidFill>
+                      <a:srgbClr val="1B2A4A"/>
+                    </a:solidFill>
+                  </a:tcPr>
+                </a:tc>
+                <a:tc>
+                  <a:txBody>
+                    <a:bodyPr/>
+                    <a:lstStyle/>
+                    <a:p>
+                      <a:pPr algn="ctr" indent="0" marL="0">
+                        <a:buNone/>
+                      </a:pPr>
+                      <a:r>
+                        <a:rPr lang="en-US" sz="700" b="1" dirty="0">
+                          <a:solidFill>
+                            <a:srgbClr val="FFFFFF"/>
+                          </a:solidFill>
+                          <a:latin typeface="Calibri" pitchFamily="34" charset="0"/>
+                          <a:ea typeface="Calibri" pitchFamily="34" charset="-122"/>
+                          <a:cs typeface="Calibri" pitchFamily="34" charset="-120"/>
+                        </a:rPr>
+                        <a:t>PCIe6 TTFT</a:t>
+                      </a:r>
+                      <a:endParaRPr lang="en-US" sz="700" dirty="0">
+                        <a:latin typeface="Calibri" charset="0"/>
+                        <a:ea typeface="Calibri" charset="0"/>
+                        <a:cs typeface="Calibri" charset="0"/>
+                      </a:endParaRPr>
+                    </a:p>
+                  </a:txBody>
+                  <a:tcPr marL="91440" marR="91440" marT="45720" marB="45720">
+                    <a:lnL w="6350" cap="flat" cmpd="sng" algn="ctr">
+                      <a:solidFill>
+                        <a:srgbClr val="BFCFE8"/>
+                      </a:solidFill>
+                      <a:prstDash val="solid"/>
+                      <a:round/>
+                      <a:headEnd type="none" w="med" len="med"/>
+                      <a:tailEnd type="none" w="med" len="med"/>
+                    </a:lnL>
+                    <a:lnR w="6350" cap="flat" cmpd="sng" algn="ctr">
+                      <a:solidFill>
+                        <a:srgbClr val="BFCFE8"/>
+                      </a:solidFill>
+                      <a:prstDash val="solid"/>
+                      <a:round/>
+                      <a:headEnd type="none" w="med" len="med"/>
+                      <a:tailEnd type="none" w="med" len="med"/>
+                    </a:lnR>
+                    <a:lnT w="6350" cap="flat" cmpd="sng" algn="ctr">
+                      <a:solidFill>
+                        <a:srgbClr val="BFCFE8"/>
+                      </a:solidFill>
+                      <a:prstDash val="solid"/>
+                      <a:round/>
+                      <a:headEnd type="none" w="med" len="med"/>
+                      <a:tailEnd type="none" w="med" len="med"/>
+                    </a:lnT>
+                    <a:lnB w="6350" cap="flat" cmpd="sng" algn="ctr">
+                      <a:solidFill>
+                        <a:srgbClr val="BFCFE8"/>
+                      </a:solidFill>
+                      <a:prstDash val="solid"/>
+                      <a:round/>
+                      <a:headEnd type="none" w="med" len="med"/>
+                      <a:tailEnd type="none" w="med" len="med"/>
+                    </a:lnB>
+                    <a:solidFill>
+                      <a:srgbClr val="1B2A4A"/>
+                    </a:solidFill>
+                  </a:tcPr>
+                </a:tc>
+                <a:tc>
+                  <a:txBody>
+                    <a:bodyPr/>
+                    <a:lstStyle/>
+                    <a:p>
+                      <a:pPr algn="ctr" indent="0" marL="0">
+                        <a:buNone/>
+                      </a:pPr>
+                      <a:r>
+                        <a:rPr lang="en-US" sz="700" b="1" dirty="0">
+                          <a:solidFill>
+                            <a:srgbClr val="FFFFFF"/>
+                          </a:solidFill>
+                          <a:latin typeface="Calibri" pitchFamily="34" charset="0"/>
+                          <a:ea typeface="Calibri" pitchFamily="34" charset="-122"/>
+                          <a:cs typeface="Calibri" pitchFamily="34" charset="-120"/>
+                        </a:rPr>
+                        <a:t>Δ</a:t>
+                      </a:r>
+                      <a:endParaRPr lang="en-US" sz="700" dirty="0">
+                        <a:latin typeface="Calibri" charset="0"/>
+                        <a:ea typeface="Calibri" charset="0"/>
+                        <a:cs typeface="Calibri" charset="0"/>
+                      </a:endParaRPr>
+                    </a:p>
+                  </a:txBody>
+                  <a:tcPr marL="91440" marR="91440" marT="45720" marB="45720">
+                    <a:lnL w="6350" cap="flat" cmpd="sng" algn="ctr">
+                      <a:solidFill>
+                        <a:srgbClr val="BFCFE8"/>
+                      </a:solidFill>
+                      <a:prstDash val="solid"/>
+                      <a:round/>
+                      <a:headEnd type="none" w="med" len="med"/>
+                      <a:tailEnd type="none" w="med" len="med"/>
+                    </a:lnL>
+                    <a:lnR w="6350" cap="flat" cmpd="sng" algn="ctr">
+                      <a:solidFill>
+                        <a:srgbClr val="BFCFE8"/>
+                      </a:solidFill>
+                      <a:prstDash val="solid"/>
+                      <a:round/>
+                      <a:headEnd type="none" w="med" len="med"/>
+                      <a:tailEnd type="none" w="med" len="med"/>
+                    </a:lnR>
+                    <a:lnT w="6350" cap="flat" cmpd="sng" algn="ctr">
+                      <a:solidFill>
+                        <a:srgbClr val="BFCFE8"/>
+                      </a:solidFill>
+                      <a:prstDash val="solid"/>
+                      <a:round/>
+                      <a:headEnd type="none" w="med" len="med"/>
+                      <a:tailEnd type="none" w="med" len="med"/>
+                    </a:lnT>
+                    <a:lnB w="6350" cap="flat" cmpd="sng" algn="ctr">
+                      <a:solidFill>
+                        <a:srgbClr val="BFCFE8"/>
+                      </a:solidFill>
+                      <a:prstDash val="solid"/>
+                      <a:round/>
+                      <a:headEnd type="none" w="med" len="med"/>
+                      <a:tailEnd type="none" w="med" len="med"/>
+                    </a:lnB>
+                    <a:solidFill>
+                      <a:srgbClr val="1B2A4A"/>
+                    </a:solidFill>
+                  </a:tcPr>
+                </a:tc>
+              </a:tr>
+              <a:tr h="164592">
+                <a:tc>
+                  <a:txBody>
+                    <a:bodyPr/>
+                    <a:lstStyle/>
+                    <a:p>
+                      <a:pPr algn="l" indent="0" marL="0">
+                        <a:buNone/>
+                      </a:pPr>
+                      <a:r>
+                        <a:rPr lang="en-US" sz="700" dirty="0">
+                          <a:solidFill>
+                            <a:srgbClr val="555555"/>
+                          </a:solidFill>
+                          <a:latin typeface="Calibri" pitchFamily="34" charset="0"/>
+                          <a:ea typeface="Calibri" pitchFamily="34" charset="-122"/>
+                          <a:cs typeface="Calibri" pitchFamily="34" charset="-120"/>
+                        </a:rPr>
+                        <a:t>L≤256  (both IO-bnd)</a:t>
+                      </a:r>
+                      <a:endParaRPr lang="en-US" sz="700" dirty="0">
+                        <a:latin typeface="Calibri" charset="0"/>
+                        <a:ea typeface="Calibri" charset="0"/>
+                        <a:cs typeface="Calibri" charset="0"/>
+                      </a:endParaRPr>
+                    </a:p>
+                  </a:txBody>
+                  <a:tcPr marL="91440" marR="91440" marT="45720" marB="45720">
+                    <a:lnL w="6350" cap="flat" cmpd="sng" algn="ctr">
+                      <a:solidFill>
+                        <a:srgbClr val="BFCFE8"/>
+                      </a:solidFill>
+                      <a:prstDash val="solid"/>
+                      <a:round/>
+                      <a:headEnd type="none" w="med" len="med"/>
+                      <a:tailEnd type="none" w="med" len="med"/>
+                    </a:lnL>
+                    <a:lnR w="6350" cap="flat" cmpd="sng" algn="ctr">
+                      <a:solidFill>
+                        <a:srgbClr val="BFCFE8"/>
+                      </a:solidFill>
+                      <a:prstDash val="solid"/>
+                      <a:round/>
+                      <a:headEnd type="none" w="med" len="med"/>
+                      <a:tailEnd type="none" w="med" len="med"/>
+                    </a:lnR>
+                    <a:lnT w="6350" cap="flat" cmpd="sng" algn="ctr">
+                      <a:solidFill>
+                        <a:srgbClr val="BFCFE8"/>
+                      </a:solidFill>
+                      <a:prstDash val="solid"/>
+                      <a:round/>
+                      <a:headEnd type="none" w="med" len="med"/>
+                      <a:tailEnd type="none" w="med" len="med"/>
+                    </a:lnT>
+                    <a:lnB w="6350" cap="flat" cmpd="sng" algn="ctr">
+                      <a:solidFill>
+                        <a:srgbClr val="BFCFE8"/>
+                      </a:solidFill>
+                      <a:prstDash val="solid"/>
+                      <a:round/>
+                      <a:headEnd type="none" w="med" len="med"/>
+                      <a:tailEnd type="none" w="med" len="med"/>
+                    </a:lnB>
+                    <a:solidFill>
+                      <a:srgbClr val="EBF3FC"/>
+                    </a:solidFill>
+                  </a:tcPr>
+                </a:tc>
+                <a:tc>
+                  <a:txBody>
+                    <a:bodyPr/>
+                    <a:lstStyle/>
+                    <a:p>
+                      <a:pPr algn="ctr" indent="0" marL="0">
+                        <a:buNone/>
+                      </a:pPr>
+                      <a:r>
+                        <a:rPr lang="en-US" sz="700" b="1" dirty="0">
+                          <a:solidFill>
+                            <a:srgbClr val="C84B00"/>
+                          </a:solidFill>
+                          <a:latin typeface="Calibri" pitchFamily="34" charset="0"/>
+                          <a:ea typeface="Calibri" pitchFamily="34" charset="-122"/>
+                          <a:cs typeface="Calibri" pitchFamily="34" charset="-120"/>
+                        </a:rPr>
+                        <a:t>110.5 ms</a:t>
+                      </a:r>
+                      <a:endParaRPr lang="en-US" sz="700" dirty="0">
+                        <a:latin typeface="Calibri" charset="0"/>
+                        <a:ea typeface="Calibri" charset="0"/>
+                        <a:cs typeface="Calibri" charset="0"/>
+                      </a:endParaRPr>
+                    </a:p>
+                  </a:txBody>
+                  <a:tcPr marL="91440" marR="91440" marT="45720" marB="45720">
+                    <a:lnL w="6350" cap="flat" cmpd="sng" algn="ctr">
+                      <a:solidFill>
+                        <a:srgbClr val="BFCFE8"/>
+                      </a:solidFill>
+                      <a:prstDash val="solid"/>
+                      <a:round/>
+                      <a:headEnd type="none" w="med" len="med"/>
+                      <a:tailEnd type="none" w="med" len="med"/>
+                    </a:lnL>
+                    <a:lnR w="6350" cap="flat" cmpd="sng" algn="ctr">
+                      <a:solidFill>
+                        <a:srgbClr val="BFCFE8"/>
+                      </a:solidFill>
+                      <a:prstDash val="solid"/>
+                      <a:round/>
+                      <a:headEnd type="none" w="med" len="med"/>
+                      <a:tailEnd type="none" w="med" len="med"/>
+                    </a:lnR>
+                    <a:lnT w="6350" cap="flat" cmpd="sng" algn="ctr">
+                      <a:solidFill>
+                        <a:srgbClr val="BFCFE8"/>
+                      </a:solidFill>
+                      <a:prstDash val="solid"/>
+                      <a:round/>
+                      <a:headEnd type="none" w="med" len="med"/>
+                      <a:tailEnd type="none" w="med" len="med"/>
+                    </a:lnT>
+                    <a:lnB w="6350" cap="flat" cmpd="sng" algn="ctr">
+                      <a:solidFill>
+                        <a:srgbClr val="BFCFE8"/>
+                      </a:solidFill>
+                      <a:prstDash val="solid"/>
+                      <a:round/>
+                      <a:headEnd type="none" w="med" len="med"/>
+                      <a:tailEnd type="none" w="med" len="med"/>
+                    </a:lnB>
+                    <a:solidFill>
+                      <a:srgbClr val="EBF3FC"/>
+                    </a:solidFill>
+                  </a:tcPr>
+                </a:tc>
+                <a:tc>
+                  <a:txBody>
+                    <a:bodyPr/>
+                    <a:lstStyle/>
+                    <a:p>
+                      <a:pPr algn="ctr" indent="0" marL="0">
+                        <a:buNone/>
+                      </a:pPr>
+                      <a:r>
+                        <a:rPr lang="en-US" sz="700" b="1" dirty="0">
+                          <a:solidFill>
+                            <a:srgbClr val="1A7A3C"/>
+                          </a:solidFill>
+                          <a:latin typeface="Calibri" pitchFamily="34" charset="0"/>
+                          <a:ea typeface="Calibri" pitchFamily="34" charset="-122"/>
+                          <a:cs typeface="Calibri" pitchFamily="34" charset="-120"/>
+                        </a:rPr>
+                        <a:t>54.4 ms ★</a:t>
+                      </a:r>
+                      <a:endParaRPr lang="en-US" sz="700" dirty="0">
+                        <a:latin typeface="Calibri" charset="0"/>
+                        <a:ea typeface="Calibri" charset="0"/>
+                        <a:cs typeface="Calibri" charset="0"/>
+                      </a:endParaRPr>
+                    </a:p>
+                  </a:txBody>
+                  <a:tcPr marL="91440" marR="91440" marT="45720" marB="45720">
+                    <a:lnL w="6350" cap="flat" cmpd="sng" algn="ctr">
+                      <a:solidFill>
+                        <a:srgbClr val="BFCFE8"/>
+                      </a:solidFill>
+                      <a:prstDash val="solid"/>
+                      <a:round/>
+                      <a:headEnd type="none" w="med" len="med"/>
+                      <a:tailEnd type="none" w="med" len="med"/>
+                    </a:lnL>
+                    <a:lnR w="6350" cap="flat" cmpd="sng" algn="ctr">
+                      <a:solidFill>
+                        <a:srgbClr val="BFCFE8"/>
+                      </a:solidFill>
+                      <a:prstDash val="solid"/>
+                      <a:round/>
+                      <a:headEnd type="none" w="med" len="med"/>
+                      <a:tailEnd type="none" w="med" len="med"/>
+                    </a:lnR>
+                    <a:lnT w="6350" cap="flat" cmpd="sng" algn="ctr">
+                      <a:solidFill>
+                        <a:srgbClr val="BFCFE8"/>
+                      </a:solidFill>
+                      <a:prstDash val="solid"/>
+                      <a:round/>
+                      <a:headEnd type="none" w="med" len="med"/>
+                      <a:tailEnd type="none" w="med" len="med"/>
+                    </a:lnT>
+                    <a:lnB w="6350" cap="flat" cmpd="sng" algn="ctr">
+                      <a:solidFill>
+                        <a:srgbClr val="BFCFE8"/>
+                      </a:solidFill>
+                      <a:prstDash val="solid"/>
+                      <a:round/>
+                      <a:headEnd type="none" w="med" len="med"/>
+                      <a:tailEnd type="none" w="med" len="med"/>
+                    </a:lnB>
+                    <a:solidFill>
+                      <a:srgbClr val="EBF3FC"/>
+                    </a:solidFill>
+                  </a:tcPr>
+                </a:tc>
+                <a:tc>
+                  <a:txBody>
+                    <a:bodyPr/>
+                    <a:lstStyle/>
+                    <a:p>
+                      <a:pPr algn="ctr" indent="0" marL="0">
+                        <a:buNone/>
+                      </a:pPr>
+                      <a:r>
+                        <a:rPr lang="en-US" sz="700" b="1" dirty="0">
+                          <a:solidFill>
+                            <a:srgbClr val="1A7A3C"/>
+                          </a:solidFill>
+                          <a:latin typeface="Calibri" pitchFamily="34" charset="0"/>
+                          <a:ea typeface="Calibri" pitchFamily="34" charset="-122"/>
+                          <a:cs typeface="Calibri" pitchFamily="34" charset="-120"/>
+                        </a:rPr>
+                        <a:t>2.03× faster</a:t>
+                      </a:r>
+                      <a:endParaRPr lang="en-US" sz="700" dirty="0">
+                        <a:latin typeface="Calibri" charset="0"/>
+                        <a:ea typeface="Calibri" charset="0"/>
+                        <a:cs typeface="Calibri" charset="0"/>
+                      </a:endParaRPr>
+                    </a:p>
+                  </a:txBody>
+                  <a:tcPr marL="91440" marR="91440" marT="45720" marB="45720">
+                    <a:lnL w="6350" cap="flat" cmpd="sng" algn="ctr">
+                      <a:solidFill>
+                        <a:srgbClr val="BFCFE8"/>
+                      </a:solidFill>
+                      <a:prstDash val="solid"/>
+                      <a:round/>
+                      <a:headEnd type="none" w="med" len="med"/>
+                      <a:tailEnd type="none" w="med" len="med"/>
+                    </a:lnL>
+                    <a:lnR w="6350" cap="flat" cmpd="sng" algn="ctr">
+                      <a:solidFill>
+                        <a:srgbClr val="BFCFE8"/>
+                      </a:solidFill>
+                      <a:prstDash val="solid"/>
+                      <a:round/>
+                      <a:headEnd type="none" w="med" len="med"/>
+                      <a:tailEnd type="none" w="med" len="med"/>
+                    </a:lnR>
+                    <a:lnT w="6350" cap="flat" cmpd="sng" algn="ctr">
+                      <a:solidFill>
+                        <a:srgbClr val="BFCFE8"/>
+                      </a:solidFill>
+                      <a:prstDash val="solid"/>
+                      <a:round/>
+                      <a:headEnd type="none" w="med" len="med"/>
+                      <a:tailEnd type="none" w="med" len="med"/>
+                    </a:lnT>
+                    <a:lnB w="6350" cap="flat" cmpd="sng" algn="ctr">
+                      <a:solidFill>
+                        <a:srgbClr val="BFCFE8"/>
+                      </a:solidFill>
+                      <a:prstDash val="solid"/>
+                      <a:round/>
+                      <a:headEnd type="none" w="med" len="med"/>
+                      <a:tailEnd type="none" w="med" len="med"/>
+                    </a:lnB>
+                    <a:solidFill>
+                      <a:srgbClr val="EBF3FC"/>
+                    </a:solidFill>
+                  </a:tcPr>
+                </a:tc>
+              </a:tr>
+              <a:tr h="164592">
+                <a:tc>
+                  <a:txBody>
+                    <a:bodyPr/>
+                    <a:lstStyle/>
+                    <a:p>
+                      <a:pPr algn="l" indent="0" marL="0">
+                        <a:buNone/>
+                      </a:pPr>
+                      <a:r>
+                        <a:rPr lang="en-US" sz="700" dirty="0">
+                          <a:solidFill>
+                            <a:srgbClr val="555555"/>
+                          </a:solidFill>
+                          <a:latin typeface="Calibri" pitchFamily="34" charset="0"/>
+                          <a:ea typeface="Calibri" pitchFamily="34" charset="-122"/>
+                          <a:cs typeface="Calibri" pitchFamily="34" charset="-120"/>
+                        </a:rPr>
+                        <a:t>L=512  P5=IO; P6=CPU</a:t>
+                      </a:r>
+                      <a:endParaRPr lang="en-US" sz="700" dirty="0">
+                        <a:latin typeface="Calibri" charset="0"/>
+                        <a:ea typeface="Calibri" charset="0"/>
+                        <a:cs typeface="Calibri" charset="0"/>
+                      </a:endParaRPr>
+                    </a:p>
+                  </a:txBody>
+                  <a:tcPr marL="91440" marR="91440" marT="45720" marB="45720">
+                    <a:lnL w="6350" cap="flat" cmpd="sng" algn="ctr">
+                      <a:solidFill>
+                        <a:srgbClr val="BFCFE8"/>
+                      </a:solidFill>
+                      <a:prstDash val="solid"/>
+                      <a:round/>
+                      <a:headEnd type="none" w="med" len="med"/>
+                      <a:tailEnd type="none" w="med" len="med"/>
+                    </a:lnL>
+                    <a:lnR w="6350" cap="flat" cmpd="sng" algn="ctr">
+                      <a:solidFill>
+                        <a:srgbClr val="BFCFE8"/>
+                      </a:solidFill>
+                      <a:prstDash val="solid"/>
+                      <a:round/>
+                      <a:headEnd type="none" w="med" len="med"/>
+                      <a:tailEnd type="none" w="med" len="med"/>
+                    </a:lnR>
+                    <a:lnT w="6350" cap="flat" cmpd="sng" algn="ctr">
+                      <a:solidFill>
+                        <a:srgbClr val="BFCFE8"/>
+                      </a:solidFill>
+                      <a:prstDash val="solid"/>
+                      <a:round/>
+                      <a:headEnd type="none" w="med" len="med"/>
+                      <a:tailEnd type="none" w="med" len="med"/>
+                    </a:lnT>
+                    <a:lnB w="6350" cap="flat" cmpd="sng" algn="ctr">
+                      <a:solidFill>
+                        <a:srgbClr val="BFCFE8"/>
+                      </a:solidFill>
+                      <a:prstDash val="solid"/>
+                      <a:round/>
+                      <a:headEnd type="none" w="med" len="med"/>
+                      <a:tailEnd type="none" w="med" len="med"/>
+                    </a:lnB>
+                    <a:solidFill>
+                      <a:srgbClr val="FFFFFF"/>
+                    </a:solidFill>
+                  </a:tcPr>
+                </a:tc>
+                <a:tc>
+                  <a:txBody>
+                    <a:bodyPr/>
+                    <a:lstStyle/>
+                    <a:p>
+                      <a:pPr algn="ctr" indent="0" marL="0">
+                        <a:buNone/>
+                      </a:pPr>
+                      <a:r>
+                        <a:rPr lang="en-US" sz="700" b="1" dirty="0">
+                          <a:solidFill>
+                            <a:srgbClr val="C84B00"/>
+                          </a:solidFill>
+                          <a:latin typeface="Calibri" pitchFamily="34" charset="0"/>
+                          <a:ea typeface="Calibri" pitchFamily="34" charset="-122"/>
+                          <a:cs typeface="Calibri" pitchFamily="34" charset="-120"/>
+                        </a:rPr>
+                        <a:t>110.5 ms</a:t>
+                      </a:r>
+                      <a:endParaRPr lang="en-US" sz="700" dirty="0">
+                        <a:latin typeface="Calibri" charset="0"/>
+                        <a:ea typeface="Calibri" charset="0"/>
+                        <a:cs typeface="Calibri" charset="0"/>
+                      </a:endParaRPr>
+                    </a:p>
+                  </a:txBody>
+                  <a:tcPr marL="91440" marR="91440" marT="45720" marB="45720">
+                    <a:lnL w="6350" cap="flat" cmpd="sng" algn="ctr">
+                      <a:solidFill>
+                        <a:srgbClr val="BFCFE8"/>
+                      </a:solidFill>
+                      <a:prstDash val="solid"/>
+                      <a:round/>
+                      <a:headEnd type="none" w="med" len="med"/>
+                      <a:tailEnd type="none" w="med" len="med"/>
+                    </a:lnL>
+                    <a:lnR w="6350" cap="flat" cmpd="sng" algn="ctr">
+                      <a:solidFill>
+                        <a:srgbClr val="BFCFE8"/>
+                      </a:solidFill>
+                      <a:prstDash val="solid"/>
+                      <a:round/>
+                      <a:headEnd type="none" w="med" len="med"/>
+                      <a:tailEnd type="none" w="med" len="med"/>
+                    </a:lnR>
+                    <a:lnT w="6350" cap="flat" cmpd="sng" algn="ctr">
+                      <a:solidFill>
+                        <a:srgbClr val="BFCFE8"/>
+                      </a:solidFill>
+                      <a:prstDash val="solid"/>
+                      <a:round/>
+                      <a:headEnd type="none" w="med" len="med"/>
+                      <a:tailEnd type="none" w="med" len="med"/>
+                    </a:lnT>
+                    <a:lnB w="6350" cap="flat" cmpd="sng" algn="ctr">
+                      <a:solidFill>
+                        <a:srgbClr val="BFCFE8"/>
+                      </a:solidFill>
+                      <a:prstDash val="solid"/>
+                      <a:round/>
+                      <a:headEnd type="none" w="med" len="med"/>
+                      <a:tailEnd type="none" w="med" len="med"/>
+                    </a:lnB>
+                    <a:solidFill>
+                      <a:srgbClr val="FFFFFF"/>
+                    </a:solidFill>
+                  </a:tcPr>
+                </a:tc>
+                <a:tc>
+                  <a:txBody>
+                    <a:bodyPr/>
+                    <a:lstStyle/>
+                    <a:p>
+                      <a:pPr algn="ctr" indent="0" marL="0">
+                        <a:buNone/>
+                      </a:pPr>
+                      <a:r>
+                        <a:rPr lang="en-US" sz="700" b="1" dirty="0">
+                          <a:solidFill>
+                            <a:srgbClr val="8A6200"/>
+                          </a:solidFill>
+                          <a:latin typeface="Calibri" pitchFamily="34" charset="0"/>
+                          <a:ea typeface="Calibri" pitchFamily="34" charset="-122"/>
+                          <a:cs typeface="Calibri" pitchFamily="34" charset="-120"/>
+                        </a:rPr>
+                        <a:t>101.4 ms</a:t>
+                      </a:r>
+                      <a:endParaRPr lang="en-US" sz="700" dirty="0">
+                        <a:latin typeface="Calibri" charset="0"/>
+                        <a:ea typeface="Calibri" charset="0"/>
+                        <a:cs typeface="Calibri" charset="0"/>
+                      </a:endParaRPr>
+                    </a:p>
+                  </a:txBody>
+                  <a:tcPr marL="91440" marR="91440" marT="45720" marB="45720">
+                    <a:lnL w="6350" cap="flat" cmpd="sng" algn="ctr">
+                      <a:solidFill>
+                        <a:srgbClr val="BFCFE8"/>
+                      </a:solidFill>
+                      <a:prstDash val="solid"/>
+                      <a:round/>
+                      <a:headEnd type="none" w="med" len="med"/>
+                      <a:tailEnd type="none" w="med" len="med"/>
+                    </a:lnL>
+                    <a:lnR w="6350" cap="flat" cmpd="sng" algn="ctr">
+                      <a:solidFill>
+                        <a:srgbClr val="BFCFE8"/>
+                      </a:solidFill>
+                      <a:prstDash val="solid"/>
+                      <a:round/>
+                      <a:headEnd type="none" w="med" len="med"/>
+                      <a:tailEnd type="none" w="med" len="med"/>
+                    </a:lnR>
+                    <a:lnT w="6350" cap="flat" cmpd="sng" algn="ctr">
+                      <a:solidFill>
+                        <a:srgbClr val="BFCFE8"/>
+                      </a:solidFill>
+                      <a:prstDash val="solid"/>
+                      <a:round/>
+                      <a:headEnd type="none" w="med" len="med"/>
+                      <a:tailEnd type="none" w="med" len="med"/>
+                    </a:lnT>
+                    <a:lnB w="6350" cap="flat" cmpd="sng" algn="ctr">
+                      <a:solidFill>
+                        <a:srgbClr val="BFCFE8"/>
+                      </a:solidFill>
+                      <a:prstDash val="solid"/>
+                      <a:round/>
+                      <a:headEnd type="none" w="med" len="med"/>
+                      <a:tailEnd type="none" w="med" len="med"/>
+                    </a:lnB>
+                    <a:solidFill>
+                      <a:srgbClr val="FFFFFF"/>
+                    </a:solidFill>
+                  </a:tcPr>
+                </a:tc>
+                <a:tc>
+                  <a:txBody>
+                    <a:bodyPr/>
+                    <a:lstStyle/>
+                    <a:p>
+                      <a:pPr algn="ctr" indent="0" marL="0">
+                        <a:buNone/>
+                      </a:pPr>
+                      <a:r>
+                        <a:rPr lang="en-US" sz="700" dirty="0">
+                          <a:solidFill>
+                            <a:srgbClr val="555555"/>
+                          </a:solidFill>
+                          <a:latin typeface="Calibri" pitchFamily="34" charset="0"/>
+                          <a:ea typeface="Calibri" pitchFamily="34" charset="-122"/>
+                          <a:cs typeface="Calibri" pitchFamily="34" charset="-120"/>
+                        </a:rPr>
+                        <a:t>1.09× faster</a:t>
+                      </a:r>
+                      <a:endParaRPr lang="en-US" sz="700" dirty="0">
+                        <a:latin typeface="Calibri" charset="0"/>
+                        <a:ea typeface="Calibri" charset="0"/>
+                        <a:cs typeface="Calibri" charset="0"/>
+                      </a:endParaRPr>
+                    </a:p>
+                  </a:txBody>
+                  <a:tcPr marL="91440" marR="91440" marT="45720" marB="45720">
+                    <a:lnL w="6350" cap="flat" cmpd="sng" algn="ctr">
+                      <a:solidFill>
+                        <a:srgbClr val="BFCFE8"/>
+                      </a:solidFill>
+                      <a:prstDash val="solid"/>
+                      <a:round/>
+                      <a:headEnd type="none" w="med" len="med"/>
+                      <a:tailEnd type="none" w="med" len="med"/>
+                    </a:lnL>
+                    <a:lnR w="6350" cap="flat" cmpd="sng" algn="ctr">
+                      <a:solidFill>
+                        <a:srgbClr val="BFCFE8"/>
+                      </a:solidFill>
+                      <a:prstDash val="solid"/>
+                      <a:round/>
+                      <a:headEnd type="none" w="med" len="med"/>
+                      <a:tailEnd type="none" w="med" len="med"/>
+                    </a:lnR>
+                    <a:lnT w="6350" cap="flat" cmpd="sng" algn="ctr">
+                      <a:solidFill>
+                        <a:srgbClr val="BFCFE8"/>
+                      </a:solidFill>
+                      <a:prstDash val="solid"/>
+                      <a:round/>
+                      <a:headEnd type="none" w="med" len="med"/>
+                      <a:tailEnd type="none" w="med" len="med"/>
+                    </a:lnT>
+                    <a:lnB w="6350" cap="flat" cmpd="sng" algn="ctr">
+                      <a:solidFill>
+                        <a:srgbClr val="BFCFE8"/>
+                      </a:solidFill>
+                      <a:prstDash val="solid"/>
+                      <a:round/>
+                      <a:headEnd type="none" w="med" len="med"/>
+                      <a:tailEnd type="none" w="med" len="med"/>
+                    </a:lnB>
+                    <a:solidFill>
+                      <a:srgbClr val="FFFFFF"/>
+                    </a:solidFill>
+                  </a:tcPr>
+                </a:tc>
+              </a:tr>
+              <a:tr h="164592">
+                <a:tc>
+                  <a:txBody>
+                    <a:bodyPr/>
+                    <a:lstStyle/>
+                    <a:p>
+                      <a:pPr algn="l" indent="0" marL="0">
+                        <a:buNone/>
+                      </a:pPr>
+                      <a:r>
+                        <a:rPr lang="en-US" sz="700" dirty="0">
+                          <a:solidFill>
+                            <a:srgbClr val="555555"/>
+                          </a:solidFill>
+                          <a:latin typeface="Calibri" pitchFamily="34" charset="0"/>
+                          <a:ea typeface="Calibri" pitchFamily="34" charset="-122"/>
+                          <a:cs typeface="Calibri" pitchFamily="34" charset="-120"/>
+                        </a:rPr>
+                        <a:t>L≥559  (both CPU-bnd)</a:t>
+                      </a:r>
+                      <a:endParaRPr lang="en-US" sz="700" dirty="0">
+                        <a:latin typeface="Calibri" charset="0"/>
+                        <a:ea typeface="Calibri" charset="0"/>
+                        <a:cs typeface="Calibri" charset="0"/>
+                      </a:endParaRPr>
+                    </a:p>
+                  </a:txBody>
+                  <a:tcPr marL="91440" marR="91440" marT="45720" marB="45720">
+                    <a:lnL w="6350" cap="flat" cmpd="sng" algn="ctr">
+                      <a:solidFill>
+                        <a:srgbClr val="BFCFE8"/>
+                      </a:solidFill>
+                      <a:prstDash val="solid"/>
+                      <a:round/>
+                      <a:headEnd type="none" w="med" len="med"/>
+                      <a:tailEnd type="none" w="med" len="med"/>
+                    </a:lnL>
+                    <a:lnR w="6350" cap="flat" cmpd="sng" algn="ctr">
+                      <a:solidFill>
+                        <a:srgbClr val="BFCFE8"/>
+                      </a:solidFill>
+                      <a:prstDash val="solid"/>
+                      <a:round/>
+                      <a:headEnd type="none" w="med" len="med"/>
+                      <a:tailEnd type="none" w="med" len="med"/>
+                    </a:lnR>
+                    <a:lnT w="6350" cap="flat" cmpd="sng" algn="ctr">
+                      <a:solidFill>
+                        <a:srgbClr val="BFCFE8"/>
+                      </a:solidFill>
+                      <a:prstDash val="solid"/>
+                      <a:round/>
+                      <a:headEnd type="none" w="med" len="med"/>
+                      <a:tailEnd type="none" w="med" len="med"/>
+                    </a:lnT>
+                    <a:lnB w="6350" cap="flat" cmpd="sng" algn="ctr">
+                      <a:solidFill>
+                        <a:srgbClr val="BFCFE8"/>
+                      </a:solidFill>
+                      <a:prstDash val="solid"/>
+                      <a:round/>
+                      <a:headEnd type="none" w="med" len="med"/>
+                      <a:tailEnd type="none" w="med" len="med"/>
+                    </a:lnB>
+                    <a:solidFill>
+                      <a:srgbClr val="EBF3FC"/>
+                    </a:solidFill>
+                  </a:tcPr>
+                </a:tc>
+                <a:tc>
+                  <a:txBody>
+                    <a:bodyPr/>
+                    <a:lstStyle/>
+                    <a:p>
+                      <a:pPr algn="ctr" indent="0" marL="0">
+                        <a:buNone/>
+                      </a:pPr>
+                      <a:r>
+                        <a:rPr lang="en-US" sz="700" b="1" dirty="0">
+                          <a:solidFill>
+                            <a:srgbClr val="1A7A3C"/>
+                          </a:solidFill>
+                          <a:latin typeface="Calibri" pitchFamily="34" charset="0"/>
+                          <a:ea typeface="Calibri" pitchFamily="34" charset="-122"/>
+                          <a:cs typeface="Calibri" pitchFamily="34" charset="-120"/>
+                        </a:rPr>
+                        <a:t>~405 ms / 2K-tok</a:t>
+                      </a:r>
+                      <a:endParaRPr lang="en-US" sz="700" dirty="0">
+                        <a:latin typeface="Calibri" charset="0"/>
+                        <a:ea typeface="Calibri" charset="0"/>
+                        <a:cs typeface="Calibri" charset="0"/>
+                      </a:endParaRPr>
+                    </a:p>
+                  </a:txBody>
+                  <a:tcPr marL="91440" marR="91440" marT="45720" marB="45720">
+                    <a:lnL w="6350" cap="flat" cmpd="sng" algn="ctr">
+                      <a:solidFill>
+                        <a:srgbClr val="BFCFE8"/>
+                      </a:solidFill>
+                      <a:prstDash val="solid"/>
+                      <a:round/>
+                      <a:headEnd type="none" w="med" len="med"/>
+                      <a:tailEnd type="none" w="med" len="med"/>
+                    </a:lnL>
+                    <a:lnR w="6350" cap="flat" cmpd="sng" algn="ctr">
+                      <a:solidFill>
+                        <a:srgbClr val="BFCFE8"/>
+                      </a:solidFill>
+                      <a:prstDash val="solid"/>
+                      <a:round/>
+                      <a:headEnd type="none" w="med" len="med"/>
+                      <a:tailEnd type="none" w="med" len="med"/>
+                    </a:lnR>
+                    <a:lnT w="6350" cap="flat" cmpd="sng" algn="ctr">
+                      <a:solidFill>
+                        <a:srgbClr val="BFCFE8"/>
+                      </a:solidFill>
+                      <a:prstDash val="solid"/>
+                      <a:round/>
+                      <a:headEnd type="none" w="med" len="med"/>
+                      <a:tailEnd type="none" w="med" len="med"/>
+                    </a:lnT>
+                    <a:lnB w="6350" cap="flat" cmpd="sng" algn="ctr">
+                      <a:solidFill>
+                        <a:srgbClr val="BFCFE8"/>
+                      </a:solidFill>
+                      <a:prstDash val="solid"/>
+                      <a:round/>
+                      <a:headEnd type="none" w="med" len="med"/>
+                      <a:tailEnd type="none" w="med" len="med"/>
+                    </a:lnB>
+                    <a:solidFill>
+                      <a:srgbClr val="EBF3FC"/>
+                    </a:solidFill>
+                  </a:tcPr>
+                </a:tc>
+                <a:tc>
+                  <a:txBody>
+                    <a:bodyPr/>
+                    <a:lstStyle/>
+                    <a:p>
+                      <a:pPr algn="ctr" indent="0" marL="0">
+                        <a:buNone/>
+                      </a:pPr>
+                      <a:r>
+                        <a:rPr lang="en-US" sz="700" b="1" dirty="0">
+                          <a:solidFill>
+                            <a:srgbClr val="1A7A3C"/>
+                          </a:solidFill>
+                          <a:latin typeface="Calibri" pitchFamily="34" charset="0"/>
+                          <a:ea typeface="Calibri" pitchFamily="34" charset="-122"/>
+                          <a:cs typeface="Calibri" pitchFamily="34" charset="-120"/>
+                        </a:rPr>
+                        <a:t>~405 ms / 2K-tok</a:t>
+                      </a:r>
+                      <a:endParaRPr lang="en-US" sz="700" dirty="0">
+                        <a:latin typeface="Calibri" charset="0"/>
+                        <a:ea typeface="Calibri" charset="0"/>
+                        <a:cs typeface="Calibri" charset="0"/>
+                      </a:endParaRPr>
+                    </a:p>
+                  </a:txBody>
+                  <a:tcPr marL="91440" marR="91440" marT="45720" marB="45720">
+                    <a:lnL w="6350" cap="flat" cmpd="sng" algn="ctr">
+                      <a:solidFill>
+                        <a:srgbClr val="BFCFE8"/>
+                      </a:solidFill>
+                      <a:prstDash val="solid"/>
+                      <a:round/>
+                      <a:headEnd type="none" w="med" len="med"/>
+                      <a:tailEnd type="none" w="med" len="med"/>
+                    </a:lnL>
+                    <a:lnR w="6350" cap="flat" cmpd="sng" algn="ctr">
+                      <a:solidFill>
+                        <a:srgbClr val="BFCFE8"/>
+                      </a:solidFill>
+                      <a:prstDash val="solid"/>
+                      <a:round/>
+                      <a:headEnd type="none" w="med" len="med"/>
+                      <a:tailEnd type="none" w="med" len="med"/>
+                    </a:lnR>
+                    <a:lnT w="6350" cap="flat" cmpd="sng" algn="ctr">
+                      <a:solidFill>
+                        <a:srgbClr val="BFCFE8"/>
+                      </a:solidFill>
+                      <a:prstDash val="solid"/>
+                      <a:round/>
+                      <a:headEnd type="none" w="med" len="med"/>
+                      <a:tailEnd type="none" w="med" len="med"/>
+                    </a:lnT>
+                    <a:lnB w="6350" cap="flat" cmpd="sng" algn="ctr">
+                      <a:solidFill>
+                        <a:srgbClr val="BFCFE8"/>
+                      </a:solidFill>
+                      <a:prstDash val="solid"/>
+                      <a:round/>
+                      <a:headEnd type="none" w="med" len="med"/>
+                      <a:tailEnd type="none" w="med" len="med"/>
+                    </a:lnB>
+                    <a:solidFill>
+                      <a:srgbClr val="EBF3FC"/>
+                    </a:solidFill>
+                  </a:tcPr>
+                </a:tc>
+                <a:tc>
+                  <a:txBody>
+                    <a:bodyPr/>
+                    <a:lstStyle/>
+                    <a:p>
+                      <a:pPr algn="ctr" indent="0" marL="0">
+                        <a:buNone/>
+                      </a:pPr>
+                      <a:r>
+                        <a:rPr lang="en-US" sz="700" dirty="0">
+                          <a:solidFill>
+                            <a:srgbClr val="555555"/>
+                          </a:solidFill>
+                          <a:latin typeface="Calibri" pitchFamily="34" charset="0"/>
+                          <a:ea typeface="Calibri" pitchFamily="34" charset="-122"/>
+                          <a:cs typeface="Calibri" pitchFamily="34" charset="-120"/>
+                        </a:rPr>
+                        <a:t>1.0× (tied)</a:t>
+                      </a:r>
+                      <a:endParaRPr lang="en-US" sz="700" dirty="0">
                         <a:latin typeface="Calibri" charset="0"/>
                         <a:ea typeface="Calibri" charset="0"/>
                         <a:cs typeface="Calibri" charset="0"/>
@@ -5777,118 +6373,7 @@
       </p:graphicFrame>
       <p:sp>
         <p:nvSpPr>
-          <p:cNvPr id="23" name="Text 19"/>
-          <p:cNvSpPr/>
-          <p:nvPr/>
-        </p:nvSpPr>
-        <p:spPr>
-          <a:xfrm>
-            <a:off x="3840480" y="3557016"/>
-            <a:ext cx="3931920" cy="256032"/>
-          </a:xfrm>
-          <a:prstGeom prst="rect">
-            <a:avLst/>
-          </a:prstGeom>
-          <a:noFill/>
-          <a:ln/>
-        </p:spPr>
-        <p:txBody>
-          <a:bodyPr wrap="square" lIns="0" tIns="0" rIns="0" bIns="0" rtlCol="0" anchor="t"/>
-          <a:lstStyle/>
-          <a:p>
-            <a:pPr indent="0" marL="0">
-              <a:buNone/>
-            </a:pPr>
-            <a:r>
-              <a:rPr lang="en-US" sz="750" b="1" dirty="0">
-                <a:solidFill>
-                  <a:srgbClr val="2458A4"/>
-                </a:solidFill>
-                <a:latin typeface="Calibri" pitchFamily="34" charset="0"/>
-                <a:ea typeface="Calibri" pitchFamily="34" charset="-122"/>
-                <a:cs typeface="Calibri" pitchFamily="34" charset="-120"/>
-              </a:rPr>
-              <a:t>New(240T): </a:t>
-            </a:r>
-            <a:pPr indent="0" marL="0">
-              <a:buNone/>
-            </a:pPr>
-            <a:r>
-              <a:rPr lang="en-US" sz="750" dirty="0">
-                <a:solidFill>
-                  <a:srgbClr val="555555"/>
-                </a:solidFill>
-                <a:latin typeface="Calibri" pitchFamily="34" charset="0"/>
-                <a:ea typeface="Calibri" pitchFamily="34" charset="-122"/>
-                <a:cs typeface="Calibri" pitchFamily="34" charset="-120"/>
-              </a:rPr>
-              <a:t>UFS5 C≥1,800 | NVMe C≥2,572 | </a:t>
-            </a:r>
-            <a:pPr indent="0" marL="0">
-              <a:buNone/>
-            </a:pPr>
-            <a:r>
-              <a:rPr lang="en-US" sz="750" b="1" dirty="0">
-                <a:solidFill>
-                  <a:srgbClr val="A06000"/>
-                </a:solidFill>
-                <a:latin typeface="Calibri" pitchFamily="34" charset="0"/>
-                <a:ea typeface="Calibri" pitchFamily="34" charset="-122"/>
-                <a:cs typeface="Calibri" pitchFamily="34" charset="-120"/>
-              </a:rPr>
-              <a:t>DGX(123T): </a:t>
-            </a:r>
-            <a:pPr indent="0" marL="0">
-              <a:buNone/>
-            </a:pPr>
-            <a:r>
-              <a:rPr lang="en-US" sz="750" dirty="0">
-                <a:solidFill>
-                  <a:srgbClr val="555555"/>
-                </a:solidFill>
-                <a:latin typeface="Calibri" pitchFamily="34" charset="0"/>
-                <a:ea typeface="Calibri" pitchFamily="34" charset="-122"/>
-                <a:cs typeface="Calibri" pitchFamily="34" charset="-120"/>
-              </a:rPr>
-              <a:t>UFS5 C≥922 | NVMe C≥1,318 | Ceil: </a:t>
-            </a:r>
-            <a:pPr indent="0" marL="0">
-              <a:buNone/>
-            </a:pPr>
-            <a:r>
-              <a:rPr lang="en-US" sz="750" b="1" dirty="0">
-                <a:solidFill>
-                  <a:srgbClr val="1A7A3C"/>
-                </a:solidFill>
-                <a:latin typeface="Calibri" pitchFamily="34" charset="0"/>
-                <a:ea typeface="Calibri" pitchFamily="34" charset="-122"/>
-                <a:cs typeface="Calibri" pitchFamily="34" charset="-120"/>
-              </a:rPr>
-              <a:t>9,445 / 4,840 tok/s</a:t>
-            </a:r>
-            <a:endParaRPr lang="en-US" sz="750" dirty="0"/>
-          </a:p>
-        </p:txBody>
-      </p:sp>
-      <p:graphicFrame>
-        <p:nvGraphicFramePr>
-          <p:cNvPr id="24" name="Chart 1" descr=""/>
-          <p:cNvGraphicFramePr/>
-          <p:nvPr/>
-        </p:nvGraphicFramePr>
-        <p:xfrm>
-          <a:off x="3840480" y="3767328"/>
-          <a:ext cx="3931920" cy="329184"/>
-        </p:xfrm>
-        <a:graphic xmlns:a="http://schemas.openxmlformats.org/drawingml/2006/main">
-          <a:graphicData uri="http://schemas.openxmlformats.org/drawingml/2006/chart">
-            <c:chart xmlns:c="http://schemas.openxmlformats.org/drawingml/2006/chart" r:id="rId2"/>
-          </a:graphicData>
-        </a:graphic>
-      </p:graphicFrame>
-      <p:sp>
-        <p:nvSpPr>
-          <p:cNvPr id="25" name="Shape 20"/>
+          <p:cNvPr id="24" name="Shape 19"/>
           <p:cNvSpPr/>
           <p:nvPr/>
         </p:nvSpPr>
@@ -5913,7 +6398,7 @@
       </p:sp>
       <p:sp>
         <p:nvSpPr>
-          <p:cNvPr id="26" name="Shape 21"/>
+          <p:cNvPr id="25" name="Shape 20"/>
           <p:cNvSpPr/>
           <p:nvPr/>
         </p:nvSpPr>
@@ -5938,7 +6423,7 @@
       </p:sp>
       <p:sp>
         <p:nvSpPr>
-          <p:cNvPr id="27" name="Shape 22"/>
+          <p:cNvPr id="26" name="Shape 21"/>
           <p:cNvSpPr/>
           <p:nvPr/>
         </p:nvSpPr>
@@ -5965,7 +6450,7 @@
       </p:sp>
       <p:sp>
         <p:nvSpPr>
-          <p:cNvPr id="28" name="Text 23"/>
+          <p:cNvPr id="27" name="Text 22"/>
           <p:cNvSpPr/>
           <p:nvPr/>
         </p:nvSpPr>
@@ -6004,7 +6489,7 @@
       </p:sp>
       <p:sp>
         <p:nvSpPr>
-          <p:cNvPr id="29" name="Text 24"/>
+          <p:cNvPr id="28" name="Text 23"/>
           <p:cNvSpPr/>
           <p:nvPr/>
         </p:nvSpPr>
@@ -6043,7 +6528,7 @@
       </p:sp>
       <p:sp>
         <p:nvSpPr>
-          <p:cNvPr id="30" name="Shape 25"/>
+          <p:cNvPr id="29" name="Shape 24"/>
           <p:cNvSpPr/>
           <p:nvPr/>
         </p:nvSpPr>
@@ -6068,7 +6553,7 @@
       </p:sp>
       <p:sp>
         <p:nvSpPr>
-          <p:cNvPr id="31" name="Text 26"/>
+          <p:cNvPr id="30" name="Text 25"/>
           <p:cNvSpPr/>
           <p:nvPr/>
         </p:nvSpPr>
@@ -6166,7 +6651,7 @@
       </p:sp>
       <p:graphicFrame>
         <p:nvGraphicFramePr>
-          <p:cNvPr id="3" name="Table 1"/>
+          <p:cNvPr id="4" name="Table 2"/>
           <p:cNvGraphicFramePr>
             <a:graphicFrameLocks noGrp="1"/>
           </p:cNvGraphicFramePr>
@@ -9070,7 +9555,7 @@
       </p:graphicFrame>
       <p:sp>
         <p:nvSpPr>
-          <p:cNvPr id="33" name="Text 27"/>
+          <p:cNvPr id="32" name="Text 26"/>
           <p:cNvSpPr/>
           <p:nvPr/>
         </p:nvSpPr>
@@ -9165,7 +9650,7 @@
       </p:sp>
       <p:graphicFrame>
         <p:nvGraphicFramePr>
-          <p:cNvPr id="34" name="Chart 2" descr=""/>
+          <p:cNvPr id="33" name="Chart 1" descr=""/>
           <p:cNvGraphicFramePr/>
           <p:nvPr/>
         </p:nvGraphicFramePr>
@@ -9175,13 +9660,13 @@
         </p:xfrm>
         <a:graphic xmlns:a="http://schemas.openxmlformats.org/drawingml/2006/main">
           <a:graphicData uri="http://schemas.openxmlformats.org/drawingml/2006/chart">
-            <c:chart xmlns:c="http://schemas.openxmlformats.org/drawingml/2006/chart" r:id="rId3"/>
+            <c:chart xmlns:c="http://schemas.openxmlformats.org/drawingml/2006/chart" r:id="rId2"/>
           </a:graphicData>
         </a:graphic>
       </p:graphicFrame>
       <p:sp>
         <p:nvSpPr>
-          <p:cNvPr id="35" name="Shape 28"/>
+          <p:cNvPr id="34" name="Shape 27"/>
           <p:cNvSpPr/>
           <p:nvPr/>
         </p:nvSpPr>
@@ -9206,7 +9691,7 @@
       </p:sp>
       <p:sp>
         <p:nvSpPr>
-          <p:cNvPr id="36" name="Text 29"/>
+          <p:cNvPr id="35" name="Text 28"/>
           <p:cNvSpPr/>
           <p:nvPr/>
         </p:nvSpPr>
@@ -9245,7 +9730,7 @@
       </p:sp>
       <p:graphicFrame>
         <p:nvGraphicFramePr>
-          <p:cNvPr id="4" name="Table 2"/>
+          <p:cNvPr id="5" name="Table 3"/>
           <p:cNvGraphicFramePr>
             <a:graphicFrameLocks noGrp="1"/>
           </p:cNvGraphicFramePr>
@@ -9272,7 +9757,7 @@
                 <a:gridCol w="1225296"/>
                 <a:gridCol w="5394960"/>
               </a:tblGrid>
-              <a:tr h="237744">
+              <a:tr h="201168">
                 <a:tc>
                   <a:txBody>
                     <a:bodyPr/>
@@ -9282,7 +9767,7 @@
                         <a:buNone/>
                       </a:pPr>
                       <a:r>
-                        <a:rPr lang="en-US" sz="850" b="1" dirty="0">
+                        <a:rPr lang="en-US" sz="800" b="1" dirty="0">
                           <a:solidFill>
                             <a:srgbClr val="FFFFFF"/>
                           </a:solidFill>
@@ -9292,7 +9777,7 @@
                         </a:rPr>
                         <a:t>Scenario</a:t>
                       </a:r>
-                      <a:endParaRPr lang="en-US" sz="850" dirty="0">
+                      <a:endParaRPr lang="en-US" sz="800" dirty="0">
                         <a:latin typeface="Calibri" charset="0"/>
                         <a:ea typeface="Calibri" charset="0"/>
                         <a:cs typeface="Calibri" charset="0"/>
@@ -9350,7 +9835,7 @@
                         <a:buNone/>
                       </a:pPr>
                       <a:r>
-                        <a:rPr lang="en-US" sz="850" b="1" dirty="0">
+                        <a:rPr lang="en-US" sz="800" b="1" dirty="0">
                           <a:solidFill>
                             <a:srgbClr val="FFFFFF"/>
                           </a:solidFill>
@@ -9360,7 +9845,7 @@
                         </a:rPr>
                         <a:t>PCIe 5.0 (15.75 GB/s)</a:t>
                       </a:r>
-                      <a:endParaRPr lang="en-US" sz="850" dirty="0">
+                      <a:endParaRPr lang="en-US" sz="800" dirty="0">
                         <a:latin typeface="Calibri" charset="0"/>
                         <a:ea typeface="Calibri" charset="0"/>
                         <a:cs typeface="Calibri" charset="0"/>
@@ -9418,7 +9903,7 @@
                         <a:buNone/>
                       </a:pPr>
                       <a:r>
-                        <a:rPr lang="en-US" sz="850" b="1" dirty="0">
+                        <a:rPr lang="en-US" sz="800" b="1" dirty="0">
                           <a:solidFill>
                             <a:srgbClr val="FFFFFF"/>
                           </a:solidFill>
@@ -9428,7 +9913,7 @@
                         </a:rPr>
                         <a:t>PCIe 6.0 (32 GB/s)</a:t>
                       </a:r>
-                      <a:endParaRPr lang="en-US" sz="850" dirty="0">
+                      <a:endParaRPr lang="en-US" sz="800" dirty="0">
                         <a:latin typeface="Calibri" charset="0"/>
                         <a:ea typeface="Calibri" charset="0"/>
                         <a:cs typeface="Calibri" charset="0"/>
@@ -9486,7 +9971,7 @@
                         <a:buNone/>
                       </a:pPr>
                       <a:r>
-                        <a:rPr lang="en-US" sz="850" b="1" dirty="0">
+                        <a:rPr lang="en-US" sz="800" b="1" dirty="0">
                           <a:solidFill>
                             <a:srgbClr val="FFFFFF"/>
                           </a:solidFill>
@@ -9496,7 +9981,7 @@
                         </a:rPr>
                         <a:t>Improvement</a:t>
                       </a:r>
-                      <a:endParaRPr lang="en-US" sz="850" dirty="0">
+                      <a:endParaRPr lang="en-US" sz="800" dirty="0">
                         <a:latin typeface="Calibri" charset="0"/>
                         <a:ea typeface="Calibri" charset="0"/>
                         <a:cs typeface="Calibri" charset="0"/>
@@ -9554,7 +10039,7 @@
                         <a:buNone/>
                       </a:pPr>
                       <a:r>
-                        <a:rPr lang="en-US" sz="850" b="1" dirty="0">
+                        <a:rPr lang="en-US" sz="800" b="1" dirty="0">
                           <a:solidFill>
                             <a:srgbClr val="FFFFFF"/>
                           </a:solidFill>
@@ -9564,7 +10049,7 @@
                         </a:rPr>
                         <a:t>Bottleneck</a:t>
                       </a:r>
-                      <a:endParaRPr lang="en-US" sz="850" dirty="0">
+                      <a:endParaRPr lang="en-US" sz="800" dirty="0">
                         <a:latin typeface="Calibri" charset="0"/>
                         <a:ea typeface="Calibri" charset="0"/>
                         <a:cs typeface="Calibri" charset="0"/>
@@ -9614,7 +10099,7 @@
                   </a:tcPr>
                 </a:tc>
               </a:tr>
-              <a:tr h="237744">
+              <a:tr h="201168">
                 <a:tc>
                   <a:txBody>
                     <a:bodyPr/>
@@ -9624,7 +10109,7 @@
                         <a:buNone/>
                       </a:pPr>
                       <a:r>
-                        <a:rPr lang="en-US" sz="850" dirty="0">
+                        <a:rPr lang="en-US" sz="800" dirty="0">
                           <a:solidFill>
                             <a:srgbClr val="1B2A4A"/>
                           </a:solidFill>
@@ -9634,7 +10119,7 @@
                         </a:rPr>
                         <a:t>Cold Boot</a:t>
                       </a:r>
-                      <a:endParaRPr lang="en-US" sz="850" dirty="0">
+                      <a:endParaRPr lang="en-US" sz="800" dirty="0">
                         <a:latin typeface="Calibri" charset="0"/>
                         <a:ea typeface="Calibri" charset="0"/>
                         <a:cs typeface="Calibri" charset="0"/>
@@ -9692,7 +10177,7 @@
                         <a:buNone/>
                       </a:pPr>
                       <a:r>
-                        <a:rPr lang="en-US" sz="850" b="1" dirty="0">
+                        <a:rPr lang="en-US" sz="800" b="1" dirty="0">
                           <a:solidFill>
                             <a:srgbClr val="C84B00"/>
                           </a:solidFill>
@@ -9702,7 +10187,7 @@
                         </a:rPr>
                         <a:t>20.55 s</a:t>
                       </a:r>
-                      <a:endParaRPr lang="en-US" sz="850" dirty="0">
+                      <a:endParaRPr lang="en-US" sz="800" dirty="0">
                         <a:latin typeface="Calibri" charset="0"/>
                         <a:ea typeface="Calibri" charset="0"/>
                         <a:cs typeface="Calibri" charset="0"/>
@@ -9760,7 +10245,7 @@
                         <a:buNone/>
                       </a:pPr>
                       <a:r>
-                        <a:rPr lang="en-US" sz="850" b="1" dirty="0">
+                        <a:rPr lang="en-US" sz="800" b="1" dirty="0">
                           <a:solidFill>
                             <a:srgbClr val="1A7A3C"/>
                           </a:solidFill>
@@ -9770,7 +10255,7 @@
                         </a:rPr>
                         <a:t>10.12 s</a:t>
                       </a:r>
-                      <a:endParaRPr lang="en-US" sz="850" dirty="0">
+                      <a:endParaRPr lang="en-US" sz="800" dirty="0">
                         <a:latin typeface="Calibri" charset="0"/>
                         <a:ea typeface="Calibri" charset="0"/>
                         <a:cs typeface="Calibri" charset="0"/>
@@ -9828,7 +10313,7 @@
                         <a:buNone/>
                       </a:pPr>
                       <a:r>
-                        <a:rPr lang="en-US" sz="850" b="1" dirty="0">
+                        <a:rPr lang="en-US" sz="800" b="1" dirty="0">
                           <a:solidFill>
                             <a:srgbClr val="1A7A3C"/>
                           </a:solidFill>
@@ -9838,7 +10323,7 @@
                         </a:rPr>
                         <a:t>2.03× faster</a:t>
                       </a:r>
-                      <a:endParaRPr lang="en-US" sz="850" dirty="0">
+                      <a:endParaRPr lang="en-US" sz="800" dirty="0">
                         <a:latin typeface="Calibri" charset="0"/>
                         <a:ea typeface="Calibri" charset="0"/>
                         <a:cs typeface="Calibri" charset="0"/>
@@ -9896,7 +10381,7 @@
                         <a:buNone/>
                       </a:pPr>
                       <a:r>
-                        <a:rPr lang="en-US" sz="850" dirty="0">
+                        <a:rPr lang="en-US" sz="800" dirty="0">
                           <a:solidFill>
                             <a:srgbClr val="555555"/>
                           </a:solidFill>
@@ -9906,7 +10391,7 @@
                         </a:rPr>
                         <a:t>Storage BW (I/O-bound both)</a:t>
                       </a:r>
-                      <a:endParaRPr lang="en-US" sz="850" dirty="0">
+                      <a:endParaRPr lang="en-US" sz="800" dirty="0">
                         <a:latin typeface="Calibri" charset="0"/>
                         <a:ea typeface="Calibri" charset="0"/>
                         <a:cs typeface="Calibri" charset="0"/>
@@ -9956,7 +10441,7 @@
                   </a:tcPr>
                 </a:tc>
               </a:tr>
-              <a:tr h="237744">
+              <a:tr h="201168">
                 <a:tc>
                   <a:txBody>
                     <a:bodyPr/>
@@ -9966,7 +10451,7 @@
                         <a:buNone/>
                       </a:pPr>
                       <a:r>
-                        <a:rPr lang="en-US" sz="850" dirty="0">
+                        <a:rPr lang="en-US" sz="800" dirty="0">
                           <a:solidFill>
                             <a:srgbClr val="1B2A4A"/>
                           </a:solidFill>
@@ -9976,7 +10461,7 @@
                         </a:rPr>
                         <a:t>Prefill C=128</a:t>
                       </a:r>
-                      <a:endParaRPr lang="en-US" sz="850" dirty="0">
+                      <a:endParaRPr lang="en-US" sz="800" dirty="0">
                         <a:latin typeface="Calibri" charset="0"/>
                         <a:ea typeface="Calibri" charset="0"/>
                         <a:cs typeface="Calibri" charset="0"/>
@@ -10034,7 +10519,7 @@
                         <a:buNone/>
                       </a:pPr>
                       <a:r>
-                        <a:rPr lang="en-US" sz="850" b="1" dirty="0">
+                        <a:rPr lang="en-US" sz="800" b="1" dirty="0">
                           <a:solidFill>
                             <a:srgbClr val="C84B00"/>
                           </a:solidFill>
@@ -10042,9 +10527,9 @@
                           <a:ea typeface="Calibri" pitchFamily="34" charset="-122"/>
                           <a:cs typeface="Calibri" pitchFamily="34" charset="-120"/>
                         </a:rPr>
-                        <a:t>403 tok/s</a:t>
-                      </a:r>
-                      <a:endParaRPr lang="en-US" sz="850" dirty="0">
+                        <a:t>1,158 tok/s</a:t>
+                      </a:r>
+                      <a:endParaRPr lang="en-US" sz="800" dirty="0">
                         <a:latin typeface="Calibri" charset="0"/>
                         <a:ea typeface="Calibri" charset="0"/>
                         <a:cs typeface="Calibri" charset="0"/>
@@ -10102,7 +10587,7 @@
                         <a:buNone/>
                       </a:pPr>
                       <a:r>
-                        <a:rPr lang="en-US" sz="850" b="1" dirty="0">
+                        <a:rPr lang="en-US" sz="800" b="1" dirty="0">
                           <a:solidFill>
                             <a:srgbClr val="1A7A3C"/>
                           </a:solidFill>
@@ -10110,9 +10595,9 @@
                           <a:ea typeface="Calibri" pitchFamily="34" charset="-122"/>
                           <a:cs typeface="Calibri" pitchFamily="34" charset="-120"/>
                         </a:rPr>
-                        <a:t>806 tok/s</a:t>
-                      </a:r>
-                      <a:endParaRPr lang="en-US" sz="850" dirty="0">
+                        <a:t>2,352 tok/s</a:t>
+                      </a:r>
+                      <a:endParaRPr lang="en-US" sz="800" dirty="0">
                         <a:latin typeface="Calibri" charset="0"/>
                         <a:ea typeface="Calibri" charset="0"/>
                         <a:cs typeface="Calibri" charset="0"/>
@@ -10170,7 +10655,7 @@
                         <a:buNone/>
                       </a:pPr>
                       <a:r>
-                        <a:rPr lang="en-US" sz="850" b="1" dirty="0">
+                        <a:rPr lang="en-US" sz="800" b="1" dirty="0">
                           <a:solidFill>
                             <a:srgbClr val="1A7A3C"/>
                           </a:solidFill>
@@ -10180,7 +10665,7 @@
                         </a:rPr>
                         <a:t>2.03×</a:t>
                       </a:r>
-                      <a:endParaRPr lang="en-US" sz="850" dirty="0">
+                      <a:endParaRPr lang="en-US" sz="800" dirty="0">
                         <a:latin typeface="Calibri" charset="0"/>
                         <a:ea typeface="Calibri" charset="0"/>
                         <a:cs typeface="Calibri" charset="0"/>
@@ -10238,7 +10723,7 @@
                         <a:buNone/>
                       </a:pPr>
                       <a:r>
-                        <a:rPr lang="en-US" sz="850" dirty="0">
+                        <a:rPr lang="en-US" sz="800" dirty="0">
                           <a:solidFill>
                             <a:srgbClr val="555555"/>
                           </a:solidFill>
@@ -10246,9 +10731,9 @@
                           <a:ea typeface="Calibri" pitchFamily="34" charset="-122"/>
                           <a:cs typeface="Calibri" pitchFamily="34" charset="-120"/>
                         </a:rPr>
-                        <a:t>GPU Mem BW-bound (C × BW / model_size)</a:t>
-                      </a:r>
-                      <a:endParaRPr lang="en-US" sz="850" dirty="0">
+                        <a:t>IO-bound (expert load/layer: PCIe5=2.57ms, PCIe6=1.27ms)</a:t>
+                      </a:r>
+                      <a:endParaRPr lang="en-US" sz="800" dirty="0">
                         <a:latin typeface="Calibri" charset="0"/>
                         <a:ea typeface="Calibri" charset="0"/>
                         <a:cs typeface="Calibri" charset="0"/>
@@ -10298,7 +10783,7 @@
                   </a:tcPr>
                 </a:tc>
               </a:tr>
-              <a:tr h="237744">
+              <a:tr h="201168">
                 <a:tc>
                   <a:txBody>
                     <a:bodyPr/>
@@ -10308,7 +10793,7 @@
                         <a:buNone/>
                       </a:pPr>
                       <a:r>
-                        <a:rPr lang="en-US" sz="850" dirty="0">
+                        <a:rPr lang="en-US" sz="800" dirty="0">
                           <a:solidFill>
                             <a:srgbClr val="1B2A4A"/>
                           </a:solidFill>
@@ -10316,9 +10801,9 @@
                           <a:ea typeface="Calibri" pitchFamily="34" charset="-122"/>
                           <a:cs typeface="Calibri" pitchFamily="34" charset="-120"/>
                         </a:rPr>
-                        <a:t>Prefill C=2,048 ★</a:t>
-                      </a:r>
-                      <a:endParaRPr lang="en-US" sz="850" dirty="0">
+                        <a:t>Prefill C≥559 ★</a:t>
+                      </a:r>
+                      <a:endParaRPr lang="en-US" sz="800" dirty="0">
                         <a:latin typeface="Calibri" charset="0"/>
                         <a:ea typeface="Calibri" charset="0"/>
                         <a:cs typeface="Calibri" charset="0"/>
@@ -10376,7 +10861,7 @@
                         <a:buNone/>
                       </a:pPr>
                       <a:r>
-                        <a:rPr lang="en-US" sz="850" b="1" dirty="0">
+                        <a:rPr lang="en-US" sz="800" b="1" dirty="0">
                           <a:solidFill>
                             <a:srgbClr val="C84B00"/>
                           </a:solidFill>
@@ -10384,9 +10869,9 @@
                           <a:ea typeface="Calibri" pitchFamily="34" charset="-122"/>
                           <a:cs typeface="Calibri" pitchFamily="34" charset="-120"/>
                         </a:rPr>
-                        <a:t>2,985 tok/s</a:t>
-                      </a:r>
-                      <a:endParaRPr lang="en-US" sz="850" dirty="0">
+                        <a:t>5,052 tok/s</a:t>
+                      </a:r>
+                      <a:endParaRPr lang="en-US" sz="800" dirty="0">
                         <a:latin typeface="Calibri" charset="0"/>
                         <a:ea typeface="Calibri" charset="0"/>
                         <a:cs typeface="Calibri" charset="0"/>
@@ -10444,7 +10929,7 @@
                         <a:buNone/>
                       </a:pPr>
                       <a:r>
-                        <a:rPr lang="en-US" sz="850" b="1" dirty="0">
+                        <a:rPr lang="en-US" sz="800" b="1" dirty="0">
                           <a:solidFill>
                             <a:srgbClr val="1A7A3C"/>
                           </a:solidFill>
@@ -10452,9 +10937,9 @@
                           <a:ea typeface="Calibri" pitchFamily="34" charset="-122"/>
                           <a:cs typeface="Calibri" pitchFamily="34" charset="-120"/>
                         </a:rPr>
-                        <a:t>2,985 tok/s</a:t>
-                      </a:r>
-                      <a:endParaRPr lang="en-US" sz="850" dirty="0">
+                        <a:t>5,052 tok/s</a:t>
+                      </a:r>
+                      <a:endParaRPr lang="en-US" sz="800" dirty="0">
                         <a:latin typeface="Calibri" charset="0"/>
                         <a:ea typeface="Calibri" charset="0"/>
                         <a:cs typeface="Calibri" charset="0"/>
@@ -10512,7 +10997,75 @@
                         <a:buNone/>
                       </a:pPr>
                       <a:r>
-                        <a:rPr lang="en-US" sz="850" b="1" dirty="0">
+                        <a:rPr lang="en-US" sz="800" b="1" dirty="0">
+                          <a:solidFill>
+                            <a:srgbClr val="1A7A3C"/>
+                          </a:solidFill>
+                          <a:latin typeface="Calibri" pitchFamily="34" charset="0"/>
+                          <a:ea typeface="Calibri" pitchFamily="34" charset="-122"/>
+                          <a:cs typeface="Calibri" pitchFamily="34" charset="-120"/>
+                        </a:rPr>
+                        <a:t>= CPU-bnd</a:t>
+                      </a:r>
+                      <a:endParaRPr lang="en-US" sz="800" dirty="0">
+                        <a:latin typeface="Calibri" charset="0"/>
+                        <a:ea typeface="Calibri" charset="0"/>
+                        <a:cs typeface="Calibri" charset="0"/>
+                      </a:endParaRPr>
+                    </a:p>
+                  </a:txBody>
+                  <a:tcPr marL="91440" marR="91440" marT="45720" marB="45720">
+                    <a:lnL w="6350" cap="flat" cmpd="sng" algn="ctr">
+                      <a:solidFill>
+                        <a:srgbClr val="BFCFE8"/>
+                      </a:solidFill>
+                      <a:prstDash val="solid"/>
+                      <a:round/>
+                      <a:headEnd type="none" w="med" len="med"/>
+                      <a:tailEnd type="none" w="med" len="med"/>
+                    </a:lnL>
+                    <a:lnR w="6350" cap="flat" cmpd="sng" algn="ctr">
+                      <a:solidFill>
+                        <a:srgbClr val="BFCFE8"/>
+                      </a:solidFill>
+                      <a:prstDash val="solid"/>
+                      <a:round/>
+                      <a:headEnd type="none" w="med" len="med"/>
+                      <a:tailEnd type="none" w="med" len="med"/>
+                    </a:lnR>
+                    <a:lnT w="6350" cap="flat" cmpd="sng" algn="ctr">
+                      <a:solidFill>
+                        <a:srgbClr val="BFCFE8"/>
+                      </a:solidFill>
+                      <a:prstDash val="solid"/>
+                      <a:round/>
+                      <a:headEnd type="none" w="med" len="med"/>
+                      <a:tailEnd type="none" w="med" len="med"/>
+                    </a:lnT>
+                    <a:lnB w="6350" cap="flat" cmpd="sng" algn="ctr">
+                      <a:solidFill>
+                        <a:srgbClr val="BFCFE8"/>
+                      </a:solidFill>
+                      <a:prstDash val="solid"/>
+                      <a:round/>
+                      <a:headEnd type="none" w="med" len="med"/>
+                      <a:tailEnd type="none" w="med" len="med"/>
+                    </a:lnB>
+                    <a:solidFill>
+                      <a:srgbClr val="FFFFFF"/>
+                    </a:solidFill>
+                  </a:tcPr>
+                </a:tc>
+                <a:tc>
+                  <a:txBody>
+                    <a:bodyPr/>
+                    <a:lstStyle/>
+                    <a:p>
+                      <a:pPr algn="l" indent="0" marL="0">
+                        <a:buNone/>
+                      </a:pPr>
+                      <a:r>
+                        <a:rPr lang="en-US" sz="800" dirty="0">
                           <a:solidFill>
                             <a:srgbClr val="555555"/>
                           </a:solidFill>
@@ -10520,9 +11073,9 @@
                           <a:ea typeface="Calibri" pitchFamily="34" charset="-122"/>
                           <a:cs typeface="Calibri" pitchFamily="34" charset="-120"/>
                         </a:rPr>
-                        <a:t>= Compute</a:t>
-                      </a:r>
-                      <a:endParaRPr lang="en-US" sz="850" dirty="0">
+                        <a:t>Compute ceiling: 123T ÷ (43×566M) = 5,052 tok/s (tied)</a:t>
+                      </a:r>
+                      <a:endParaRPr lang="en-US" sz="800" dirty="0">
                         <a:latin typeface="Calibri" charset="0"/>
                         <a:ea typeface="Calibri" charset="0"/>
                         <a:cs typeface="Calibri" charset="0"/>
@@ -10571,6 +11124,8 @@
                     </a:solidFill>
                   </a:tcPr>
                 </a:tc>
+              </a:tr>
+              <a:tr h="201168">
                 <a:tc>
                   <a:txBody>
                     <a:bodyPr/>
@@ -10580,7 +11135,279 @@
                         <a:buNone/>
                       </a:pPr>
                       <a:r>
-                        <a:rPr lang="en-US" sz="850" dirty="0">
+                        <a:rPr lang="en-US" sz="800" dirty="0">
+                          <a:solidFill>
+                            <a:srgbClr val="1B2A4A"/>
+                          </a:solidFill>
+                          <a:latin typeface="Calibri" pitchFamily="34" charset="0"/>
+                          <a:ea typeface="Calibri" pitchFamily="34" charset="-122"/>
+                          <a:cs typeface="Calibri" pitchFamily="34" charset="-120"/>
+                        </a:rPr>
+                        <a:t>Decode 0% hot</a:t>
+                      </a:r>
+                      <a:endParaRPr lang="en-US" sz="800" dirty="0">
+                        <a:latin typeface="Calibri" charset="0"/>
+                        <a:ea typeface="Calibri" charset="0"/>
+                        <a:cs typeface="Calibri" charset="0"/>
+                      </a:endParaRPr>
+                    </a:p>
+                  </a:txBody>
+                  <a:tcPr marL="91440" marR="91440" marT="45720" marB="45720">
+                    <a:lnL w="6350" cap="flat" cmpd="sng" algn="ctr">
+                      <a:solidFill>
+                        <a:srgbClr val="BFCFE8"/>
+                      </a:solidFill>
+                      <a:prstDash val="solid"/>
+                      <a:round/>
+                      <a:headEnd type="none" w="med" len="med"/>
+                      <a:tailEnd type="none" w="med" len="med"/>
+                    </a:lnL>
+                    <a:lnR w="6350" cap="flat" cmpd="sng" algn="ctr">
+                      <a:solidFill>
+                        <a:srgbClr val="BFCFE8"/>
+                      </a:solidFill>
+                      <a:prstDash val="solid"/>
+                      <a:round/>
+                      <a:headEnd type="none" w="med" len="med"/>
+                      <a:tailEnd type="none" w="med" len="med"/>
+                    </a:lnR>
+                    <a:lnT w="6350" cap="flat" cmpd="sng" algn="ctr">
+                      <a:solidFill>
+                        <a:srgbClr val="BFCFE8"/>
+                      </a:solidFill>
+                      <a:prstDash val="solid"/>
+                      <a:round/>
+                      <a:headEnd type="none" w="med" len="med"/>
+                      <a:tailEnd type="none" w="med" len="med"/>
+                    </a:lnT>
+                    <a:lnB w="6350" cap="flat" cmpd="sng" algn="ctr">
+                      <a:solidFill>
+                        <a:srgbClr val="BFCFE8"/>
+                      </a:solidFill>
+                      <a:prstDash val="solid"/>
+                      <a:round/>
+                      <a:headEnd type="none" w="med" len="med"/>
+                      <a:tailEnd type="none" w="med" len="med"/>
+                    </a:lnB>
+                    <a:solidFill>
+                      <a:srgbClr val="FFFFFF"/>
+                    </a:solidFill>
+                  </a:tcPr>
+                </a:tc>
+                <a:tc>
+                  <a:txBody>
+                    <a:bodyPr/>
+                    <a:lstStyle/>
+                    <a:p>
+                      <a:pPr algn="ctr" indent="0" marL="0">
+                        <a:buNone/>
+                      </a:pPr>
+                      <a:r>
+                        <a:rPr lang="en-US" sz="800" b="1" dirty="0">
+                          <a:solidFill>
+                            <a:srgbClr val="C84B00"/>
+                          </a:solidFill>
+                          <a:latin typeface="Calibri" pitchFamily="34" charset="0"/>
+                          <a:ea typeface="Calibri" pitchFamily="34" charset="-122"/>
+                          <a:cs typeface="Calibri" pitchFamily="34" charset="-120"/>
+                        </a:rPr>
+                        <a:t>9.1 tok/s</a:t>
+                      </a:r>
+                      <a:endParaRPr lang="en-US" sz="800" dirty="0">
+                        <a:latin typeface="Calibri" charset="0"/>
+                        <a:ea typeface="Calibri" charset="0"/>
+                        <a:cs typeface="Calibri" charset="0"/>
+                      </a:endParaRPr>
+                    </a:p>
+                  </a:txBody>
+                  <a:tcPr marL="91440" marR="91440" marT="45720" marB="45720">
+                    <a:lnL w="6350" cap="flat" cmpd="sng" algn="ctr">
+                      <a:solidFill>
+                        <a:srgbClr val="BFCFE8"/>
+                      </a:solidFill>
+                      <a:prstDash val="solid"/>
+                      <a:round/>
+                      <a:headEnd type="none" w="med" len="med"/>
+                      <a:tailEnd type="none" w="med" len="med"/>
+                    </a:lnL>
+                    <a:lnR w="6350" cap="flat" cmpd="sng" algn="ctr">
+                      <a:solidFill>
+                        <a:srgbClr val="BFCFE8"/>
+                      </a:solidFill>
+                      <a:prstDash val="solid"/>
+                      <a:round/>
+                      <a:headEnd type="none" w="med" len="med"/>
+                      <a:tailEnd type="none" w="med" len="med"/>
+                    </a:lnR>
+                    <a:lnT w="6350" cap="flat" cmpd="sng" algn="ctr">
+                      <a:solidFill>
+                        <a:srgbClr val="BFCFE8"/>
+                      </a:solidFill>
+                      <a:prstDash val="solid"/>
+                      <a:round/>
+                      <a:headEnd type="none" w="med" len="med"/>
+                      <a:tailEnd type="none" w="med" len="med"/>
+                    </a:lnT>
+                    <a:lnB w="6350" cap="flat" cmpd="sng" algn="ctr">
+                      <a:solidFill>
+                        <a:srgbClr val="BFCFE8"/>
+                      </a:solidFill>
+                      <a:prstDash val="solid"/>
+                      <a:round/>
+                      <a:headEnd type="none" w="med" len="med"/>
+                      <a:tailEnd type="none" w="med" len="med"/>
+                    </a:lnB>
+                    <a:solidFill>
+                      <a:srgbClr val="FFFFFF"/>
+                    </a:solidFill>
+                  </a:tcPr>
+                </a:tc>
+                <a:tc>
+                  <a:txBody>
+                    <a:bodyPr/>
+                    <a:lstStyle/>
+                    <a:p>
+                      <a:pPr algn="ctr" indent="0" marL="0">
+                        <a:buNone/>
+                      </a:pPr>
+                      <a:r>
+                        <a:rPr lang="en-US" sz="800" b="1" dirty="0">
+                          <a:solidFill>
+                            <a:srgbClr val="1A7A3C"/>
+                          </a:solidFill>
+                          <a:latin typeface="Calibri" pitchFamily="34" charset="0"/>
+                          <a:ea typeface="Calibri" pitchFamily="34" charset="-122"/>
+                          <a:cs typeface="Calibri" pitchFamily="34" charset="-120"/>
+                        </a:rPr>
+                        <a:t>18.4 tok/s</a:t>
+                      </a:r>
+                      <a:endParaRPr lang="en-US" sz="800" dirty="0">
+                        <a:latin typeface="Calibri" charset="0"/>
+                        <a:ea typeface="Calibri" charset="0"/>
+                        <a:cs typeface="Calibri" charset="0"/>
+                      </a:endParaRPr>
+                    </a:p>
+                  </a:txBody>
+                  <a:tcPr marL="91440" marR="91440" marT="45720" marB="45720">
+                    <a:lnL w="6350" cap="flat" cmpd="sng" algn="ctr">
+                      <a:solidFill>
+                        <a:srgbClr val="BFCFE8"/>
+                      </a:solidFill>
+                      <a:prstDash val="solid"/>
+                      <a:round/>
+                      <a:headEnd type="none" w="med" len="med"/>
+                      <a:tailEnd type="none" w="med" len="med"/>
+                    </a:lnL>
+                    <a:lnR w="6350" cap="flat" cmpd="sng" algn="ctr">
+                      <a:solidFill>
+                        <a:srgbClr val="BFCFE8"/>
+                      </a:solidFill>
+                      <a:prstDash val="solid"/>
+                      <a:round/>
+                      <a:headEnd type="none" w="med" len="med"/>
+                      <a:tailEnd type="none" w="med" len="med"/>
+                    </a:lnR>
+                    <a:lnT w="6350" cap="flat" cmpd="sng" algn="ctr">
+                      <a:solidFill>
+                        <a:srgbClr val="BFCFE8"/>
+                      </a:solidFill>
+                      <a:prstDash val="solid"/>
+                      <a:round/>
+                      <a:headEnd type="none" w="med" len="med"/>
+                      <a:tailEnd type="none" w="med" len="med"/>
+                    </a:lnT>
+                    <a:lnB w="6350" cap="flat" cmpd="sng" algn="ctr">
+                      <a:solidFill>
+                        <a:srgbClr val="BFCFE8"/>
+                      </a:solidFill>
+                      <a:prstDash val="solid"/>
+                      <a:round/>
+                      <a:headEnd type="none" w="med" len="med"/>
+                      <a:tailEnd type="none" w="med" len="med"/>
+                    </a:lnB>
+                    <a:solidFill>
+                      <a:srgbClr val="FFFFFF"/>
+                    </a:solidFill>
+                  </a:tcPr>
+                </a:tc>
+                <a:tc>
+                  <a:txBody>
+                    <a:bodyPr/>
+                    <a:lstStyle/>
+                    <a:p>
+                      <a:pPr algn="ctr" indent="0" marL="0">
+                        <a:buNone/>
+                      </a:pPr>
+                      <a:r>
+                        <a:rPr lang="en-US" sz="800" b="1" dirty="0">
+                          <a:solidFill>
+                            <a:srgbClr val="1A7A3C"/>
+                          </a:solidFill>
+                          <a:latin typeface="Calibri" pitchFamily="34" charset="0"/>
+                          <a:ea typeface="Calibri" pitchFamily="34" charset="-122"/>
+                          <a:cs typeface="Calibri" pitchFamily="34" charset="-120"/>
+                        </a:rPr>
+                        <a:t>2.03×</a:t>
+                      </a:r>
+                      <a:endParaRPr lang="en-US" sz="800" dirty="0">
+                        <a:latin typeface="Calibri" charset="0"/>
+                        <a:ea typeface="Calibri" charset="0"/>
+                        <a:cs typeface="Calibri" charset="0"/>
+                      </a:endParaRPr>
+                    </a:p>
+                  </a:txBody>
+                  <a:tcPr marL="91440" marR="91440" marT="45720" marB="45720">
+                    <a:lnL w="6350" cap="flat" cmpd="sng" algn="ctr">
+                      <a:solidFill>
+                        <a:srgbClr val="BFCFE8"/>
+                      </a:solidFill>
+                      <a:prstDash val="solid"/>
+                      <a:round/>
+                      <a:headEnd type="none" w="med" len="med"/>
+                      <a:tailEnd type="none" w="med" len="med"/>
+                    </a:lnL>
+                    <a:lnR w="6350" cap="flat" cmpd="sng" algn="ctr">
+                      <a:solidFill>
+                        <a:srgbClr val="BFCFE8"/>
+                      </a:solidFill>
+                      <a:prstDash val="solid"/>
+                      <a:round/>
+                      <a:headEnd type="none" w="med" len="med"/>
+                      <a:tailEnd type="none" w="med" len="med"/>
+                    </a:lnR>
+                    <a:lnT w="6350" cap="flat" cmpd="sng" algn="ctr">
+                      <a:solidFill>
+                        <a:srgbClr val="BFCFE8"/>
+                      </a:solidFill>
+                      <a:prstDash val="solid"/>
+                      <a:round/>
+                      <a:headEnd type="none" w="med" len="med"/>
+                      <a:tailEnd type="none" w="med" len="med"/>
+                    </a:lnT>
+                    <a:lnB w="6350" cap="flat" cmpd="sng" algn="ctr">
+                      <a:solidFill>
+                        <a:srgbClr val="BFCFE8"/>
+                      </a:solidFill>
+                      <a:prstDash val="solid"/>
+                      <a:round/>
+                      <a:headEnd type="none" w="med" len="med"/>
+                      <a:tailEnd type="none" w="med" len="med"/>
+                    </a:lnB>
+                    <a:solidFill>
+                      <a:srgbClr val="FFFFFF"/>
+                    </a:solidFill>
+                  </a:tcPr>
+                </a:tc>
+                <a:tc>
+                  <a:txBody>
+                    <a:bodyPr/>
+                    <a:lstStyle/>
+                    <a:p>
+                      <a:pPr algn="l" indent="0" marL="0">
+                        <a:buNone/>
+                      </a:pPr>
+                      <a:r>
+                        <a:rPr lang="en-US" sz="800" dirty="0">
                           <a:solidFill>
                             <a:srgbClr val="555555"/>
                           </a:solidFill>
@@ -10588,9 +11415,9 @@
                           <a:ea typeface="Calibri" pitchFamily="34" charset="-122"/>
                           <a:cs typeface="Calibri" pitchFamily="34" charset="-120"/>
                         </a:rPr>
-                        <a:t>Compute-bound (both identical)</a:t>
-                      </a:r>
-                      <a:endParaRPr lang="en-US" sz="850" dirty="0">
+                        <a:t>Cold NVMe bottleneck</a:t>
+                      </a:r>
+                      <a:endParaRPr lang="en-US" sz="800" dirty="0">
                         <a:latin typeface="Calibri" charset="0"/>
                         <a:ea typeface="Calibri" charset="0"/>
                         <a:cs typeface="Calibri" charset="0"/>
@@ -10640,7 +11467,7 @@
                   </a:tcPr>
                 </a:tc>
               </a:tr>
-              <a:tr h="237744">
+              <a:tr h="201168">
                 <a:tc>
                   <a:txBody>
                     <a:bodyPr/>
@@ -10650,7 +11477,7 @@
                         <a:buNone/>
                       </a:pPr>
                       <a:r>
-                        <a:rPr lang="en-US" sz="850" dirty="0">
+                        <a:rPr lang="en-US" sz="800" dirty="0">
                           <a:solidFill>
                             <a:srgbClr val="1B2A4A"/>
                           </a:solidFill>
@@ -10658,9 +11485,9 @@
                           <a:ea typeface="Calibri" pitchFamily="34" charset="-122"/>
                           <a:cs typeface="Calibri" pitchFamily="34" charset="-120"/>
                         </a:rPr>
-                        <a:t>Decode 0% hot</a:t>
-                      </a:r>
-                      <a:endParaRPr lang="en-US" sz="850" dirty="0">
+                        <a:t>Decode ~50% hot</a:t>
+                      </a:r>
+                      <a:endParaRPr lang="en-US" sz="800" dirty="0">
                         <a:latin typeface="Calibri" charset="0"/>
                         <a:ea typeface="Calibri" charset="0"/>
                         <a:cs typeface="Calibri" charset="0"/>
@@ -10718,7 +11545,7 @@
                         <a:buNone/>
                       </a:pPr>
                       <a:r>
-                        <a:rPr lang="en-US" sz="850" b="1" dirty="0">
+                        <a:rPr lang="en-US" sz="800" b="1" dirty="0">
                           <a:solidFill>
                             <a:srgbClr val="C84B00"/>
                           </a:solidFill>
@@ -10726,9 +11553,9 @@
                           <a:ea typeface="Calibri" pitchFamily="34" charset="-122"/>
                           <a:cs typeface="Calibri" pitchFamily="34" charset="-120"/>
                         </a:rPr>
-                        <a:t>9.1 tok/s</a:t>
-                      </a:r>
-                      <a:endParaRPr lang="en-US" sz="850" dirty="0">
+                        <a:t>18.1 tok/s</a:t>
+                      </a:r>
+                      <a:endParaRPr lang="en-US" sz="800" dirty="0">
                         <a:latin typeface="Calibri" charset="0"/>
                         <a:ea typeface="Calibri" charset="0"/>
                         <a:cs typeface="Calibri" charset="0"/>
@@ -10786,7 +11613,7 @@
                         <a:buNone/>
                       </a:pPr>
                       <a:r>
-                        <a:rPr lang="en-US" sz="850" b="1" dirty="0">
+                        <a:rPr lang="en-US" sz="800" b="1" dirty="0">
                           <a:solidFill>
                             <a:srgbClr val="1A7A3C"/>
                           </a:solidFill>
@@ -10794,9 +11621,9 @@
                           <a:ea typeface="Calibri" pitchFamily="34" charset="-122"/>
                           <a:cs typeface="Calibri" pitchFamily="34" charset="-120"/>
                         </a:rPr>
-                        <a:t>18.4 tok/s</a:t>
-                      </a:r>
-                      <a:endParaRPr lang="en-US" sz="850" dirty="0">
+                        <a:t>28.3 tok/s ★</a:t>
+                      </a:r>
+                      <a:endParaRPr lang="en-US" sz="800" dirty="0">
                         <a:latin typeface="Calibri" charset="0"/>
                         <a:ea typeface="Calibri" charset="0"/>
                         <a:cs typeface="Calibri" charset="0"/>
@@ -10854,7 +11681,7 @@
                         <a:buNone/>
                       </a:pPr>
                       <a:r>
-                        <a:rPr lang="en-US" sz="850" b="1" dirty="0">
+                        <a:rPr lang="en-US" sz="800" b="1" dirty="0">
                           <a:solidFill>
                             <a:srgbClr val="1A7A3C"/>
                           </a:solidFill>
@@ -10862,9 +11689,9 @@
                           <a:ea typeface="Calibri" pitchFamily="34" charset="-122"/>
                           <a:cs typeface="Calibri" pitchFamily="34" charset="-120"/>
                         </a:rPr>
-                        <a:t>2.03×</a:t>
-                      </a:r>
-                      <a:endParaRPr lang="en-US" sz="850" dirty="0">
+                        <a:t>PCIe6 peak</a:t>
+                      </a:r>
+                      <a:endParaRPr lang="en-US" sz="800" dirty="0">
                         <a:latin typeface="Calibri" charset="0"/>
                         <a:ea typeface="Calibri" charset="0"/>
                         <a:cs typeface="Calibri" charset="0"/>
@@ -10922,7 +11749,7 @@
                         <a:buNone/>
                       </a:pPr>
                       <a:r>
-                        <a:rPr lang="en-US" sz="850" dirty="0">
+                        <a:rPr lang="en-US" sz="800" dirty="0">
                           <a:solidFill>
                             <a:srgbClr val="555555"/>
                           </a:solidFill>
@@ -10930,9 +11757,9 @@
                           <a:ea typeface="Calibri" pitchFamily="34" charset="-122"/>
                           <a:cs typeface="Calibri" pitchFamily="34" charset="-120"/>
                         </a:rPr>
-                        <a:t>Cold NVMe bottleneck</a:t>
-                      </a:r>
-                      <a:endParaRPr lang="en-US" sz="850" dirty="0">
+                        <a:t>PCIe5=SSD-bnd; PCIe6=GPU-bnd (peak at ~37% hit)</a:t>
+                      </a:r>
+                      <a:endParaRPr lang="en-US" sz="800" dirty="0">
                         <a:latin typeface="Calibri" charset="0"/>
                         <a:ea typeface="Calibri" charset="0"/>
                         <a:cs typeface="Calibri" charset="0"/>
@@ -10982,7 +11809,7 @@
                   </a:tcPr>
                 </a:tc>
               </a:tr>
-              <a:tr h="237744">
+              <a:tr h="201168">
                 <a:tc>
                   <a:txBody>
                     <a:bodyPr/>
@@ -10992,7 +11819,7 @@
                         <a:buNone/>
                       </a:pPr>
                       <a:r>
-                        <a:rPr lang="en-US" sz="850" dirty="0">
+                        <a:rPr lang="en-US" sz="800" dirty="0">
                           <a:solidFill>
                             <a:srgbClr val="1B2A4A"/>
                           </a:solidFill>
@@ -11000,9 +11827,9 @@
                           <a:ea typeface="Calibri" pitchFamily="34" charset="-122"/>
                           <a:cs typeface="Calibri" pitchFamily="34" charset="-120"/>
                         </a:rPr>
-                        <a:t>Decode ~50% hot</a:t>
-                      </a:r>
-                      <a:endParaRPr lang="en-US" sz="850" dirty="0">
+                        <a:t>Decode ≥70% hot</a:t>
+                      </a:r>
+                      <a:endParaRPr lang="en-US" sz="800" dirty="0">
                         <a:latin typeface="Calibri" charset="0"/>
                         <a:ea typeface="Calibri" charset="0"/>
                         <a:cs typeface="Calibri" charset="0"/>
@@ -11060,7 +11887,7 @@
                         <a:buNone/>
                       </a:pPr>
                       <a:r>
-                        <a:rPr lang="en-US" sz="850" b="1" dirty="0">
+                        <a:rPr lang="en-US" sz="800" b="1" dirty="0">
                           <a:solidFill>
                             <a:srgbClr val="C84B00"/>
                           </a:solidFill>
@@ -11068,9 +11895,9 @@
                           <a:ea typeface="Calibri" pitchFamily="34" charset="-122"/>
                           <a:cs typeface="Calibri" pitchFamily="34" charset="-120"/>
                         </a:rPr>
-                        <a:t>18.1 tok/s</a:t>
-                      </a:r>
-                      <a:endParaRPr lang="en-US" sz="850" dirty="0">
+                        <a:t>~27 tok/s</a:t>
+                      </a:r>
+                      <a:endParaRPr lang="en-US" sz="800" dirty="0">
                         <a:latin typeface="Calibri" charset="0"/>
                         <a:ea typeface="Calibri" charset="0"/>
                         <a:cs typeface="Calibri" charset="0"/>
@@ -11128,7 +11955,7 @@
                         <a:buNone/>
                       </a:pPr>
                       <a:r>
-                        <a:rPr lang="en-US" sz="850" b="1" dirty="0">
+                        <a:rPr lang="en-US" sz="800" b="1" dirty="0">
                           <a:solidFill>
                             <a:srgbClr val="1A7A3C"/>
                           </a:solidFill>
@@ -11136,9 +11963,9 @@
                           <a:ea typeface="Calibri" pitchFamily="34" charset="-122"/>
                           <a:cs typeface="Calibri" pitchFamily="34" charset="-120"/>
                         </a:rPr>
-                        <a:t>28.3 tok/s ★</a:t>
-                      </a:r>
-                      <a:endParaRPr lang="en-US" sz="850" dirty="0">
+                        <a:t>~27 tok/s</a:t>
+                      </a:r>
+                      <a:endParaRPr lang="en-US" sz="800" dirty="0">
                         <a:latin typeface="Calibri" charset="0"/>
                         <a:ea typeface="Calibri" charset="0"/>
                         <a:cs typeface="Calibri" charset="0"/>
@@ -11196,7 +12023,281 @@
                         <a:buNone/>
                       </a:pPr>
                       <a:r>
-                        <a:rPr lang="en-US" sz="850" b="1" dirty="0">
+                        <a:rPr lang="en-US" sz="800" b="1" dirty="0">
+                          <a:solidFill>
+                            <a:srgbClr val="555555"/>
+                          </a:solidFill>
+                          <a:latin typeface="Calibri" pitchFamily="34" charset="0"/>
+                          <a:ea typeface="Calibri" pitchFamily="34" charset="-122"/>
+                          <a:cs typeface="Calibri" pitchFamily="34" charset="-120"/>
+                        </a:rPr>
+                        <a:t>≈1.0× (tied)</a:t>
+                      </a:r>
+                      <a:endParaRPr lang="en-US" sz="800" dirty="0">
+                        <a:latin typeface="Calibri" charset="0"/>
+                        <a:ea typeface="Calibri" charset="0"/>
+                        <a:cs typeface="Calibri" charset="0"/>
+                      </a:endParaRPr>
+                    </a:p>
+                  </a:txBody>
+                  <a:tcPr marL="91440" marR="91440" marT="45720" marB="45720">
+                    <a:lnL w="6350" cap="flat" cmpd="sng" algn="ctr">
+                      <a:solidFill>
+                        <a:srgbClr val="BFCFE8"/>
+                      </a:solidFill>
+                      <a:prstDash val="solid"/>
+                      <a:round/>
+                      <a:headEnd type="none" w="med" len="med"/>
+                      <a:tailEnd type="none" w="med" len="med"/>
+                    </a:lnL>
+                    <a:lnR w="6350" cap="flat" cmpd="sng" algn="ctr">
+                      <a:solidFill>
+                        <a:srgbClr val="BFCFE8"/>
+                      </a:solidFill>
+                      <a:prstDash val="solid"/>
+                      <a:round/>
+                      <a:headEnd type="none" w="med" len="med"/>
+                      <a:tailEnd type="none" w="med" len="med"/>
+                    </a:lnR>
+                    <a:lnT w="6350" cap="flat" cmpd="sng" algn="ctr">
+                      <a:solidFill>
+                        <a:srgbClr val="BFCFE8"/>
+                      </a:solidFill>
+                      <a:prstDash val="solid"/>
+                      <a:round/>
+                      <a:headEnd type="none" w="med" len="med"/>
+                      <a:tailEnd type="none" w="med" len="med"/>
+                    </a:lnT>
+                    <a:lnB w="6350" cap="flat" cmpd="sng" algn="ctr">
+                      <a:solidFill>
+                        <a:srgbClr val="BFCFE8"/>
+                      </a:solidFill>
+                      <a:prstDash val="solid"/>
+                      <a:round/>
+                      <a:headEnd type="none" w="med" len="med"/>
+                      <a:tailEnd type="none" w="med" len="med"/>
+                    </a:lnB>
+                    <a:solidFill>
+                      <a:srgbClr val="FFFFFF"/>
+                    </a:solidFill>
+                  </a:tcPr>
+                </a:tc>
+                <a:tc>
+                  <a:txBody>
+                    <a:bodyPr/>
+                    <a:lstStyle/>
+                    <a:p>
+                      <a:pPr algn="l" indent="0" marL="0">
+                        <a:buNone/>
+                      </a:pPr>
+                      <a:r>
+                        <a:rPr lang="en-US" sz="800" dirty="0">
+                          <a:solidFill>
+                            <a:srgbClr val="555555"/>
+                          </a:solidFill>
+                          <a:latin typeface="Calibri" pitchFamily="34" charset="0"/>
+                          <a:ea typeface="Calibri" pitchFamily="34" charset="-122"/>
+                          <a:cs typeface="Calibri" pitchFamily="34" charset="-120"/>
+                        </a:rPr>
+                        <a:t>GPU memory ceiling (both) @ 273 GB/s</a:t>
+                      </a:r>
+                      <a:endParaRPr lang="en-US" sz="800" dirty="0">
+                        <a:latin typeface="Calibri" charset="0"/>
+                        <a:ea typeface="Calibri" charset="0"/>
+                        <a:cs typeface="Calibri" charset="0"/>
+                      </a:endParaRPr>
+                    </a:p>
+                  </a:txBody>
+                  <a:tcPr marL="91440" marR="91440" marT="45720" marB="45720">
+                    <a:lnL w="6350" cap="flat" cmpd="sng" algn="ctr">
+                      <a:solidFill>
+                        <a:srgbClr val="BFCFE8"/>
+                      </a:solidFill>
+                      <a:prstDash val="solid"/>
+                      <a:round/>
+                      <a:headEnd type="none" w="med" len="med"/>
+                      <a:tailEnd type="none" w="med" len="med"/>
+                    </a:lnL>
+                    <a:lnR w="6350" cap="flat" cmpd="sng" algn="ctr">
+                      <a:solidFill>
+                        <a:srgbClr val="BFCFE8"/>
+                      </a:solidFill>
+                      <a:prstDash val="solid"/>
+                      <a:round/>
+                      <a:headEnd type="none" w="med" len="med"/>
+                      <a:tailEnd type="none" w="med" len="med"/>
+                    </a:lnR>
+                    <a:lnT w="6350" cap="flat" cmpd="sng" algn="ctr">
+                      <a:solidFill>
+                        <a:srgbClr val="BFCFE8"/>
+                      </a:solidFill>
+                      <a:prstDash val="solid"/>
+                      <a:round/>
+                      <a:headEnd type="none" w="med" len="med"/>
+                      <a:tailEnd type="none" w="med" len="med"/>
+                    </a:lnT>
+                    <a:lnB w="6350" cap="flat" cmpd="sng" algn="ctr">
+                      <a:solidFill>
+                        <a:srgbClr val="BFCFE8"/>
+                      </a:solidFill>
+                      <a:prstDash val="solid"/>
+                      <a:round/>
+                      <a:headEnd type="none" w="med" len="med"/>
+                      <a:tailEnd type="none" w="med" len="med"/>
+                    </a:lnB>
+                    <a:solidFill>
+                      <a:srgbClr val="FFFFFF"/>
+                    </a:solidFill>
+                  </a:tcPr>
+                </a:tc>
+              </a:tr>
+              <a:tr h="201168">
+                <a:tc>
+                  <a:txBody>
+                    <a:bodyPr/>
+                    <a:lstStyle/>
+                    <a:p>
+                      <a:pPr algn="l" indent="0" marL="0">
+                        <a:buNone/>
+                      </a:pPr>
+                      <a:r>
+                        <a:rPr lang="en-US" sz="800" dirty="0">
+                          <a:solidFill>
+                            <a:srgbClr val="1B2A4A"/>
+                          </a:solidFill>
+                          <a:latin typeface="Calibri" pitchFamily="34" charset="0"/>
+                          <a:ea typeface="Calibri" pitchFamily="34" charset="-122"/>
+                          <a:cs typeface="Calibri" pitchFamily="34" charset="-120"/>
+                        </a:rPr>
+                        <a:t>TTFT  L≤256</a:t>
+                      </a:r>
+                      <a:endParaRPr lang="en-US" sz="800" dirty="0">
+                        <a:latin typeface="Calibri" charset="0"/>
+                        <a:ea typeface="Calibri" charset="0"/>
+                        <a:cs typeface="Calibri" charset="0"/>
+                      </a:endParaRPr>
+                    </a:p>
+                  </a:txBody>
+                  <a:tcPr marL="91440" marR="91440" marT="45720" marB="45720">
+                    <a:lnL w="6350" cap="flat" cmpd="sng" algn="ctr">
+                      <a:solidFill>
+                        <a:srgbClr val="BFCFE8"/>
+                      </a:solidFill>
+                      <a:prstDash val="solid"/>
+                      <a:round/>
+                      <a:headEnd type="none" w="med" len="med"/>
+                      <a:tailEnd type="none" w="med" len="med"/>
+                    </a:lnL>
+                    <a:lnR w="6350" cap="flat" cmpd="sng" algn="ctr">
+                      <a:solidFill>
+                        <a:srgbClr val="BFCFE8"/>
+                      </a:solidFill>
+                      <a:prstDash val="solid"/>
+                      <a:round/>
+                      <a:headEnd type="none" w="med" len="med"/>
+                      <a:tailEnd type="none" w="med" len="med"/>
+                    </a:lnR>
+                    <a:lnT w="6350" cap="flat" cmpd="sng" algn="ctr">
+                      <a:solidFill>
+                        <a:srgbClr val="BFCFE8"/>
+                      </a:solidFill>
+                      <a:prstDash val="solid"/>
+                      <a:round/>
+                      <a:headEnd type="none" w="med" len="med"/>
+                      <a:tailEnd type="none" w="med" len="med"/>
+                    </a:lnT>
+                    <a:lnB w="6350" cap="flat" cmpd="sng" algn="ctr">
+                      <a:solidFill>
+                        <a:srgbClr val="BFCFE8"/>
+                      </a:solidFill>
+                      <a:prstDash val="solid"/>
+                      <a:round/>
+                      <a:headEnd type="none" w="med" len="med"/>
+                      <a:tailEnd type="none" w="med" len="med"/>
+                    </a:lnB>
+                    <a:solidFill>
+                      <a:srgbClr val="FFFFFF"/>
+                    </a:solidFill>
+                  </a:tcPr>
+                </a:tc>
+                <a:tc>
+                  <a:txBody>
+                    <a:bodyPr/>
+                    <a:lstStyle/>
+                    <a:p>
+                      <a:pPr algn="ctr" indent="0" marL="0">
+                        <a:buNone/>
+                      </a:pPr>
+                      <a:r>
+                        <a:rPr lang="en-US" sz="800" b="1" dirty="0">
+                          <a:solidFill>
+                            <a:srgbClr val="C84B00"/>
+                          </a:solidFill>
+                          <a:latin typeface="Calibri" pitchFamily="34" charset="0"/>
+                          <a:ea typeface="Calibri" pitchFamily="34" charset="-122"/>
+                          <a:cs typeface="Calibri" pitchFamily="34" charset="-120"/>
+                        </a:rPr>
+                        <a:t>110.5 ms</a:t>
+                      </a:r>
+                      <a:endParaRPr lang="en-US" sz="800" dirty="0">
+                        <a:latin typeface="Calibri" charset="0"/>
+                        <a:ea typeface="Calibri" charset="0"/>
+                        <a:cs typeface="Calibri" charset="0"/>
+                      </a:endParaRPr>
+                    </a:p>
+                  </a:txBody>
+                  <a:tcPr marL="91440" marR="91440" marT="45720" marB="45720">
+                    <a:lnL w="6350" cap="flat" cmpd="sng" algn="ctr">
+                      <a:solidFill>
+                        <a:srgbClr val="BFCFE8"/>
+                      </a:solidFill>
+                      <a:prstDash val="solid"/>
+                      <a:round/>
+                      <a:headEnd type="none" w="med" len="med"/>
+                      <a:tailEnd type="none" w="med" len="med"/>
+                    </a:lnL>
+                    <a:lnR w="6350" cap="flat" cmpd="sng" algn="ctr">
+                      <a:solidFill>
+                        <a:srgbClr val="BFCFE8"/>
+                      </a:solidFill>
+                      <a:prstDash val="solid"/>
+                      <a:round/>
+                      <a:headEnd type="none" w="med" len="med"/>
+                      <a:tailEnd type="none" w="med" len="med"/>
+                    </a:lnR>
+                    <a:lnT w="6350" cap="flat" cmpd="sng" algn="ctr">
+                      <a:solidFill>
+                        <a:srgbClr val="BFCFE8"/>
+                      </a:solidFill>
+                      <a:prstDash val="solid"/>
+                      <a:round/>
+                      <a:headEnd type="none" w="med" len="med"/>
+                      <a:tailEnd type="none" w="med" len="med"/>
+                    </a:lnT>
+                    <a:lnB w="6350" cap="flat" cmpd="sng" algn="ctr">
+                      <a:solidFill>
+                        <a:srgbClr val="BFCFE8"/>
+                      </a:solidFill>
+                      <a:prstDash val="solid"/>
+                      <a:round/>
+                      <a:headEnd type="none" w="med" len="med"/>
+                      <a:tailEnd type="none" w="med" len="med"/>
+                    </a:lnB>
+                    <a:solidFill>
+                      <a:srgbClr val="FFFFFF"/>
+                    </a:solidFill>
+                  </a:tcPr>
+                </a:tc>
+                <a:tc>
+                  <a:txBody>
+                    <a:bodyPr/>
+                    <a:lstStyle/>
+                    <a:p>
+                      <a:pPr algn="ctr" indent="0" marL="0">
+                        <a:buNone/>
+                      </a:pPr>
+                      <a:r>
+                        <a:rPr lang="en-US" sz="800" b="1" dirty="0">
                           <a:solidFill>
                             <a:srgbClr val="1A7A3C"/>
                           </a:solidFill>
@@ -11204,9 +12305,9 @@
                           <a:ea typeface="Calibri" pitchFamily="34" charset="-122"/>
                           <a:cs typeface="Calibri" pitchFamily="34" charset="-120"/>
                         </a:rPr>
-                        <a:t>PCIe6 peak</a:t>
-                      </a:r>
-                      <a:endParaRPr lang="en-US" sz="850" dirty="0">
+                        <a:t>54.4 ms ★</a:t>
+                      </a:r>
+                      <a:endParaRPr lang="en-US" sz="800" dirty="0">
                         <a:latin typeface="Calibri" charset="0"/>
                         <a:ea typeface="Calibri" charset="0"/>
                         <a:cs typeface="Calibri" charset="0"/>
@@ -11260,11 +12361,79 @@
                     <a:bodyPr/>
                     <a:lstStyle/>
                     <a:p>
+                      <a:pPr algn="ctr" indent="0" marL="0">
+                        <a:buNone/>
+                      </a:pPr>
+                      <a:r>
+                        <a:rPr lang="en-US" sz="800" b="1" dirty="0">
+                          <a:solidFill>
+                            <a:srgbClr val="1A7A3C"/>
+                          </a:solidFill>
+                          <a:latin typeface="Calibri" pitchFamily="34" charset="0"/>
+                          <a:ea typeface="Calibri" pitchFamily="34" charset="-122"/>
+                          <a:cs typeface="Calibri" pitchFamily="34" charset="-120"/>
+                        </a:rPr>
+                        <a:t>2.03× faster</a:t>
+                      </a:r>
+                      <a:endParaRPr lang="en-US" sz="800" dirty="0">
+                        <a:latin typeface="Calibri" charset="0"/>
+                        <a:ea typeface="Calibri" charset="0"/>
+                        <a:cs typeface="Calibri" charset="0"/>
+                      </a:endParaRPr>
+                    </a:p>
+                  </a:txBody>
+                  <a:tcPr marL="91440" marR="91440" marT="45720" marB="45720">
+                    <a:lnL w="6350" cap="flat" cmpd="sng" algn="ctr">
+                      <a:solidFill>
+                        <a:srgbClr val="BFCFE8"/>
+                      </a:solidFill>
+                      <a:prstDash val="solid"/>
+                      <a:round/>
+                      <a:headEnd type="none" w="med" len="med"/>
+                      <a:tailEnd type="none" w="med" len="med"/>
+                    </a:lnL>
+                    <a:lnR w="6350" cap="flat" cmpd="sng" algn="ctr">
+                      <a:solidFill>
+                        <a:srgbClr val="BFCFE8"/>
+                      </a:solidFill>
+                      <a:prstDash val="solid"/>
+                      <a:round/>
+                      <a:headEnd type="none" w="med" len="med"/>
+                      <a:tailEnd type="none" w="med" len="med"/>
+                    </a:lnR>
+                    <a:lnT w="6350" cap="flat" cmpd="sng" algn="ctr">
+                      <a:solidFill>
+                        <a:srgbClr val="BFCFE8"/>
+                      </a:solidFill>
+                      <a:prstDash val="solid"/>
+                      <a:round/>
+                      <a:headEnd type="none" w="med" len="med"/>
+                      <a:tailEnd type="none" w="med" len="med"/>
+                    </a:lnT>
+                    <a:lnB w="6350" cap="flat" cmpd="sng" algn="ctr">
+                      <a:solidFill>
+                        <a:srgbClr val="BFCFE8"/>
+                      </a:solidFill>
+                      <a:prstDash val="solid"/>
+                      <a:round/>
+                      <a:headEnd type="none" w="med" len="med"/>
+                      <a:tailEnd type="none" w="med" len="med"/>
+                    </a:lnB>
+                    <a:solidFill>
+                      <a:srgbClr val="FFFFFF"/>
+                    </a:solidFill>
+                  </a:tcPr>
+                </a:tc>
+                <a:tc>
+                  <a:txBody>
+                    <a:bodyPr/>
+                    <a:lstStyle/>
+                    <a:p>
                       <a:pPr algn="l" indent="0" marL="0">
                         <a:buNone/>
                       </a:pPr>
                       <a:r>
-                        <a:rPr lang="en-US" sz="850" dirty="0">
+                        <a:rPr lang="en-US" sz="800" dirty="0">
                           <a:solidFill>
                             <a:srgbClr val="555555"/>
                           </a:solidFill>
@@ -11272,9 +12441,9 @@
                           <a:ea typeface="Calibri" pitchFamily="34" charset="-122"/>
                           <a:cs typeface="Calibri" pitchFamily="34" charset="-120"/>
                         </a:rPr>
-                        <a:t>PCIe5=SSD-bnd; PCIe6=GPU-bnd (peak at ~37% hit)</a:t>
-                      </a:r>
-                      <a:endParaRPr lang="en-US" sz="850" dirty="0">
+                        <a:t>IO-bound (same expert-load BW as decode cold path)</a:t>
+                      </a:r>
+                      <a:endParaRPr lang="en-US" sz="800" dirty="0">
                         <a:latin typeface="Calibri" charset="0"/>
                         <a:ea typeface="Calibri" charset="0"/>
                         <a:cs typeface="Calibri" charset="0"/>
@@ -11324,7 +12493,7 @@
                   </a:tcPr>
                 </a:tc>
               </a:tr>
-              <a:tr h="237744">
+              <a:tr h="201168">
                 <a:tc>
                   <a:txBody>
                     <a:bodyPr/>
@@ -11334,7 +12503,7 @@
                         <a:buNone/>
                       </a:pPr>
                       <a:r>
-                        <a:rPr lang="en-US" sz="850" dirty="0">
+                        <a:rPr lang="en-US" sz="800" dirty="0">
                           <a:solidFill>
                             <a:srgbClr val="1B2A4A"/>
                           </a:solidFill>
@@ -11342,9 +12511,9 @@
                           <a:ea typeface="Calibri" pitchFamily="34" charset="-122"/>
                           <a:cs typeface="Calibri" pitchFamily="34" charset="-120"/>
                         </a:rPr>
-                        <a:t>Decode ≥70% hot</a:t>
-                      </a:r>
-                      <a:endParaRPr lang="en-US" sz="850" dirty="0">
+                        <a:t>TTFT  L=512</a:t>
+                      </a:r>
+                      <a:endParaRPr lang="en-US" sz="800" dirty="0">
                         <a:latin typeface="Calibri" charset="0"/>
                         <a:ea typeface="Calibri" charset="0"/>
                         <a:cs typeface="Calibri" charset="0"/>
@@ -11402,7 +12571,7 @@
                         <a:buNone/>
                       </a:pPr>
                       <a:r>
-                        <a:rPr lang="en-US" sz="850" b="1" dirty="0">
+                        <a:rPr lang="en-US" sz="800" b="1" dirty="0">
                           <a:solidFill>
                             <a:srgbClr val="C84B00"/>
                           </a:solidFill>
@@ -11410,9 +12579,9 @@
                           <a:ea typeface="Calibri" pitchFamily="34" charset="-122"/>
                           <a:cs typeface="Calibri" pitchFamily="34" charset="-120"/>
                         </a:rPr>
-                        <a:t>~27 tok/s</a:t>
-                      </a:r>
-                      <a:endParaRPr lang="en-US" sz="850" dirty="0">
+                        <a:t>110.5 ms</a:t>
+                      </a:r>
+                      <a:endParaRPr lang="en-US" sz="800" dirty="0">
                         <a:latin typeface="Calibri" charset="0"/>
                         <a:ea typeface="Calibri" charset="0"/>
                         <a:cs typeface="Calibri" charset="0"/>
@@ -11470,7 +12639,7 @@
                         <a:buNone/>
                       </a:pPr>
                       <a:r>
-                        <a:rPr lang="en-US" sz="850" b="1" dirty="0">
+                        <a:rPr lang="en-US" sz="800" b="1" dirty="0">
                           <a:solidFill>
                             <a:srgbClr val="1A7A3C"/>
                           </a:solidFill>
@@ -11478,9 +12647,9 @@
                           <a:ea typeface="Calibri" pitchFamily="34" charset="-122"/>
                           <a:cs typeface="Calibri" pitchFamily="34" charset="-120"/>
                         </a:rPr>
-                        <a:t>~27 tok/s</a:t>
-                      </a:r>
-                      <a:endParaRPr lang="en-US" sz="850" dirty="0">
+                        <a:t>101.4 ms</a:t>
+                      </a:r>
+                      <a:endParaRPr lang="en-US" sz="800" dirty="0">
                         <a:latin typeface="Calibri" charset="0"/>
                         <a:ea typeface="Calibri" charset="0"/>
                         <a:cs typeface="Calibri" charset="0"/>
@@ -11538,7 +12707,75 @@
                         <a:buNone/>
                       </a:pPr>
                       <a:r>
-                        <a:rPr lang="en-US" sz="850" b="1" dirty="0">
+                        <a:rPr lang="en-US" sz="800" b="1" dirty="0">
+                          <a:solidFill>
+                            <a:srgbClr val="1A7A3C"/>
+                          </a:solidFill>
+                          <a:latin typeface="Calibri" pitchFamily="34" charset="0"/>
+                          <a:ea typeface="Calibri" pitchFamily="34" charset="-122"/>
+                          <a:cs typeface="Calibri" pitchFamily="34" charset="-120"/>
+                        </a:rPr>
+                        <a:t>1.09× faster</a:t>
+                      </a:r>
+                      <a:endParaRPr lang="en-US" sz="800" dirty="0">
+                        <a:latin typeface="Calibri" charset="0"/>
+                        <a:ea typeface="Calibri" charset="0"/>
+                        <a:cs typeface="Calibri" charset="0"/>
+                      </a:endParaRPr>
+                    </a:p>
+                  </a:txBody>
+                  <a:tcPr marL="91440" marR="91440" marT="45720" marB="45720">
+                    <a:lnL w="6350" cap="flat" cmpd="sng" algn="ctr">
+                      <a:solidFill>
+                        <a:srgbClr val="BFCFE8"/>
+                      </a:solidFill>
+                      <a:prstDash val="solid"/>
+                      <a:round/>
+                      <a:headEnd type="none" w="med" len="med"/>
+                      <a:tailEnd type="none" w="med" len="med"/>
+                    </a:lnL>
+                    <a:lnR w="6350" cap="flat" cmpd="sng" algn="ctr">
+                      <a:solidFill>
+                        <a:srgbClr val="BFCFE8"/>
+                      </a:solidFill>
+                      <a:prstDash val="solid"/>
+                      <a:round/>
+                      <a:headEnd type="none" w="med" len="med"/>
+                      <a:tailEnd type="none" w="med" len="med"/>
+                    </a:lnR>
+                    <a:lnT w="6350" cap="flat" cmpd="sng" algn="ctr">
+                      <a:solidFill>
+                        <a:srgbClr val="BFCFE8"/>
+                      </a:solidFill>
+                      <a:prstDash val="solid"/>
+                      <a:round/>
+                      <a:headEnd type="none" w="med" len="med"/>
+                      <a:tailEnd type="none" w="med" len="med"/>
+                    </a:lnT>
+                    <a:lnB w="6350" cap="flat" cmpd="sng" algn="ctr">
+                      <a:solidFill>
+                        <a:srgbClr val="BFCFE8"/>
+                      </a:solidFill>
+                      <a:prstDash val="solid"/>
+                      <a:round/>
+                      <a:headEnd type="none" w="med" len="med"/>
+                      <a:tailEnd type="none" w="med" len="med"/>
+                    </a:lnB>
+                    <a:solidFill>
+                      <a:srgbClr val="FFFFFF"/>
+                    </a:solidFill>
+                  </a:tcPr>
+                </a:tc>
+                <a:tc>
+                  <a:txBody>
+                    <a:bodyPr/>
+                    <a:lstStyle/>
+                    <a:p>
+                      <a:pPr algn="l" indent="0" marL="0">
+                        <a:buNone/>
+                      </a:pPr>
+                      <a:r>
+                        <a:rPr lang="en-US" sz="800" dirty="0">
                           <a:solidFill>
                             <a:srgbClr val="555555"/>
                           </a:solidFill>
@@ -11546,9 +12783,9 @@
                           <a:ea typeface="Calibri" pitchFamily="34" charset="-122"/>
                           <a:cs typeface="Calibri" pitchFamily="34" charset="-120"/>
                         </a:rPr>
-                        <a:t>≈1.0× (tied)</a:t>
-                      </a:r>
-                      <a:endParaRPr lang="en-US" sz="850" dirty="0">
+                        <a:t>PCIe5=IO-bnd (C&lt;559); PCIe6=CPU-bnd (C&gt;275)</a:t>
+                      </a:r>
+                      <a:endParaRPr lang="en-US" sz="800" dirty="0">
                         <a:latin typeface="Calibri" charset="0"/>
                         <a:ea typeface="Calibri" charset="0"/>
                         <a:cs typeface="Calibri" charset="0"/>
@@ -11597,6 +12834,8 @@
                     </a:solidFill>
                   </a:tcPr>
                 </a:tc>
+              </a:tr>
+              <a:tr h="201168">
                 <a:tc>
                   <a:txBody>
                     <a:bodyPr/>
@@ -11606,7 +12845,279 @@
                         <a:buNone/>
                       </a:pPr>
                       <a:r>
-                        <a:rPr lang="en-US" sz="850" dirty="0">
+                        <a:rPr lang="en-US" sz="800" dirty="0">
+                          <a:solidFill>
+                            <a:srgbClr val="1B2A4A"/>
+                          </a:solidFill>
+                          <a:latin typeface="Calibri" pitchFamily="34" charset="0"/>
+                          <a:ea typeface="Calibri" pitchFamily="34" charset="-122"/>
+                          <a:cs typeface="Calibri" pitchFamily="34" charset="-120"/>
+                        </a:rPr>
+                        <a:t>TTFT  L≥559 (C=2K)</a:t>
+                      </a:r>
+                      <a:endParaRPr lang="en-US" sz="800" dirty="0">
+                        <a:latin typeface="Calibri" charset="0"/>
+                        <a:ea typeface="Calibri" charset="0"/>
+                        <a:cs typeface="Calibri" charset="0"/>
+                      </a:endParaRPr>
+                    </a:p>
+                  </a:txBody>
+                  <a:tcPr marL="91440" marR="91440" marT="45720" marB="45720">
+                    <a:lnL w="6350" cap="flat" cmpd="sng" algn="ctr">
+                      <a:solidFill>
+                        <a:srgbClr val="BFCFE8"/>
+                      </a:solidFill>
+                      <a:prstDash val="solid"/>
+                      <a:round/>
+                      <a:headEnd type="none" w="med" len="med"/>
+                      <a:tailEnd type="none" w="med" len="med"/>
+                    </a:lnL>
+                    <a:lnR w="6350" cap="flat" cmpd="sng" algn="ctr">
+                      <a:solidFill>
+                        <a:srgbClr val="BFCFE8"/>
+                      </a:solidFill>
+                      <a:prstDash val="solid"/>
+                      <a:round/>
+                      <a:headEnd type="none" w="med" len="med"/>
+                      <a:tailEnd type="none" w="med" len="med"/>
+                    </a:lnR>
+                    <a:lnT w="6350" cap="flat" cmpd="sng" algn="ctr">
+                      <a:solidFill>
+                        <a:srgbClr val="BFCFE8"/>
+                      </a:solidFill>
+                      <a:prstDash val="solid"/>
+                      <a:round/>
+                      <a:headEnd type="none" w="med" len="med"/>
+                      <a:tailEnd type="none" w="med" len="med"/>
+                    </a:lnT>
+                    <a:lnB w="6350" cap="flat" cmpd="sng" algn="ctr">
+                      <a:solidFill>
+                        <a:srgbClr val="BFCFE8"/>
+                      </a:solidFill>
+                      <a:prstDash val="solid"/>
+                      <a:round/>
+                      <a:headEnd type="none" w="med" len="med"/>
+                      <a:tailEnd type="none" w="med" len="med"/>
+                    </a:lnB>
+                    <a:solidFill>
+                      <a:srgbClr val="FFFFFF"/>
+                    </a:solidFill>
+                  </a:tcPr>
+                </a:tc>
+                <a:tc>
+                  <a:txBody>
+                    <a:bodyPr/>
+                    <a:lstStyle/>
+                    <a:p>
+                      <a:pPr algn="ctr" indent="0" marL="0">
+                        <a:buNone/>
+                      </a:pPr>
+                      <a:r>
+                        <a:rPr lang="en-US" sz="800" b="1" dirty="0">
+                          <a:solidFill>
+                            <a:srgbClr val="C84B00"/>
+                          </a:solidFill>
+                          <a:latin typeface="Calibri" pitchFamily="34" charset="0"/>
+                          <a:ea typeface="Calibri" pitchFamily="34" charset="-122"/>
+                          <a:cs typeface="Calibri" pitchFamily="34" charset="-120"/>
+                        </a:rPr>
+                        <a:t>~405 ms/2K</a:t>
+                      </a:r>
+                      <a:endParaRPr lang="en-US" sz="800" dirty="0">
+                        <a:latin typeface="Calibri" charset="0"/>
+                        <a:ea typeface="Calibri" charset="0"/>
+                        <a:cs typeface="Calibri" charset="0"/>
+                      </a:endParaRPr>
+                    </a:p>
+                  </a:txBody>
+                  <a:tcPr marL="91440" marR="91440" marT="45720" marB="45720">
+                    <a:lnL w="6350" cap="flat" cmpd="sng" algn="ctr">
+                      <a:solidFill>
+                        <a:srgbClr val="BFCFE8"/>
+                      </a:solidFill>
+                      <a:prstDash val="solid"/>
+                      <a:round/>
+                      <a:headEnd type="none" w="med" len="med"/>
+                      <a:tailEnd type="none" w="med" len="med"/>
+                    </a:lnL>
+                    <a:lnR w="6350" cap="flat" cmpd="sng" algn="ctr">
+                      <a:solidFill>
+                        <a:srgbClr val="BFCFE8"/>
+                      </a:solidFill>
+                      <a:prstDash val="solid"/>
+                      <a:round/>
+                      <a:headEnd type="none" w="med" len="med"/>
+                      <a:tailEnd type="none" w="med" len="med"/>
+                    </a:lnR>
+                    <a:lnT w="6350" cap="flat" cmpd="sng" algn="ctr">
+                      <a:solidFill>
+                        <a:srgbClr val="BFCFE8"/>
+                      </a:solidFill>
+                      <a:prstDash val="solid"/>
+                      <a:round/>
+                      <a:headEnd type="none" w="med" len="med"/>
+                      <a:tailEnd type="none" w="med" len="med"/>
+                    </a:lnT>
+                    <a:lnB w="6350" cap="flat" cmpd="sng" algn="ctr">
+                      <a:solidFill>
+                        <a:srgbClr val="BFCFE8"/>
+                      </a:solidFill>
+                      <a:prstDash val="solid"/>
+                      <a:round/>
+                      <a:headEnd type="none" w="med" len="med"/>
+                      <a:tailEnd type="none" w="med" len="med"/>
+                    </a:lnB>
+                    <a:solidFill>
+                      <a:srgbClr val="FFFFFF"/>
+                    </a:solidFill>
+                  </a:tcPr>
+                </a:tc>
+                <a:tc>
+                  <a:txBody>
+                    <a:bodyPr/>
+                    <a:lstStyle/>
+                    <a:p>
+                      <a:pPr algn="ctr" indent="0" marL="0">
+                        <a:buNone/>
+                      </a:pPr>
+                      <a:r>
+                        <a:rPr lang="en-US" sz="800" b="1" dirty="0">
+                          <a:solidFill>
+                            <a:srgbClr val="1A7A3C"/>
+                          </a:solidFill>
+                          <a:latin typeface="Calibri" pitchFamily="34" charset="0"/>
+                          <a:ea typeface="Calibri" pitchFamily="34" charset="-122"/>
+                          <a:cs typeface="Calibri" pitchFamily="34" charset="-120"/>
+                        </a:rPr>
+                        <a:t>~405 ms/2K</a:t>
+                      </a:r>
+                      <a:endParaRPr lang="en-US" sz="800" dirty="0">
+                        <a:latin typeface="Calibri" charset="0"/>
+                        <a:ea typeface="Calibri" charset="0"/>
+                        <a:cs typeface="Calibri" charset="0"/>
+                      </a:endParaRPr>
+                    </a:p>
+                  </a:txBody>
+                  <a:tcPr marL="91440" marR="91440" marT="45720" marB="45720">
+                    <a:lnL w="6350" cap="flat" cmpd="sng" algn="ctr">
+                      <a:solidFill>
+                        <a:srgbClr val="BFCFE8"/>
+                      </a:solidFill>
+                      <a:prstDash val="solid"/>
+                      <a:round/>
+                      <a:headEnd type="none" w="med" len="med"/>
+                      <a:tailEnd type="none" w="med" len="med"/>
+                    </a:lnL>
+                    <a:lnR w="6350" cap="flat" cmpd="sng" algn="ctr">
+                      <a:solidFill>
+                        <a:srgbClr val="BFCFE8"/>
+                      </a:solidFill>
+                      <a:prstDash val="solid"/>
+                      <a:round/>
+                      <a:headEnd type="none" w="med" len="med"/>
+                      <a:tailEnd type="none" w="med" len="med"/>
+                    </a:lnR>
+                    <a:lnT w="6350" cap="flat" cmpd="sng" algn="ctr">
+                      <a:solidFill>
+                        <a:srgbClr val="BFCFE8"/>
+                      </a:solidFill>
+                      <a:prstDash val="solid"/>
+                      <a:round/>
+                      <a:headEnd type="none" w="med" len="med"/>
+                      <a:tailEnd type="none" w="med" len="med"/>
+                    </a:lnT>
+                    <a:lnB w="6350" cap="flat" cmpd="sng" algn="ctr">
+                      <a:solidFill>
+                        <a:srgbClr val="BFCFE8"/>
+                      </a:solidFill>
+                      <a:prstDash val="solid"/>
+                      <a:round/>
+                      <a:headEnd type="none" w="med" len="med"/>
+                      <a:tailEnd type="none" w="med" len="med"/>
+                    </a:lnB>
+                    <a:solidFill>
+                      <a:srgbClr val="FFFFFF"/>
+                    </a:solidFill>
+                  </a:tcPr>
+                </a:tc>
+                <a:tc>
+                  <a:txBody>
+                    <a:bodyPr/>
+                    <a:lstStyle/>
+                    <a:p>
+                      <a:pPr algn="ctr" indent="0" marL="0">
+                        <a:buNone/>
+                      </a:pPr>
+                      <a:r>
+                        <a:rPr lang="en-US" sz="800" b="1" dirty="0">
+                          <a:solidFill>
+                            <a:srgbClr val="1A7A3C"/>
+                          </a:solidFill>
+                          <a:latin typeface="Calibri" pitchFamily="34" charset="0"/>
+                          <a:ea typeface="Calibri" pitchFamily="34" charset="-122"/>
+                          <a:cs typeface="Calibri" pitchFamily="34" charset="-120"/>
+                        </a:rPr>
+                        <a:t>1.0× (tied)</a:t>
+                      </a:r>
+                      <a:endParaRPr lang="en-US" sz="800" dirty="0">
+                        <a:latin typeface="Calibri" charset="0"/>
+                        <a:ea typeface="Calibri" charset="0"/>
+                        <a:cs typeface="Calibri" charset="0"/>
+                      </a:endParaRPr>
+                    </a:p>
+                  </a:txBody>
+                  <a:tcPr marL="91440" marR="91440" marT="45720" marB="45720">
+                    <a:lnL w="6350" cap="flat" cmpd="sng" algn="ctr">
+                      <a:solidFill>
+                        <a:srgbClr val="BFCFE8"/>
+                      </a:solidFill>
+                      <a:prstDash val="solid"/>
+                      <a:round/>
+                      <a:headEnd type="none" w="med" len="med"/>
+                      <a:tailEnd type="none" w="med" len="med"/>
+                    </a:lnL>
+                    <a:lnR w="6350" cap="flat" cmpd="sng" algn="ctr">
+                      <a:solidFill>
+                        <a:srgbClr val="BFCFE8"/>
+                      </a:solidFill>
+                      <a:prstDash val="solid"/>
+                      <a:round/>
+                      <a:headEnd type="none" w="med" len="med"/>
+                      <a:tailEnd type="none" w="med" len="med"/>
+                    </a:lnR>
+                    <a:lnT w="6350" cap="flat" cmpd="sng" algn="ctr">
+                      <a:solidFill>
+                        <a:srgbClr val="BFCFE8"/>
+                      </a:solidFill>
+                      <a:prstDash val="solid"/>
+                      <a:round/>
+                      <a:headEnd type="none" w="med" len="med"/>
+                      <a:tailEnd type="none" w="med" len="med"/>
+                    </a:lnT>
+                    <a:lnB w="6350" cap="flat" cmpd="sng" algn="ctr">
+                      <a:solidFill>
+                        <a:srgbClr val="BFCFE8"/>
+                      </a:solidFill>
+                      <a:prstDash val="solid"/>
+                      <a:round/>
+                      <a:headEnd type="none" w="med" len="med"/>
+                      <a:tailEnd type="none" w="med" len="med"/>
+                    </a:lnB>
+                    <a:solidFill>
+                      <a:srgbClr val="FFFFFF"/>
+                    </a:solidFill>
+                  </a:tcPr>
+                </a:tc>
+                <a:tc>
+                  <a:txBody>
+                    <a:bodyPr/>
+                    <a:lstStyle/>
+                    <a:p>
+                      <a:pPr algn="l" indent="0" marL="0">
+                        <a:buNone/>
+                      </a:pPr>
+                      <a:r>
+                        <a:rPr lang="en-US" sz="800" dirty="0">
                           <a:solidFill>
                             <a:srgbClr val="555555"/>
                           </a:solidFill>
@@ -11614,9 +13125,9 @@
                           <a:ea typeface="Calibri" pitchFamily="34" charset="-122"/>
                           <a:cs typeface="Calibri" pitchFamily="34" charset="-120"/>
                         </a:rPr>
-                        <a:t>GPU memory ceiling (both) @ 273 GB/s</a:t>
-                      </a:r>
-                      <a:endParaRPr lang="en-US" sz="850" dirty="0">
+                        <a:t>CPU-bound — NVMe upgrade won't shorten prefill latency</a:t>
+                      </a:r>
+                      <a:endParaRPr lang="en-US" sz="800" dirty="0">
                         <a:latin typeface="Calibri" charset="0"/>
                         <a:ea typeface="Calibri" charset="0"/>
                         <a:cs typeface="Calibri" charset="0"/>
@@ -11672,7 +13183,7 @@
       </p:graphicFrame>
       <p:sp>
         <p:nvSpPr>
-          <p:cNvPr id="38" name="Text 30"/>
+          <p:cNvPr id="37" name="Text 29"/>
           <p:cNvSpPr/>
           <p:nvPr/>
         </p:nvSpPr>
@@ -11703,7 +13214,7 @@
                 <a:ea typeface="Calibri" pitchFamily="34" charset="-122"/>
                 <a:cs typeface="Calibri" pitchFamily="34" charset="-120"/>
               </a:rPr>
-              <a:t>* GB10: 273 GB/s GPU mem BW, 123 TOPS FP16. ds4 FlashMoE: 43 layers, 256 experts/layer, 6 active, expert=6.75 MB (Q4), total expert IO/token=258×6.75=1.74 GB. PCIe 5.0 x4: 32GT/s×4×128/130/8=15.75 GB/s; PCIe 6.0 x4: 64GT/s×4/8=32 GB/s. Decode: bottleneck=max(cold_storage_time, GPU_mem_time); PCIe5→GPU-bnd@~67% hit; PCIe6→GPU-bnd@~37%. GPU ceiling: 10.5 GB/273 GB/s=38.5 ms=26 tok/s.</a:t>
+              <a:t>* GB10: 273 GB/s GPU mem BW, 123 TOPS FP16. ds4 FlashMoE: 43 layers, 256 experts/layer, 6 active, expert=6.75 MB (Q4). PCIe 5.0 x4: 15.75 GB/s; PCIe 6.0 x4: 32 GB/s. Prefill TPS ceiling: 123T÷(43×566.2M)=5,052 tok/s; PCIe6 IO→CPU crossover C=275, PCIe5 C=559. TTFT(L)=43×max(IO/layer, L×4.603µs/layer): PCIe5 IO-bnd TTFT=110.5 ms fixed for L&lt;559; PCIe6 IO-bnd TTFT=54.4 ms for L&lt;275. Decode: PCIe5→GPU-bnd@~67% hit; PCIe6→GPU-bnd@~37%; GPU ceil=26 tok/s.</a:t>
             </a:r>
             <a:endParaRPr lang="en-US" sz="650" dirty="0"/>
           </a:p>

</xml_diff>